<commit_message>
chore: team name -> Coba Namanya Ini across deck
</commit_message>
<xml_diff>
--- a/proposal/Proposal_SiKePo_Healthkathon2026.pptx
+++ b/proposal/Proposal_SiKePo_Healthkathon2026.pptx
@@ -2321,7 +2321,7 @@
                 <a:ea typeface="Inter" pitchFamily="34" charset="-122"/>
                 <a:cs typeface="Inter" pitchFamily="34" charset="-120"/>
               </a:rPr>
-              <a:t>Tim KePo</a:t>
+              <a:t>Coba Namanya Ini</a:t>
             </a:r>
             <a:r>
               <a:rPr lang="en-US" sz="1300" dirty="0">
@@ -7385,7 +7385,7 @@
                 <a:ea typeface="Inter" pitchFamily="34" charset="-122"/>
                 <a:cs typeface="Inter" pitchFamily="34" charset="-120"/>
               </a:rPr>
-              <a:t>Tim KePo · Decka Fadhila Tirta
+              <a:t>Coba Namanya Ini · Decka Fadhila Tirta
 </a:t>
             </a:r>
             <a:r>
@@ -8811,7 +8811,7 @@
                 <a:ea typeface="Plus Jakarta Sans" pitchFamily="34" charset="-122"/>
                 <a:cs typeface="Plus Jakarta Sans" pitchFamily="34" charset="-120"/>
               </a:rPr>
-              <a:t>Tim KePo</a:t>
+              <a:t>Coba Namanya Ini</a:t>
             </a:r>
             <a:endParaRPr lang="en-US" sz="2200" dirty="0"/>
           </a:p>
@@ -8853,7 +8853,7 @@
                 <a:ea typeface="Inter" pitchFamily="34" charset="-122"/>
                 <a:cs typeface="Inter" pitchFamily="34" charset="-120"/>
               </a:rPr>
-              <a:t>Kami memang kepo, makanya fraud ketahuan.</a:t>
+              <a:t>Namanya konyol, kerjaannya serius.</a:t>
             </a:r>
             <a:endParaRPr lang="en-US" sz="1200" dirty="0"/>
           </a:p>
@@ -11874,7 +11874,7 @@
       </p:sp>
       <p:pic>
         <p:nvPicPr>
-          <p:cNvPr id="4" name="Image 0" descr="C:/Users/Administrator/Downloads/shot-claims.png">    </p:cNvPr>
+          <p:cNvPr id="4" name="Image 0" descr="D:/FamilyAgent/Nox/workspace/sikepo-app/proposal/assets/shot-claims.png">    </p:cNvPr>
           <p:cNvPicPr>
             <a:picLocks noChangeAspect="1"/>
           </p:cNvPicPr>
@@ -12288,7 +12288,7 @@
       </p:sp>
       <p:pic>
         <p:nvPicPr>
-          <p:cNvPr id="4" name="Image 0" descr="C:/Users/Administrator/Downloads/shot-dashboard.png">    </p:cNvPr>
+          <p:cNvPr id="4" name="Image 0" descr="D:/FamilyAgent/Nox/workspace/sikepo-app/proposal/assets/shot-dashboard.png">    </p:cNvPr>
           <p:cNvPicPr>
             <a:picLocks noChangeAspect="1"/>
           </p:cNvPicPr>
@@ -12392,7 +12392,7 @@
       </p:sp>
       <p:pic>
         <p:nvPicPr>
-          <p:cNvPr id="7" name="Image 1" descr="C:/Users/Administrator/Downloads/shot-sandbox.png">    </p:cNvPr>
+          <p:cNvPr id="7" name="Image 1" descr="D:/FamilyAgent/Nox/workspace/sikepo-app/proposal/assets/shot-sandbox.png">    </p:cNvPr>
           <p:cNvPicPr>
             <a:picLocks noChangeAspect="1"/>
           </p:cNvPicPr>
@@ -12496,7 +12496,7 @@
       </p:sp>
       <p:pic>
         <p:nvPicPr>
-          <p:cNvPr id="10" name="Image 2" descr="C:/Users/Administrator/Downloads/shot-faskes.png">    </p:cNvPr>
+          <p:cNvPr id="10" name="Image 2" descr="D:/FamilyAgent/Nox/workspace/sikepo-app/proposal/assets/shot-faskes.png">    </p:cNvPr>
           <p:cNvPicPr>
             <a:picLocks noChangeAspect="1"/>
           </p:cNvPicPr>

</xml_diff>

<commit_message>
feat: revisi proposal — sub-kategori daftar resmi, foto+domain baru, daftar singkatan, disclaimer demo, LLM diperjelas
</commit_message>
<xml_diff>
--- a/proposal/Proposal_SiKePo_Healthkathon2026.pptx
+++ b/proposal/Proposal_SiKePo_Healthkathon2026.pptx
@@ -19,9 +19,10 @@
     <p:sldId id="267" r:id="rId13"/>
     <p:sldId id="268" r:id="rId14"/>
     <p:sldId id="269" r:id="rId15"/>
+    <p:sldId id="270" r:id="rId16"/>
   </p:sldIdLst>
   <p:notesMasterIdLst>
-    <p:notesMasterId r:id="rId16"/>
+    <p:notesMasterId r:id="rId17"/>
   </p:notesMasterIdLst>
   <p:sldSz cx="12192000" cy="6858000"/>
   <p:notesSz cx="6858000" cy="12192000"/>
@@ -979,6 +980,94 @@
             <a:fld id="{F7021451-1387-4CA6-816F-3879F97B5CBC}" type="slidenum">
               <a:rPr lang="en-US"/>
               <a:t>14</a:t>
+            </a:fld>
+            <a:endParaRPr lang="en-US"/>
+          </a:p>
+        </p:txBody>
+      </p:sp>
+    </p:spTree>
+    <p:extLst>
+      <p:ext uri="{BB962C8B-B14F-4D97-AF65-F5344CB8AC3E}">
+        <p14:creationId xmlns:p14="http://schemas.microsoft.com/office/powerpoint/2010/main" val="1024086991"/>
+      </p:ext>
+    </p:extLst>
+  </p:cSld>
+  <p:clrMapOvr>
+    <a:masterClrMapping/>
+  </p:clrMapOvr>
+</p:notes>
+</file>
+
+<file path=ppt/notesSlides/notesSlide15.xml><?xml version="1.0" encoding="utf-8"?>
+<p:notes xmlns:a="http://schemas.openxmlformats.org/drawingml/2006/main" xmlns:r="http://schemas.openxmlformats.org/officeDocument/2006/relationships" xmlns:p="http://schemas.openxmlformats.org/presentationml/2006/main">
+  <p:cSld>
+    <p:spTree>
+      <p:nvGrpSpPr>
+        <p:cNvPr id="1" name=""/>
+        <p:cNvGrpSpPr/>
+        <p:nvPr/>
+      </p:nvGrpSpPr>
+      <p:grpSpPr>
+        <a:xfrm>
+          <a:off x="0" y="0"/>
+          <a:ext cx="0" cy="0"/>
+          <a:chOff x="0" y="0"/>
+          <a:chExt cx="0" cy="0"/>
+        </a:xfrm>
+      </p:grpSpPr>
+      <p:sp>
+        <p:nvSpPr>
+          <p:cNvPr id="2" name="Slide Image Placeholder 1"/>
+          <p:cNvSpPr>
+            <a:spLocks noGrp="1" noRot="1" noChangeAspect="1"/>
+          </p:cNvSpPr>
+          <p:nvPr>
+            <p:ph type="sldImg"/>
+          </p:nvPr>
+        </p:nvSpPr>
+        <p:spPr/>
+      </p:sp>
+      <p:sp>
+        <p:nvSpPr>
+          <p:cNvPr id="3" name="Notes Placeholder 2"/>
+          <p:cNvSpPr>
+            <a:spLocks noGrp="1"/>
+          </p:cNvSpPr>
+          <p:nvPr>
+            <p:ph type="body" idx="1"/>
+          </p:nvPr>
+        </p:nvSpPr>
+        <p:spPr/>
+        <p:txBody>
+          <a:bodyPr/>
+          <a:lstStyle/>
+          <a:p>
+            <a:r>
+              <a:rPr lang="en-US" dirty="0"/>
+              <a:t/>
+            </a:r>
+            <a:endParaRPr lang="en-US" dirty="0"/>
+          </a:p>
+        </p:txBody>
+      </p:sp>
+      <p:sp>
+        <p:nvSpPr>
+          <p:cNvPr id="4" name="Slide Number Placeholder 3"/>
+          <p:cNvSpPr>
+            <a:spLocks noGrp="1"/>
+          </p:cNvSpPr>
+          <p:nvPr>
+            <p:ph type="sldNum" sz="quarter" idx="10"/>
+          </p:nvPr>
+        </p:nvSpPr>
+        <p:spPr/>
+        <p:txBody>
+          <a:bodyPr/>
+          <a:lstStyle/>
+          <a:p>
+            <a:fld id="{F7021451-1387-4CA6-816F-3879F97B5CBC}" type="slidenum">
+              <a:rPr lang="en-US"/>
+              <a:t>15</a:t>
             </a:fld>
             <a:endParaRPr lang="en-US"/>
           </a:p>
@@ -6543,7 +6632,7 @@
                 <a:ea typeface="Inter" pitchFamily="34" charset="-122"/>
                 <a:cs typeface="Inter" pitchFamily="34" charset="-120"/>
               </a:rPr>
-              <a:t>deckafadhila@gmail.com · decka.xyz</a:t>
+              <a:t>deckafadhila@gmail.com · dktirta.tech</a:t>
             </a:r>
             <a:endParaRPr lang="en-US" sz="1400" dirty="0"/>
           </a:p>
@@ -7115,6 +7204,2453 @@
 <file path=ppt/slides/slide14.xml><?xml version="1.0" encoding="utf-8"?>
 <p:sld xmlns:a="http://schemas.openxmlformats.org/drawingml/2006/main" xmlns:r="http://schemas.openxmlformats.org/officeDocument/2006/relationships" xmlns:p="http://schemas.openxmlformats.org/presentationml/2006/main">
   <p:cSld name="Slide 14">
+    <p:bg>
+      <p:bgPr>
+        <a:solidFill>
+          <a:srgbClr val="FFFFFF"/>
+        </a:solidFill>
+      </p:bgPr>
+    </p:bg>
+    <p:spTree>
+      <p:nvGrpSpPr>
+        <p:cNvPr id="1" name=""/>
+        <p:cNvGrpSpPr/>
+        <p:nvPr/>
+      </p:nvGrpSpPr>
+      <p:grpSpPr>
+        <a:xfrm>
+          <a:off x="0" y="0"/>
+          <a:ext cx="0" cy="0"/>
+          <a:chOff x="0" y="0"/>
+          <a:chExt cx="0" cy="0"/>
+        </a:xfrm>
+      </p:grpSpPr>
+      <p:sp>
+        <p:nvSpPr>
+          <p:cNvPr id="2" name="Text 0"/>
+          <p:cNvSpPr/>
+          <p:nvPr/>
+        </p:nvSpPr>
+        <p:spPr>
+          <a:xfrm>
+            <a:off x="457200" y="384048"/>
+            <a:ext cx="5486400" cy="274320"/>
+          </a:xfrm>
+          <a:prstGeom prst="rect">
+            <a:avLst/>
+          </a:prstGeom>
+          <a:noFill/>
+          <a:ln/>
+        </p:spPr>
+        <p:txBody>
+          <a:bodyPr wrap="square" lIns="0" tIns="0" rIns="0" bIns="0" rtlCol="0" anchor="ctr"/>
+          <a:lstStyle/>
+          <a:p>
+            <a:pPr algn="l" indent="0" marL="0">
+              <a:buNone/>
+            </a:pPr>
+            <a:r>
+              <a:rPr lang="en-US" sz="1100" b="1" spc="300" kern="0" dirty="0">
+                <a:solidFill>
+                  <a:srgbClr val="009B4C"/>
+                </a:solidFill>
+                <a:latin typeface="Plus Jakarta Sans" pitchFamily="34" charset="0"/>
+                <a:ea typeface="Plus Jakarta Sans" pitchFamily="34" charset="-122"/>
+                <a:cs typeface="Plus Jakarta Sans" pitchFamily="34" charset="-120"/>
+              </a:rPr>
+              <a:t>DAFTAR SINGKATAN</a:t>
+            </a:r>
+            <a:endParaRPr lang="en-US" sz="1100" dirty="0"/>
+          </a:p>
+        </p:txBody>
+      </p:sp>
+      <p:sp>
+        <p:nvSpPr>
+          <p:cNvPr id="3" name="Text 1"/>
+          <p:cNvSpPr/>
+          <p:nvPr/>
+        </p:nvSpPr>
+        <p:spPr>
+          <a:xfrm>
+            <a:off x="457200" y="658368"/>
+            <a:ext cx="11274552" cy="685800"/>
+          </a:xfrm>
+          <a:prstGeom prst="rect">
+            <a:avLst/>
+          </a:prstGeom>
+          <a:noFill/>
+          <a:ln/>
+        </p:spPr>
+        <p:txBody>
+          <a:bodyPr wrap="square" lIns="0" tIns="0" rIns="0" bIns="0" rtlCol="0" anchor="ctr"/>
+          <a:lstStyle/>
+          <a:p>
+            <a:pPr algn="l" indent="0" marL="0">
+              <a:buNone/>
+            </a:pPr>
+            <a:r>
+              <a:rPr lang="en-US" sz="3000" b="1" dirty="0">
+                <a:solidFill>
+                  <a:srgbClr val="0B1526"/>
+                </a:solidFill>
+                <a:latin typeface="Plus Jakarta Sans" pitchFamily="34" charset="0"/>
+                <a:ea typeface="Plus Jakarta Sans" pitchFamily="34" charset="-122"/>
+                <a:cs typeface="Plus Jakarta Sans" pitchFamily="34" charset="-120"/>
+              </a:rPr>
+              <a:t>Istilah dan singkatan yang dipakai</a:t>
+            </a:r>
+            <a:endParaRPr lang="en-US" sz="3000" dirty="0"/>
+          </a:p>
+        </p:txBody>
+      </p:sp>
+      <p:graphicFrame>
+        <p:nvGraphicFramePr>
+          <p:cNvPr id="15" name="Table 0"/>
+          <p:cNvGraphicFramePr>
+            <a:graphicFrameLocks noGrp="1"/>
+          </p:cNvGraphicFramePr>
+          <p:nvPr>
+            <p:extLst>
+              <p:ext uri="{D42A27DB-BD31-4B8C-83A1-F6EECF244321}">
+                <p14:modId xmlns:p14="http://schemas.microsoft.com/office/powerpoint/2010/main" val="1579011935"/>
+              </p:ext>
+            </p:extLst>
+          </p:nvPr>
+        </p:nvGraphicFramePr>
+        <p:xfrm>
+          <a:off x="457200" y="1627632"/>
+          <a:ext cx="5394960" cy="914400"/>
+        </p:xfrm>
+        <a:graphic>
+          <a:graphicData uri="http://schemas.openxmlformats.org/drawingml/2006/table">
+            <a:tbl>
+              <a:tblPr/>
+              <a:tblGrid>
+                <a:gridCol w="1234440"/>
+                <a:gridCol w="4160520"/>
+              </a:tblGrid>
+              <a:tr h="457200">
+                <a:tc>
+                  <a:txBody>
+                    <a:bodyPr/>
+                    <a:lstStyle/>
+                    <a:p>
+                      <a:pPr indent="0" marL="0">
+                        <a:buNone/>
+                      </a:pPr>
+                      <a:r>
+                        <a:rPr lang="en-US" sz="1050" b="1" dirty="0">
+                          <a:solidFill>
+                            <a:srgbClr val="0B1526"/>
+                          </a:solidFill>
+                          <a:latin typeface="JetBrains Mono" pitchFamily="34" charset="0"/>
+                          <a:ea typeface="JetBrains Mono" pitchFamily="34" charset="-122"/>
+                          <a:cs typeface="JetBrains Mono" pitchFamily="34" charset="-120"/>
+                        </a:rPr>
+                        <a:t>JKN</a:t>
+                      </a:r>
+                      <a:endParaRPr lang="en-US" sz="1050" dirty="0">
+                        <a:latin typeface="JetBrains Mono" charset="0"/>
+                        <a:ea typeface="JetBrains Mono" charset="0"/>
+                        <a:cs typeface="JetBrains Mono" charset="0"/>
+                      </a:endParaRPr>
+                    </a:p>
+                  </a:txBody>
+                  <a:tcPr marL="73152" marR="73152" marT="73152" marB="73152" anchor="ctr">
+                    <a:lnL w="12700" cap="flat" cmpd="sng" algn="ctr">
+                      <a:solidFill>
+                        <a:srgbClr val="ECEEF2"/>
+                      </a:solidFill>
+                      <a:prstDash val="solid"/>
+                      <a:round/>
+                      <a:headEnd type="none" w="med" len="med"/>
+                      <a:tailEnd type="none" w="med" len="med"/>
+                    </a:lnL>
+                    <a:lnR w="12700" cap="flat" cmpd="sng" algn="ctr">
+                      <a:solidFill>
+                        <a:srgbClr val="ECEEF2"/>
+                      </a:solidFill>
+                      <a:prstDash val="solid"/>
+                      <a:round/>
+                      <a:headEnd type="none" w="med" len="med"/>
+                      <a:tailEnd type="none" w="med" len="med"/>
+                    </a:lnR>
+                    <a:lnT w="12700" cap="flat" cmpd="sng" algn="ctr">
+                      <a:solidFill>
+                        <a:srgbClr val="ECEEF2"/>
+                      </a:solidFill>
+                      <a:prstDash val="solid"/>
+                      <a:round/>
+                      <a:headEnd type="none" w="med" len="med"/>
+                      <a:tailEnd type="none" w="med" len="med"/>
+                    </a:lnT>
+                    <a:lnB w="12700" cap="flat" cmpd="sng" algn="ctr">
+                      <a:solidFill>
+                        <a:srgbClr val="ECEEF2"/>
+                      </a:solidFill>
+                      <a:prstDash val="solid"/>
+                      <a:round/>
+                      <a:headEnd type="none" w="med" len="med"/>
+                      <a:tailEnd type="none" w="med" len="med"/>
+                    </a:lnB>
+                    <a:solidFill>
+                      <a:srgbClr val="F6F8FA"/>
+                    </a:solidFill>
+                  </a:tcPr>
+                </a:tc>
+                <a:tc>
+                  <a:txBody>
+                    <a:bodyPr/>
+                    <a:lstStyle/>
+                    <a:p>
+                      <a:pPr indent="0" marL="0">
+                        <a:buNone/>
+                      </a:pPr>
+                      <a:r>
+                        <a:rPr lang="en-US" sz="1100" dirty="0">
+                          <a:solidFill>
+                            <a:srgbClr val="4A5568"/>
+                          </a:solidFill>
+                          <a:latin typeface="Inter" pitchFamily="34" charset="0"/>
+                          <a:ea typeface="Inter" pitchFamily="34" charset="-122"/>
+                          <a:cs typeface="Inter" pitchFamily="34" charset="-120"/>
+                        </a:rPr>
+                        <a:t>Jaminan Kesehatan Nasional</a:t>
+                      </a:r>
+                      <a:endParaRPr lang="en-US" sz="1100" dirty="0">
+                        <a:latin typeface="Inter" charset="0"/>
+                        <a:ea typeface="Inter" charset="0"/>
+                        <a:cs typeface="Inter" charset="0"/>
+                      </a:endParaRPr>
+                    </a:p>
+                  </a:txBody>
+                  <a:tcPr marL="73152" marR="73152" marT="73152" marB="73152" anchor="ctr">
+                    <a:lnL w="12700" cap="flat" cmpd="sng" algn="ctr">
+                      <a:solidFill>
+                        <a:srgbClr val="ECEEF2"/>
+                      </a:solidFill>
+                      <a:prstDash val="solid"/>
+                      <a:round/>
+                      <a:headEnd type="none" w="med" len="med"/>
+                      <a:tailEnd type="none" w="med" len="med"/>
+                    </a:lnL>
+                    <a:lnR w="12700" cap="flat" cmpd="sng" algn="ctr">
+                      <a:solidFill>
+                        <a:srgbClr val="ECEEF2"/>
+                      </a:solidFill>
+                      <a:prstDash val="solid"/>
+                      <a:round/>
+                      <a:headEnd type="none" w="med" len="med"/>
+                      <a:tailEnd type="none" w="med" len="med"/>
+                    </a:lnR>
+                    <a:lnT w="12700" cap="flat" cmpd="sng" algn="ctr">
+                      <a:solidFill>
+                        <a:srgbClr val="ECEEF2"/>
+                      </a:solidFill>
+                      <a:prstDash val="solid"/>
+                      <a:round/>
+                      <a:headEnd type="none" w="med" len="med"/>
+                      <a:tailEnd type="none" w="med" len="med"/>
+                    </a:lnT>
+                    <a:lnB w="12700" cap="flat" cmpd="sng" algn="ctr">
+                      <a:solidFill>
+                        <a:srgbClr val="ECEEF2"/>
+                      </a:solidFill>
+                      <a:prstDash val="solid"/>
+                      <a:round/>
+                      <a:headEnd type="none" w="med" len="med"/>
+                      <a:tailEnd type="none" w="med" len="med"/>
+                    </a:lnB>
+                  </a:tcPr>
+                </a:tc>
+              </a:tr>
+              <a:tr h="457200">
+                <a:tc>
+                  <a:txBody>
+                    <a:bodyPr/>
+                    <a:lstStyle/>
+                    <a:p>
+                      <a:pPr indent="0" marL="0">
+                        <a:buNone/>
+                      </a:pPr>
+                      <a:r>
+                        <a:rPr lang="en-US" sz="1050" b="1" dirty="0">
+                          <a:solidFill>
+                            <a:srgbClr val="0B1526"/>
+                          </a:solidFill>
+                          <a:latin typeface="JetBrains Mono" pitchFamily="34" charset="0"/>
+                          <a:ea typeface="JetBrains Mono" pitchFamily="34" charset="-122"/>
+                          <a:cs typeface="JetBrains Mono" pitchFamily="34" charset="-120"/>
+                        </a:rPr>
+                        <a:t>BPJS</a:t>
+                      </a:r>
+                      <a:endParaRPr lang="en-US" sz="1050" dirty="0">
+                        <a:latin typeface="JetBrains Mono" charset="0"/>
+                        <a:ea typeface="JetBrains Mono" charset="0"/>
+                        <a:cs typeface="JetBrains Mono" charset="0"/>
+                      </a:endParaRPr>
+                    </a:p>
+                  </a:txBody>
+                  <a:tcPr marL="73152" marR="73152" marT="73152" marB="73152" anchor="ctr">
+                    <a:lnL w="12700" cap="flat" cmpd="sng" algn="ctr">
+                      <a:solidFill>
+                        <a:srgbClr val="ECEEF2"/>
+                      </a:solidFill>
+                      <a:prstDash val="solid"/>
+                      <a:round/>
+                      <a:headEnd type="none" w="med" len="med"/>
+                      <a:tailEnd type="none" w="med" len="med"/>
+                    </a:lnL>
+                    <a:lnR w="12700" cap="flat" cmpd="sng" algn="ctr">
+                      <a:solidFill>
+                        <a:srgbClr val="ECEEF2"/>
+                      </a:solidFill>
+                      <a:prstDash val="solid"/>
+                      <a:round/>
+                      <a:headEnd type="none" w="med" len="med"/>
+                      <a:tailEnd type="none" w="med" len="med"/>
+                    </a:lnR>
+                    <a:lnT w="12700" cap="flat" cmpd="sng" algn="ctr">
+                      <a:solidFill>
+                        <a:srgbClr val="ECEEF2"/>
+                      </a:solidFill>
+                      <a:prstDash val="solid"/>
+                      <a:round/>
+                      <a:headEnd type="none" w="med" len="med"/>
+                      <a:tailEnd type="none" w="med" len="med"/>
+                    </a:lnT>
+                    <a:lnB w="12700" cap="flat" cmpd="sng" algn="ctr">
+                      <a:solidFill>
+                        <a:srgbClr val="ECEEF2"/>
+                      </a:solidFill>
+                      <a:prstDash val="solid"/>
+                      <a:round/>
+                      <a:headEnd type="none" w="med" len="med"/>
+                      <a:tailEnd type="none" w="med" len="med"/>
+                    </a:lnB>
+                    <a:solidFill>
+                      <a:srgbClr val="F6F8FA"/>
+                    </a:solidFill>
+                  </a:tcPr>
+                </a:tc>
+                <a:tc>
+                  <a:txBody>
+                    <a:bodyPr/>
+                    <a:lstStyle/>
+                    <a:p>
+                      <a:pPr indent="0" marL="0">
+                        <a:buNone/>
+                      </a:pPr>
+                      <a:r>
+                        <a:rPr lang="en-US" sz="1100" dirty="0">
+                          <a:solidFill>
+                            <a:srgbClr val="4A5568"/>
+                          </a:solidFill>
+                          <a:latin typeface="Inter" pitchFamily="34" charset="0"/>
+                          <a:ea typeface="Inter" pitchFamily="34" charset="-122"/>
+                          <a:cs typeface="Inter" pitchFamily="34" charset="-120"/>
+                        </a:rPr>
+                        <a:t>Badan Penyelenggara Jaminan Sosial</a:t>
+                      </a:r>
+                      <a:endParaRPr lang="en-US" sz="1100" dirty="0">
+                        <a:latin typeface="Inter" charset="0"/>
+                        <a:ea typeface="Inter" charset="0"/>
+                        <a:cs typeface="Inter" charset="0"/>
+                      </a:endParaRPr>
+                    </a:p>
+                  </a:txBody>
+                  <a:tcPr marL="73152" marR="73152" marT="73152" marB="73152" anchor="ctr">
+                    <a:lnL w="12700" cap="flat" cmpd="sng" algn="ctr">
+                      <a:solidFill>
+                        <a:srgbClr val="ECEEF2"/>
+                      </a:solidFill>
+                      <a:prstDash val="solid"/>
+                      <a:round/>
+                      <a:headEnd type="none" w="med" len="med"/>
+                      <a:tailEnd type="none" w="med" len="med"/>
+                    </a:lnL>
+                    <a:lnR w="12700" cap="flat" cmpd="sng" algn="ctr">
+                      <a:solidFill>
+                        <a:srgbClr val="ECEEF2"/>
+                      </a:solidFill>
+                      <a:prstDash val="solid"/>
+                      <a:round/>
+                      <a:headEnd type="none" w="med" len="med"/>
+                      <a:tailEnd type="none" w="med" len="med"/>
+                    </a:lnR>
+                    <a:lnT w="12700" cap="flat" cmpd="sng" algn="ctr">
+                      <a:solidFill>
+                        <a:srgbClr val="ECEEF2"/>
+                      </a:solidFill>
+                      <a:prstDash val="solid"/>
+                      <a:round/>
+                      <a:headEnd type="none" w="med" len="med"/>
+                      <a:tailEnd type="none" w="med" len="med"/>
+                    </a:lnT>
+                    <a:lnB w="12700" cap="flat" cmpd="sng" algn="ctr">
+                      <a:solidFill>
+                        <a:srgbClr val="ECEEF2"/>
+                      </a:solidFill>
+                      <a:prstDash val="solid"/>
+                      <a:round/>
+                      <a:headEnd type="none" w="med" len="med"/>
+                      <a:tailEnd type="none" w="med" len="med"/>
+                    </a:lnB>
+                  </a:tcPr>
+                </a:tc>
+              </a:tr>
+              <a:tr h="457200">
+                <a:tc>
+                  <a:txBody>
+                    <a:bodyPr/>
+                    <a:lstStyle/>
+                    <a:p>
+                      <a:pPr indent="0" marL="0">
+                        <a:buNone/>
+                      </a:pPr>
+                      <a:r>
+                        <a:rPr lang="en-US" sz="1050" b="1" dirty="0">
+                          <a:solidFill>
+                            <a:srgbClr val="0B1526"/>
+                          </a:solidFill>
+                          <a:latin typeface="JetBrains Mono" pitchFamily="34" charset="0"/>
+                          <a:ea typeface="JetBrains Mono" pitchFamily="34" charset="-122"/>
+                          <a:cs typeface="JetBrains Mono" pitchFamily="34" charset="-120"/>
+                        </a:rPr>
+                        <a:t>INA-CBG</a:t>
+                      </a:r>
+                      <a:endParaRPr lang="en-US" sz="1050" dirty="0">
+                        <a:latin typeface="JetBrains Mono" charset="0"/>
+                        <a:ea typeface="JetBrains Mono" charset="0"/>
+                        <a:cs typeface="JetBrains Mono" charset="0"/>
+                      </a:endParaRPr>
+                    </a:p>
+                  </a:txBody>
+                  <a:tcPr marL="73152" marR="73152" marT="73152" marB="73152" anchor="ctr">
+                    <a:lnL w="12700" cap="flat" cmpd="sng" algn="ctr">
+                      <a:solidFill>
+                        <a:srgbClr val="ECEEF2"/>
+                      </a:solidFill>
+                      <a:prstDash val="solid"/>
+                      <a:round/>
+                      <a:headEnd type="none" w="med" len="med"/>
+                      <a:tailEnd type="none" w="med" len="med"/>
+                    </a:lnL>
+                    <a:lnR w="12700" cap="flat" cmpd="sng" algn="ctr">
+                      <a:solidFill>
+                        <a:srgbClr val="ECEEF2"/>
+                      </a:solidFill>
+                      <a:prstDash val="solid"/>
+                      <a:round/>
+                      <a:headEnd type="none" w="med" len="med"/>
+                      <a:tailEnd type="none" w="med" len="med"/>
+                    </a:lnR>
+                    <a:lnT w="12700" cap="flat" cmpd="sng" algn="ctr">
+                      <a:solidFill>
+                        <a:srgbClr val="ECEEF2"/>
+                      </a:solidFill>
+                      <a:prstDash val="solid"/>
+                      <a:round/>
+                      <a:headEnd type="none" w="med" len="med"/>
+                      <a:tailEnd type="none" w="med" len="med"/>
+                    </a:lnT>
+                    <a:lnB w="12700" cap="flat" cmpd="sng" algn="ctr">
+                      <a:solidFill>
+                        <a:srgbClr val="ECEEF2"/>
+                      </a:solidFill>
+                      <a:prstDash val="solid"/>
+                      <a:round/>
+                      <a:headEnd type="none" w="med" len="med"/>
+                      <a:tailEnd type="none" w="med" len="med"/>
+                    </a:lnB>
+                    <a:solidFill>
+                      <a:srgbClr val="F6F8FA"/>
+                    </a:solidFill>
+                  </a:tcPr>
+                </a:tc>
+                <a:tc>
+                  <a:txBody>
+                    <a:bodyPr/>
+                    <a:lstStyle/>
+                    <a:p>
+                      <a:pPr indent="0" marL="0">
+                        <a:buNone/>
+                      </a:pPr>
+                      <a:r>
+                        <a:rPr lang="en-US" sz="1100" dirty="0">
+                          <a:solidFill>
+                            <a:srgbClr val="4A5568"/>
+                          </a:solidFill>
+                          <a:latin typeface="Inter" pitchFamily="34" charset="0"/>
+                          <a:ea typeface="Inter" pitchFamily="34" charset="-122"/>
+                          <a:cs typeface="Inter" pitchFamily="34" charset="-120"/>
+                        </a:rPr>
+                        <a:t>Indonesian Case Based Groups (tarif paket klaim)</a:t>
+                      </a:r>
+                      <a:endParaRPr lang="en-US" sz="1100" dirty="0">
+                        <a:latin typeface="Inter" charset="0"/>
+                        <a:ea typeface="Inter" charset="0"/>
+                        <a:cs typeface="Inter" charset="0"/>
+                      </a:endParaRPr>
+                    </a:p>
+                  </a:txBody>
+                  <a:tcPr marL="73152" marR="73152" marT="73152" marB="73152" anchor="ctr">
+                    <a:lnL w="12700" cap="flat" cmpd="sng" algn="ctr">
+                      <a:solidFill>
+                        <a:srgbClr val="ECEEF2"/>
+                      </a:solidFill>
+                      <a:prstDash val="solid"/>
+                      <a:round/>
+                      <a:headEnd type="none" w="med" len="med"/>
+                      <a:tailEnd type="none" w="med" len="med"/>
+                    </a:lnL>
+                    <a:lnR w="12700" cap="flat" cmpd="sng" algn="ctr">
+                      <a:solidFill>
+                        <a:srgbClr val="ECEEF2"/>
+                      </a:solidFill>
+                      <a:prstDash val="solid"/>
+                      <a:round/>
+                      <a:headEnd type="none" w="med" len="med"/>
+                      <a:tailEnd type="none" w="med" len="med"/>
+                    </a:lnR>
+                    <a:lnT w="12700" cap="flat" cmpd="sng" algn="ctr">
+                      <a:solidFill>
+                        <a:srgbClr val="ECEEF2"/>
+                      </a:solidFill>
+                      <a:prstDash val="solid"/>
+                      <a:round/>
+                      <a:headEnd type="none" w="med" len="med"/>
+                      <a:tailEnd type="none" w="med" len="med"/>
+                    </a:lnT>
+                    <a:lnB w="12700" cap="flat" cmpd="sng" algn="ctr">
+                      <a:solidFill>
+                        <a:srgbClr val="ECEEF2"/>
+                      </a:solidFill>
+                      <a:prstDash val="solid"/>
+                      <a:round/>
+                      <a:headEnd type="none" w="med" len="med"/>
+                      <a:tailEnd type="none" w="med" len="med"/>
+                    </a:lnB>
+                  </a:tcPr>
+                </a:tc>
+              </a:tr>
+              <a:tr h="457200">
+                <a:tc>
+                  <a:txBody>
+                    <a:bodyPr/>
+                    <a:lstStyle/>
+                    <a:p>
+                      <a:pPr indent="0" marL="0">
+                        <a:buNone/>
+                      </a:pPr>
+                      <a:r>
+                        <a:rPr lang="en-US" sz="1050" b="1" dirty="0">
+                          <a:solidFill>
+                            <a:srgbClr val="0B1526"/>
+                          </a:solidFill>
+                          <a:latin typeface="JetBrains Mono" pitchFamily="34" charset="0"/>
+                          <a:ea typeface="JetBrains Mono" pitchFamily="34" charset="-122"/>
+                          <a:cs typeface="JetBrains Mono" pitchFamily="34" charset="-120"/>
+                        </a:rPr>
+                        <a:t>SEP</a:t>
+                      </a:r>
+                      <a:endParaRPr lang="en-US" sz="1050" dirty="0">
+                        <a:latin typeface="JetBrains Mono" charset="0"/>
+                        <a:ea typeface="JetBrains Mono" charset="0"/>
+                        <a:cs typeface="JetBrains Mono" charset="0"/>
+                      </a:endParaRPr>
+                    </a:p>
+                  </a:txBody>
+                  <a:tcPr marL="73152" marR="73152" marT="73152" marB="73152" anchor="ctr">
+                    <a:lnL w="12700" cap="flat" cmpd="sng" algn="ctr">
+                      <a:solidFill>
+                        <a:srgbClr val="ECEEF2"/>
+                      </a:solidFill>
+                      <a:prstDash val="solid"/>
+                      <a:round/>
+                      <a:headEnd type="none" w="med" len="med"/>
+                      <a:tailEnd type="none" w="med" len="med"/>
+                    </a:lnL>
+                    <a:lnR w="12700" cap="flat" cmpd="sng" algn="ctr">
+                      <a:solidFill>
+                        <a:srgbClr val="ECEEF2"/>
+                      </a:solidFill>
+                      <a:prstDash val="solid"/>
+                      <a:round/>
+                      <a:headEnd type="none" w="med" len="med"/>
+                      <a:tailEnd type="none" w="med" len="med"/>
+                    </a:lnR>
+                    <a:lnT w="12700" cap="flat" cmpd="sng" algn="ctr">
+                      <a:solidFill>
+                        <a:srgbClr val="ECEEF2"/>
+                      </a:solidFill>
+                      <a:prstDash val="solid"/>
+                      <a:round/>
+                      <a:headEnd type="none" w="med" len="med"/>
+                      <a:tailEnd type="none" w="med" len="med"/>
+                    </a:lnT>
+                    <a:lnB w="12700" cap="flat" cmpd="sng" algn="ctr">
+                      <a:solidFill>
+                        <a:srgbClr val="ECEEF2"/>
+                      </a:solidFill>
+                      <a:prstDash val="solid"/>
+                      <a:round/>
+                      <a:headEnd type="none" w="med" len="med"/>
+                      <a:tailEnd type="none" w="med" len="med"/>
+                    </a:lnB>
+                    <a:solidFill>
+                      <a:srgbClr val="F6F8FA"/>
+                    </a:solidFill>
+                  </a:tcPr>
+                </a:tc>
+                <a:tc>
+                  <a:txBody>
+                    <a:bodyPr/>
+                    <a:lstStyle/>
+                    <a:p>
+                      <a:pPr indent="0" marL="0">
+                        <a:buNone/>
+                      </a:pPr>
+                      <a:r>
+                        <a:rPr lang="en-US" sz="1100" dirty="0">
+                          <a:solidFill>
+                            <a:srgbClr val="4A5568"/>
+                          </a:solidFill>
+                          <a:latin typeface="Inter" pitchFamily="34" charset="0"/>
+                          <a:ea typeface="Inter" pitchFamily="34" charset="-122"/>
+                          <a:cs typeface="Inter" pitchFamily="34" charset="-120"/>
+                        </a:rPr>
+                        <a:t>Surat Eligibilitas Peserta</a:t>
+                      </a:r>
+                      <a:endParaRPr lang="en-US" sz="1100" dirty="0">
+                        <a:latin typeface="Inter" charset="0"/>
+                        <a:ea typeface="Inter" charset="0"/>
+                        <a:cs typeface="Inter" charset="0"/>
+                      </a:endParaRPr>
+                    </a:p>
+                  </a:txBody>
+                  <a:tcPr marL="73152" marR="73152" marT="73152" marB="73152" anchor="ctr">
+                    <a:lnL w="12700" cap="flat" cmpd="sng" algn="ctr">
+                      <a:solidFill>
+                        <a:srgbClr val="ECEEF2"/>
+                      </a:solidFill>
+                      <a:prstDash val="solid"/>
+                      <a:round/>
+                      <a:headEnd type="none" w="med" len="med"/>
+                      <a:tailEnd type="none" w="med" len="med"/>
+                    </a:lnL>
+                    <a:lnR w="12700" cap="flat" cmpd="sng" algn="ctr">
+                      <a:solidFill>
+                        <a:srgbClr val="ECEEF2"/>
+                      </a:solidFill>
+                      <a:prstDash val="solid"/>
+                      <a:round/>
+                      <a:headEnd type="none" w="med" len="med"/>
+                      <a:tailEnd type="none" w="med" len="med"/>
+                    </a:lnR>
+                    <a:lnT w="12700" cap="flat" cmpd="sng" algn="ctr">
+                      <a:solidFill>
+                        <a:srgbClr val="ECEEF2"/>
+                      </a:solidFill>
+                      <a:prstDash val="solid"/>
+                      <a:round/>
+                      <a:headEnd type="none" w="med" len="med"/>
+                      <a:tailEnd type="none" w="med" len="med"/>
+                    </a:lnT>
+                    <a:lnB w="12700" cap="flat" cmpd="sng" algn="ctr">
+                      <a:solidFill>
+                        <a:srgbClr val="ECEEF2"/>
+                      </a:solidFill>
+                      <a:prstDash val="solid"/>
+                      <a:round/>
+                      <a:headEnd type="none" w="med" len="med"/>
+                      <a:tailEnd type="none" w="med" len="med"/>
+                    </a:lnB>
+                  </a:tcPr>
+                </a:tc>
+              </a:tr>
+              <a:tr h="457200">
+                <a:tc>
+                  <a:txBody>
+                    <a:bodyPr/>
+                    <a:lstStyle/>
+                    <a:p>
+                      <a:pPr indent="0" marL="0">
+                        <a:buNone/>
+                      </a:pPr>
+                      <a:r>
+                        <a:rPr lang="en-US" sz="1050" b="1" dirty="0">
+                          <a:solidFill>
+                            <a:srgbClr val="0B1526"/>
+                          </a:solidFill>
+                          <a:latin typeface="JetBrains Mono" pitchFamily="34" charset="0"/>
+                          <a:ea typeface="JetBrains Mono" pitchFamily="34" charset="-122"/>
+                          <a:cs typeface="JetBrains Mono" pitchFamily="34" charset="-120"/>
+                        </a:rPr>
+                        <a:t>ICD-10</a:t>
+                      </a:r>
+                      <a:endParaRPr lang="en-US" sz="1050" dirty="0">
+                        <a:latin typeface="JetBrains Mono" charset="0"/>
+                        <a:ea typeface="JetBrains Mono" charset="0"/>
+                        <a:cs typeface="JetBrains Mono" charset="0"/>
+                      </a:endParaRPr>
+                    </a:p>
+                  </a:txBody>
+                  <a:tcPr marL="73152" marR="73152" marT="73152" marB="73152" anchor="ctr">
+                    <a:lnL w="12700" cap="flat" cmpd="sng" algn="ctr">
+                      <a:solidFill>
+                        <a:srgbClr val="ECEEF2"/>
+                      </a:solidFill>
+                      <a:prstDash val="solid"/>
+                      <a:round/>
+                      <a:headEnd type="none" w="med" len="med"/>
+                      <a:tailEnd type="none" w="med" len="med"/>
+                    </a:lnL>
+                    <a:lnR w="12700" cap="flat" cmpd="sng" algn="ctr">
+                      <a:solidFill>
+                        <a:srgbClr val="ECEEF2"/>
+                      </a:solidFill>
+                      <a:prstDash val="solid"/>
+                      <a:round/>
+                      <a:headEnd type="none" w="med" len="med"/>
+                      <a:tailEnd type="none" w="med" len="med"/>
+                    </a:lnR>
+                    <a:lnT w="12700" cap="flat" cmpd="sng" algn="ctr">
+                      <a:solidFill>
+                        <a:srgbClr val="ECEEF2"/>
+                      </a:solidFill>
+                      <a:prstDash val="solid"/>
+                      <a:round/>
+                      <a:headEnd type="none" w="med" len="med"/>
+                      <a:tailEnd type="none" w="med" len="med"/>
+                    </a:lnT>
+                    <a:lnB w="12700" cap="flat" cmpd="sng" algn="ctr">
+                      <a:solidFill>
+                        <a:srgbClr val="ECEEF2"/>
+                      </a:solidFill>
+                      <a:prstDash val="solid"/>
+                      <a:round/>
+                      <a:headEnd type="none" w="med" len="med"/>
+                      <a:tailEnd type="none" w="med" len="med"/>
+                    </a:lnB>
+                    <a:solidFill>
+                      <a:srgbClr val="F6F8FA"/>
+                    </a:solidFill>
+                  </a:tcPr>
+                </a:tc>
+                <a:tc>
+                  <a:txBody>
+                    <a:bodyPr/>
+                    <a:lstStyle/>
+                    <a:p>
+                      <a:pPr indent="0" marL="0">
+                        <a:buNone/>
+                      </a:pPr>
+                      <a:r>
+                        <a:rPr lang="en-US" sz="1100" dirty="0">
+                          <a:solidFill>
+                            <a:srgbClr val="4A5568"/>
+                          </a:solidFill>
+                          <a:latin typeface="Inter" pitchFamily="34" charset="0"/>
+                          <a:ea typeface="Inter" pitchFamily="34" charset="-122"/>
+                          <a:cs typeface="Inter" pitchFamily="34" charset="-120"/>
+                        </a:rPr>
+                        <a:t>Klasifikasi Penyakit Internasional edisi 10</a:t>
+                      </a:r>
+                      <a:endParaRPr lang="en-US" sz="1100" dirty="0">
+                        <a:latin typeface="Inter" charset="0"/>
+                        <a:ea typeface="Inter" charset="0"/>
+                        <a:cs typeface="Inter" charset="0"/>
+                      </a:endParaRPr>
+                    </a:p>
+                  </a:txBody>
+                  <a:tcPr marL="73152" marR="73152" marT="73152" marB="73152" anchor="ctr">
+                    <a:lnL w="12700" cap="flat" cmpd="sng" algn="ctr">
+                      <a:solidFill>
+                        <a:srgbClr val="ECEEF2"/>
+                      </a:solidFill>
+                      <a:prstDash val="solid"/>
+                      <a:round/>
+                      <a:headEnd type="none" w="med" len="med"/>
+                      <a:tailEnd type="none" w="med" len="med"/>
+                    </a:lnL>
+                    <a:lnR w="12700" cap="flat" cmpd="sng" algn="ctr">
+                      <a:solidFill>
+                        <a:srgbClr val="ECEEF2"/>
+                      </a:solidFill>
+                      <a:prstDash val="solid"/>
+                      <a:round/>
+                      <a:headEnd type="none" w="med" len="med"/>
+                      <a:tailEnd type="none" w="med" len="med"/>
+                    </a:lnR>
+                    <a:lnT w="12700" cap="flat" cmpd="sng" algn="ctr">
+                      <a:solidFill>
+                        <a:srgbClr val="ECEEF2"/>
+                      </a:solidFill>
+                      <a:prstDash val="solid"/>
+                      <a:round/>
+                      <a:headEnd type="none" w="med" len="med"/>
+                      <a:tailEnd type="none" w="med" len="med"/>
+                    </a:lnT>
+                    <a:lnB w="12700" cap="flat" cmpd="sng" algn="ctr">
+                      <a:solidFill>
+                        <a:srgbClr val="ECEEF2"/>
+                      </a:solidFill>
+                      <a:prstDash val="solid"/>
+                      <a:round/>
+                      <a:headEnd type="none" w="med" len="med"/>
+                      <a:tailEnd type="none" w="med" len="med"/>
+                    </a:lnB>
+                  </a:tcPr>
+                </a:tc>
+              </a:tr>
+              <a:tr h="457200">
+                <a:tc>
+                  <a:txBody>
+                    <a:bodyPr/>
+                    <a:lstStyle/>
+                    <a:p>
+                      <a:pPr indent="0" marL="0">
+                        <a:buNone/>
+                      </a:pPr>
+                      <a:r>
+                        <a:rPr lang="en-US" sz="1050" b="1" dirty="0">
+                          <a:solidFill>
+                            <a:srgbClr val="0B1526"/>
+                          </a:solidFill>
+                          <a:latin typeface="JetBrains Mono" pitchFamily="34" charset="0"/>
+                          <a:ea typeface="JetBrains Mono" pitchFamily="34" charset="-122"/>
+                          <a:cs typeface="JetBrains Mono" pitchFamily="34" charset="-120"/>
+                        </a:rPr>
+                        <a:t>LOS</a:t>
+                      </a:r>
+                      <a:endParaRPr lang="en-US" sz="1050" dirty="0">
+                        <a:latin typeface="JetBrains Mono" charset="0"/>
+                        <a:ea typeface="JetBrains Mono" charset="0"/>
+                        <a:cs typeface="JetBrains Mono" charset="0"/>
+                      </a:endParaRPr>
+                    </a:p>
+                  </a:txBody>
+                  <a:tcPr marL="73152" marR="73152" marT="73152" marB="73152" anchor="ctr">
+                    <a:lnL w="12700" cap="flat" cmpd="sng" algn="ctr">
+                      <a:solidFill>
+                        <a:srgbClr val="ECEEF2"/>
+                      </a:solidFill>
+                      <a:prstDash val="solid"/>
+                      <a:round/>
+                      <a:headEnd type="none" w="med" len="med"/>
+                      <a:tailEnd type="none" w="med" len="med"/>
+                    </a:lnL>
+                    <a:lnR w="12700" cap="flat" cmpd="sng" algn="ctr">
+                      <a:solidFill>
+                        <a:srgbClr val="ECEEF2"/>
+                      </a:solidFill>
+                      <a:prstDash val="solid"/>
+                      <a:round/>
+                      <a:headEnd type="none" w="med" len="med"/>
+                      <a:tailEnd type="none" w="med" len="med"/>
+                    </a:lnR>
+                    <a:lnT w="12700" cap="flat" cmpd="sng" algn="ctr">
+                      <a:solidFill>
+                        <a:srgbClr val="ECEEF2"/>
+                      </a:solidFill>
+                      <a:prstDash val="solid"/>
+                      <a:round/>
+                      <a:headEnd type="none" w="med" len="med"/>
+                      <a:tailEnd type="none" w="med" len="med"/>
+                    </a:lnT>
+                    <a:lnB w="12700" cap="flat" cmpd="sng" algn="ctr">
+                      <a:solidFill>
+                        <a:srgbClr val="ECEEF2"/>
+                      </a:solidFill>
+                      <a:prstDash val="solid"/>
+                      <a:round/>
+                      <a:headEnd type="none" w="med" len="med"/>
+                      <a:tailEnd type="none" w="med" len="med"/>
+                    </a:lnB>
+                    <a:solidFill>
+                      <a:srgbClr val="F6F8FA"/>
+                    </a:solidFill>
+                  </a:tcPr>
+                </a:tc>
+                <a:tc>
+                  <a:txBody>
+                    <a:bodyPr/>
+                    <a:lstStyle/>
+                    <a:p>
+                      <a:pPr indent="0" marL="0">
+                        <a:buNone/>
+                      </a:pPr>
+                      <a:r>
+                        <a:rPr lang="en-US" sz="1100" dirty="0">
+                          <a:solidFill>
+                            <a:srgbClr val="4A5568"/>
+                          </a:solidFill>
+                          <a:latin typeface="Inter" pitchFamily="34" charset="0"/>
+                          <a:ea typeface="Inter" pitchFamily="34" charset="-122"/>
+                          <a:cs typeface="Inter" pitchFamily="34" charset="-120"/>
+                        </a:rPr>
+                        <a:t>Length of Stay (lama rawat)</a:t>
+                      </a:r>
+                      <a:endParaRPr lang="en-US" sz="1100" dirty="0">
+                        <a:latin typeface="Inter" charset="0"/>
+                        <a:ea typeface="Inter" charset="0"/>
+                        <a:cs typeface="Inter" charset="0"/>
+                      </a:endParaRPr>
+                    </a:p>
+                  </a:txBody>
+                  <a:tcPr marL="73152" marR="73152" marT="73152" marB="73152" anchor="ctr">
+                    <a:lnL w="12700" cap="flat" cmpd="sng" algn="ctr">
+                      <a:solidFill>
+                        <a:srgbClr val="ECEEF2"/>
+                      </a:solidFill>
+                      <a:prstDash val="solid"/>
+                      <a:round/>
+                      <a:headEnd type="none" w="med" len="med"/>
+                      <a:tailEnd type="none" w="med" len="med"/>
+                    </a:lnL>
+                    <a:lnR w="12700" cap="flat" cmpd="sng" algn="ctr">
+                      <a:solidFill>
+                        <a:srgbClr val="ECEEF2"/>
+                      </a:solidFill>
+                      <a:prstDash val="solid"/>
+                      <a:round/>
+                      <a:headEnd type="none" w="med" len="med"/>
+                      <a:tailEnd type="none" w="med" len="med"/>
+                    </a:lnR>
+                    <a:lnT w="12700" cap="flat" cmpd="sng" algn="ctr">
+                      <a:solidFill>
+                        <a:srgbClr val="ECEEF2"/>
+                      </a:solidFill>
+                      <a:prstDash val="solid"/>
+                      <a:round/>
+                      <a:headEnd type="none" w="med" len="med"/>
+                      <a:tailEnd type="none" w="med" len="med"/>
+                    </a:lnT>
+                    <a:lnB w="12700" cap="flat" cmpd="sng" algn="ctr">
+                      <a:solidFill>
+                        <a:srgbClr val="ECEEF2"/>
+                      </a:solidFill>
+                      <a:prstDash val="solid"/>
+                      <a:round/>
+                      <a:headEnd type="none" w="med" len="med"/>
+                      <a:tailEnd type="none" w="med" len="med"/>
+                    </a:lnB>
+                  </a:tcPr>
+                </a:tc>
+              </a:tr>
+              <a:tr h="457200">
+                <a:tc>
+                  <a:txBody>
+                    <a:bodyPr/>
+                    <a:lstStyle/>
+                    <a:p>
+                      <a:pPr indent="0" marL="0">
+                        <a:buNone/>
+                      </a:pPr>
+                      <a:r>
+                        <a:rPr lang="en-US" sz="1050" b="1" dirty="0">
+                          <a:solidFill>
+                            <a:srgbClr val="0B1526"/>
+                          </a:solidFill>
+                          <a:latin typeface="JetBrains Mono" pitchFamily="34" charset="0"/>
+                          <a:ea typeface="JetBrains Mono" pitchFamily="34" charset="-122"/>
+                          <a:cs typeface="JetBrains Mono" pitchFamily="34" charset="-120"/>
+                        </a:rPr>
+                        <a:t>e-Fornas</a:t>
+                      </a:r>
+                      <a:endParaRPr lang="en-US" sz="1050" dirty="0">
+                        <a:latin typeface="JetBrains Mono" charset="0"/>
+                        <a:ea typeface="JetBrains Mono" charset="0"/>
+                        <a:cs typeface="JetBrains Mono" charset="0"/>
+                      </a:endParaRPr>
+                    </a:p>
+                  </a:txBody>
+                  <a:tcPr marL="73152" marR="73152" marT="73152" marB="73152" anchor="ctr">
+                    <a:lnL w="12700" cap="flat" cmpd="sng" algn="ctr">
+                      <a:solidFill>
+                        <a:srgbClr val="ECEEF2"/>
+                      </a:solidFill>
+                      <a:prstDash val="solid"/>
+                      <a:round/>
+                      <a:headEnd type="none" w="med" len="med"/>
+                      <a:tailEnd type="none" w="med" len="med"/>
+                    </a:lnL>
+                    <a:lnR w="12700" cap="flat" cmpd="sng" algn="ctr">
+                      <a:solidFill>
+                        <a:srgbClr val="ECEEF2"/>
+                      </a:solidFill>
+                      <a:prstDash val="solid"/>
+                      <a:round/>
+                      <a:headEnd type="none" w="med" len="med"/>
+                      <a:tailEnd type="none" w="med" len="med"/>
+                    </a:lnR>
+                    <a:lnT w="12700" cap="flat" cmpd="sng" algn="ctr">
+                      <a:solidFill>
+                        <a:srgbClr val="ECEEF2"/>
+                      </a:solidFill>
+                      <a:prstDash val="solid"/>
+                      <a:round/>
+                      <a:headEnd type="none" w="med" len="med"/>
+                      <a:tailEnd type="none" w="med" len="med"/>
+                    </a:lnT>
+                    <a:lnB w="12700" cap="flat" cmpd="sng" algn="ctr">
+                      <a:solidFill>
+                        <a:srgbClr val="ECEEF2"/>
+                      </a:solidFill>
+                      <a:prstDash val="solid"/>
+                      <a:round/>
+                      <a:headEnd type="none" w="med" len="med"/>
+                      <a:tailEnd type="none" w="med" len="med"/>
+                    </a:lnB>
+                    <a:solidFill>
+                      <a:srgbClr val="F6F8FA"/>
+                    </a:solidFill>
+                  </a:tcPr>
+                </a:tc>
+                <a:tc>
+                  <a:txBody>
+                    <a:bodyPr/>
+                    <a:lstStyle/>
+                    <a:p>
+                      <a:pPr indent="0" marL="0">
+                        <a:buNone/>
+                      </a:pPr>
+                      <a:r>
+                        <a:rPr lang="en-US" sz="1100" dirty="0">
+                          <a:solidFill>
+                            <a:srgbClr val="4A5568"/>
+                          </a:solidFill>
+                          <a:latin typeface="Inter" pitchFamily="34" charset="0"/>
+                          <a:ea typeface="Inter" pitchFamily="34" charset="-122"/>
+                          <a:cs typeface="Inter" pitchFamily="34" charset="-120"/>
+                        </a:rPr>
+                        <a:t>Formularium Nasional elektronik</a:t>
+                      </a:r>
+                      <a:endParaRPr lang="en-US" sz="1100" dirty="0">
+                        <a:latin typeface="Inter" charset="0"/>
+                        <a:ea typeface="Inter" charset="0"/>
+                        <a:cs typeface="Inter" charset="0"/>
+                      </a:endParaRPr>
+                    </a:p>
+                  </a:txBody>
+                  <a:tcPr marL="73152" marR="73152" marT="73152" marB="73152" anchor="ctr">
+                    <a:lnL w="12700" cap="flat" cmpd="sng" algn="ctr">
+                      <a:solidFill>
+                        <a:srgbClr val="ECEEF2"/>
+                      </a:solidFill>
+                      <a:prstDash val="solid"/>
+                      <a:round/>
+                      <a:headEnd type="none" w="med" len="med"/>
+                      <a:tailEnd type="none" w="med" len="med"/>
+                    </a:lnL>
+                    <a:lnR w="12700" cap="flat" cmpd="sng" algn="ctr">
+                      <a:solidFill>
+                        <a:srgbClr val="ECEEF2"/>
+                      </a:solidFill>
+                      <a:prstDash val="solid"/>
+                      <a:round/>
+                      <a:headEnd type="none" w="med" len="med"/>
+                      <a:tailEnd type="none" w="med" len="med"/>
+                    </a:lnR>
+                    <a:lnT w="12700" cap="flat" cmpd="sng" algn="ctr">
+                      <a:solidFill>
+                        <a:srgbClr val="ECEEF2"/>
+                      </a:solidFill>
+                      <a:prstDash val="solid"/>
+                      <a:round/>
+                      <a:headEnd type="none" w="med" len="med"/>
+                      <a:tailEnd type="none" w="med" len="med"/>
+                    </a:lnT>
+                    <a:lnB w="12700" cap="flat" cmpd="sng" algn="ctr">
+                      <a:solidFill>
+                        <a:srgbClr val="ECEEF2"/>
+                      </a:solidFill>
+                      <a:prstDash val="solid"/>
+                      <a:round/>
+                      <a:headEnd type="none" w="med" len="med"/>
+                      <a:tailEnd type="none" w="med" len="med"/>
+                    </a:lnB>
+                  </a:tcPr>
+                </a:tc>
+              </a:tr>
+              <a:tr h="457200">
+                <a:tc>
+                  <a:txBody>
+                    <a:bodyPr/>
+                    <a:lstStyle/>
+                    <a:p>
+                      <a:pPr indent="0" marL="0">
+                        <a:buNone/>
+                      </a:pPr>
+                      <a:r>
+                        <a:rPr lang="en-US" sz="1050" b="1" dirty="0">
+                          <a:solidFill>
+                            <a:srgbClr val="0B1526"/>
+                          </a:solidFill>
+                          <a:latin typeface="JetBrains Mono" pitchFamily="34" charset="0"/>
+                          <a:ea typeface="JetBrains Mono" pitchFamily="34" charset="-122"/>
+                          <a:cs typeface="JetBrains Mono" pitchFamily="34" charset="-120"/>
+                        </a:rPr>
+                        <a:t>FKRTL</a:t>
+                      </a:r>
+                      <a:endParaRPr lang="en-US" sz="1050" dirty="0">
+                        <a:latin typeface="JetBrains Mono" charset="0"/>
+                        <a:ea typeface="JetBrains Mono" charset="0"/>
+                        <a:cs typeface="JetBrains Mono" charset="0"/>
+                      </a:endParaRPr>
+                    </a:p>
+                  </a:txBody>
+                  <a:tcPr marL="73152" marR="73152" marT="73152" marB="73152" anchor="ctr">
+                    <a:lnL w="12700" cap="flat" cmpd="sng" algn="ctr">
+                      <a:solidFill>
+                        <a:srgbClr val="ECEEF2"/>
+                      </a:solidFill>
+                      <a:prstDash val="solid"/>
+                      <a:round/>
+                      <a:headEnd type="none" w="med" len="med"/>
+                      <a:tailEnd type="none" w="med" len="med"/>
+                    </a:lnL>
+                    <a:lnR w="12700" cap="flat" cmpd="sng" algn="ctr">
+                      <a:solidFill>
+                        <a:srgbClr val="ECEEF2"/>
+                      </a:solidFill>
+                      <a:prstDash val="solid"/>
+                      <a:round/>
+                      <a:headEnd type="none" w="med" len="med"/>
+                      <a:tailEnd type="none" w="med" len="med"/>
+                    </a:lnR>
+                    <a:lnT w="12700" cap="flat" cmpd="sng" algn="ctr">
+                      <a:solidFill>
+                        <a:srgbClr val="ECEEF2"/>
+                      </a:solidFill>
+                      <a:prstDash val="solid"/>
+                      <a:round/>
+                      <a:headEnd type="none" w="med" len="med"/>
+                      <a:tailEnd type="none" w="med" len="med"/>
+                    </a:lnT>
+                    <a:lnB w="12700" cap="flat" cmpd="sng" algn="ctr">
+                      <a:solidFill>
+                        <a:srgbClr val="ECEEF2"/>
+                      </a:solidFill>
+                      <a:prstDash val="solid"/>
+                      <a:round/>
+                      <a:headEnd type="none" w="med" len="med"/>
+                      <a:tailEnd type="none" w="med" len="med"/>
+                    </a:lnB>
+                    <a:solidFill>
+                      <a:srgbClr val="F6F8FA"/>
+                    </a:solidFill>
+                  </a:tcPr>
+                </a:tc>
+                <a:tc>
+                  <a:txBody>
+                    <a:bodyPr/>
+                    <a:lstStyle/>
+                    <a:p>
+                      <a:pPr indent="0" marL="0">
+                        <a:buNone/>
+                      </a:pPr>
+                      <a:r>
+                        <a:rPr lang="en-US" sz="1100" dirty="0">
+                          <a:solidFill>
+                            <a:srgbClr val="4A5568"/>
+                          </a:solidFill>
+                          <a:latin typeface="Inter" pitchFamily="34" charset="0"/>
+                          <a:ea typeface="Inter" pitchFamily="34" charset="-122"/>
+                          <a:cs typeface="Inter" pitchFamily="34" charset="-120"/>
+                        </a:rPr>
+                        <a:t>Fasilitas Kesehatan Rujukan Tingkat Lanjut</a:t>
+                      </a:r>
+                      <a:endParaRPr lang="en-US" sz="1100" dirty="0">
+                        <a:latin typeface="Inter" charset="0"/>
+                        <a:ea typeface="Inter" charset="0"/>
+                        <a:cs typeface="Inter" charset="0"/>
+                      </a:endParaRPr>
+                    </a:p>
+                  </a:txBody>
+                  <a:tcPr marL="73152" marR="73152" marT="73152" marB="73152" anchor="ctr">
+                    <a:lnL w="12700" cap="flat" cmpd="sng" algn="ctr">
+                      <a:solidFill>
+                        <a:srgbClr val="ECEEF2"/>
+                      </a:solidFill>
+                      <a:prstDash val="solid"/>
+                      <a:round/>
+                      <a:headEnd type="none" w="med" len="med"/>
+                      <a:tailEnd type="none" w="med" len="med"/>
+                    </a:lnL>
+                    <a:lnR w="12700" cap="flat" cmpd="sng" algn="ctr">
+                      <a:solidFill>
+                        <a:srgbClr val="ECEEF2"/>
+                      </a:solidFill>
+                      <a:prstDash val="solid"/>
+                      <a:round/>
+                      <a:headEnd type="none" w="med" len="med"/>
+                      <a:tailEnd type="none" w="med" len="med"/>
+                    </a:lnR>
+                    <a:lnT w="12700" cap="flat" cmpd="sng" algn="ctr">
+                      <a:solidFill>
+                        <a:srgbClr val="ECEEF2"/>
+                      </a:solidFill>
+                      <a:prstDash val="solid"/>
+                      <a:round/>
+                      <a:headEnd type="none" w="med" len="med"/>
+                      <a:tailEnd type="none" w="med" len="med"/>
+                    </a:lnT>
+                    <a:lnB w="12700" cap="flat" cmpd="sng" algn="ctr">
+                      <a:solidFill>
+                        <a:srgbClr val="ECEEF2"/>
+                      </a:solidFill>
+                      <a:prstDash val="solid"/>
+                      <a:round/>
+                      <a:headEnd type="none" w="med" len="med"/>
+                      <a:tailEnd type="none" w="med" len="med"/>
+                    </a:lnB>
+                  </a:tcPr>
+                </a:tc>
+              </a:tr>
+            </a:tbl>
+          </a:graphicData>
+        </a:graphic>
+      </p:graphicFrame>
+      <p:graphicFrame>
+        <p:nvGraphicFramePr>
+          <p:cNvPr id="29" name="Table 1"/>
+          <p:cNvGraphicFramePr>
+            <a:graphicFrameLocks noGrp="1"/>
+          </p:cNvGraphicFramePr>
+          <p:nvPr>
+            <p:extLst>
+              <p:ext uri="{D42A27DB-BD31-4B8C-83A1-F6EECF244321}">
+                <p14:modId xmlns:p14="http://schemas.microsoft.com/office/powerpoint/2010/main" val="1579011935"/>
+              </p:ext>
+            </p:extLst>
+          </p:nvPr>
+        </p:nvGraphicFramePr>
+        <p:xfrm>
+          <a:off x="6245352" y="1627632"/>
+          <a:ext cx="5394960" cy="914400"/>
+        </p:xfrm>
+        <a:graphic>
+          <a:graphicData uri="http://schemas.openxmlformats.org/drawingml/2006/table">
+            <a:tbl>
+              <a:tblPr/>
+              <a:tblGrid>
+                <a:gridCol w="1234440"/>
+                <a:gridCol w="4160520"/>
+              </a:tblGrid>
+              <a:tr h="457200">
+                <a:tc>
+                  <a:txBody>
+                    <a:bodyPr/>
+                    <a:lstStyle/>
+                    <a:p>
+                      <a:pPr indent="0" marL="0">
+                        <a:buNone/>
+                      </a:pPr>
+                      <a:r>
+                        <a:rPr lang="en-US" sz="1050" b="1" dirty="0">
+                          <a:solidFill>
+                            <a:srgbClr val="0B1526"/>
+                          </a:solidFill>
+                          <a:latin typeface="JetBrains Mono" pitchFamily="34" charset="0"/>
+                          <a:ea typeface="JetBrains Mono" pitchFamily="34" charset="-122"/>
+                          <a:cs typeface="JetBrains Mono" pitchFamily="34" charset="-120"/>
+                        </a:rPr>
+                        <a:t>FKTP</a:t>
+                      </a:r>
+                      <a:endParaRPr lang="en-US" sz="1050" dirty="0">
+                        <a:latin typeface="JetBrains Mono" charset="0"/>
+                        <a:ea typeface="JetBrains Mono" charset="0"/>
+                        <a:cs typeface="JetBrains Mono" charset="0"/>
+                      </a:endParaRPr>
+                    </a:p>
+                  </a:txBody>
+                  <a:tcPr marL="73152" marR="73152" marT="73152" marB="73152" anchor="ctr">
+                    <a:lnL w="12700" cap="flat" cmpd="sng" algn="ctr">
+                      <a:solidFill>
+                        <a:srgbClr val="ECEEF2"/>
+                      </a:solidFill>
+                      <a:prstDash val="solid"/>
+                      <a:round/>
+                      <a:headEnd type="none" w="med" len="med"/>
+                      <a:tailEnd type="none" w="med" len="med"/>
+                    </a:lnL>
+                    <a:lnR w="12700" cap="flat" cmpd="sng" algn="ctr">
+                      <a:solidFill>
+                        <a:srgbClr val="ECEEF2"/>
+                      </a:solidFill>
+                      <a:prstDash val="solid"/>
+                      <a:round/>
+                      <a:headEnd type="none" w="med" len="med"/>
+                      <a:tailEnd type="none" w="med" len="med"/>
+                    </a:lnR>
+                    <a:lnT w="12700" cap="flat" cmpd="sng" algn="ctr">
+                      <a:solidFill>
+                        <a:srgbClr val="ECEEF2"/>
+                      </a:solidFill>
+                      <a:prstDash val="solid"/>
+                      <a:round/>
+                      <a:headEnd type="none" w="med" len="med"/>
+                      <a:tailEnd type="none" w="med" len="med"/>
+                    </a:lnT>
+                    <a:lnB w="12700" cap="flat" cmpd="sng" algn="ctr">
+                      <a:solidFill>
+                        <a:srgbClr val="ECEEF2"/>
+                      </a:solidFill>
+                      <a:prstDash val="solid"/>
+                      <a:round/>
+                      <a:headEnd type="none" w="med" len="med"/>
+                      <a:tailEnd type="none" w="med" len="med"/>
+                    </a:lnB>
+                    <a:solidFill>
+                      <a:srgbClr val="F6F8FA"/>
+                    </a:solidFill>
+                  </a:tcPr>
+                </a:tc>
+                <a:tc>
+                  <a:txBody>
+                    <a:bodyPr/>
+                    <a:lstStyle/>
+                    <a:p>
+                      <a:pPr indent="0" marL="0">
+                        <a:buNone/>
+                      </a:pPr>
+                      <a:r>
+                        <a:rPr lang="en-US" sz="1100" dirty="0">
+                          <a:solidFill>
+                            <a:srgbClr val="4A5568"/>
+                          </a:solidFill>
+                          <a:latin typeface="Inter" pitchFamily="34" charset="0"/>
+                          <a:ea typeface="Inter" pitchFamily="34" charset="-122"/>
+                          <a:cs typeface="Inter" pitchFamily="34" charset="-120"/>
+                        </a:rPr>
+                        <a:t>Fasilitas Kesehatan Tingkat Pertama</a:t>
+                      </a:r>
+                      <a:endParaRPr lang="en-US" sz="1100" dirty="0">
+                        <a:latin typeface="Inter" charset="0"/>
+                        <a:ea typeface="Inter" charset="0"/>
+                        <a:cs typeface="Inter" charset="0"/>
+                      </a:endParaRPr>
+                    </a:p>
+                  </a:txBody>
+                  <a:tcPr marL="73152" marR="73152" marT="73152" marB="73152" anchor="ctr">
+                    <a:lnL w="12700" cap="flat" cmpd="sng" algn="ctr">
+                      <a:solidFill>
+                        <a:srgbClr val="ECEEF2"/>
+                      </a:solidFill>
+                      <a:prstDash val="solid"/>
+                      <a:round/>
+                      <a:headEnd type="none" w="med" len="med"/>
+                      <a:tailEnd type="none" w="med" len="med"/>
+                    </a:lnL>
+                    <a:lnR w="12700" cap="flat" cmpd="sng" algn="ctr">
+                      <a:solidFill>
+                        <a:srgbClr val="ECEEF2"/>
+                      </a:solidFill>
+                      <a:prstDash val="solid"/>
+                      <a:round/>
+                      <a:headEnd type="none" w="med" len="med"/>
+                      <a:tailEnd type="none" w="med" len="med"/>
+                    </a:lnR>
+                    <a:lnT w="12700" cap="flat" cmpd="sng" algn="ctr">
+                      <a:solidFill>
+                        <a:srgbClr val="ECEEF2"/>
+                      </a:solidFill>
+                      <a:prstDash val="solid"/>
+                      <a:round/>
+                      <a:headEnd type="none" w="med" len="med"/>
+                      <a:tailEnd type="none" w="med" len="med"/>
+                    </a:lnT>
+                    <a:lnB w="12700" cap="flat" cmpd="sng" algn="ctr">
+                      <a:solidFill>
+                        <a:srgbClr val="ECEEF2"/>
+                      </a:solidFill>
+                      <a:prstDash val="solid"/>
+                      <a:round/>
+                      <a:headEnd type="none" w="med" len="med"/>
+                      <a:tailEnd type="none" w="med" len="med"/>
+                    </a:lnB>
+                  </a:tcPr>
+                </a:tc>
+              </a:tr>
+              <a:tr h="457200">
+                <a:tc>
+                  <a:txBody>
+                    <a:bodyPr/>
+                    <a:lstStyle/>
+                    <a:p>
+                      <a:pPr indent="0" marL="0">
+                        <a:buNone/>
+                      </a:pPr>
+                      <a:r>
+                        <a:rPr lang="en-US" sz="1050" b="1" dirty="0">
+                          <a:solidFill>
+                            <a:srgbClr val="0B1526"/>
+                          </a:solidFill>
+                          <a:latin typeface="JetBrains Mono" pitchFamily="34" charset="0"/>
+                          <a:ea typeface="JetBrains Mono" pitchFamily="34" charset="-122"/>
+                          <a:cs typeface="JetBrains Mono" pitchFamily="34" charset="-120"/>
+                        </a:rPr>
+                        <a:t>SIMRS</a:t>
+                      </a:r>
+                      <a:endParaRPr lang="en-US" sz="1050" dirty="0">
+                        <a:latin typeface="JetBrains Mono" charset="0"/>
+                        <a:ea typeface="JetBrains Mono" charset="0"/>
+                        <a:cs typeface="JetBrains Mono" charset="0"/>
+                      </a:endParaRPr>
+                    </a:p>
+                  </a:txBody>
+                  <a:tcPr marL="73152" marR="73152" marT="73152" marB="73152" anchor="ctr">
+                    <a:lnL w="12700" cap="flat" cmpd="sng" algn="ctr">
+                      <a:solidFill>
+                        <a:srgbClr val="ECEEF2"/>
+                      </a:solidFill>
+                      <a:prstDash val="solid"/>
+                      <a:round/>
+                      <a:headEnd type="none" w="med" len="med"/>
+                      <a:tailEnd type="none" w="med" len="med"/>
+                    </a:lnL>
+                    <a:lnR w="12700" cap="flat" cmpd="sng" algn="ctr">
+                      <a:solidFill>
+                        <a:srgbClr val="ECEEF2"/>
+                      </a:solidFill>
+                      <a:prstDash val="solid"/>
+                      <a:round/>
+                      <a:headEnd type="none" w="med" len="med"/>
+                      <a:tailEnd type="none" w="med" len="med"/>
+                    </a:lnR>
+                    <a:lnT w="12700" cap="flat" cmpd="sng" algn="ctr">
+                      <a:solidFill>
+                        <a:srgbClr val="ECEEF2"/>
+                      </a:solidFill>
+                      <a:prstDash val="solid"/>
+                      <a:round/>
+                      <a:headEnd type="none" w="med" len="med"/>
+                      <a:tailEnd type="none" w="med" len="med"/>
+                    </a:lnT>
+                    <a:lnB w="12700" cap="flat" cmpd="sng" algn="ctr">
+                      <a:solidFill>
+                        <a:srgbClr val="ECEEF2"/>
+                      </a:solidFill>
+                      <a:prstDash val="solid"/>
+                      <a:round/>
+                      <a:headEnd type="none" w="med" len="med"/>
+                      <a:tailEnd type="none" w="med" len="med"/>
+                    </a:lnB>
+                    <a:solidFill>
+                      <a:srgbClr val="F6F8FA"/>
+                    </a:solidFill>
+                  </a:tcPr>
+                </a:tc>
+                <a:tc>
+                  <a:txBody>
+                    <a:bodyPr/>
+                    <a:lstStyle/>
+                    <a:p>
+                      <a:pPr indent="0" marL="0">
+                        <a:buNone/>
+                      </a:pPr>
+                      <a:r>
+                        <a:rPr lang="en-US" sz="1100" dirty="0">
+                          <a:solidFill>
+                            <a:srgbClr val="4A5568"/>
+                          </a:solidFill>
+                          <a:latin typeface="Inter" pitchFamily="34" charset="0"/>
+                          <a:ea typeface="Inter" pitchFamily="34" charset="-122"/>
+                          <a:cs typeface="Inter" pitchFamily="34" charset="-120"/>
+                        </a:rPr>
+                        <a:t>Sistem Informasi Manajemen Rumah Sakit</a:t>
+                      </a:r>
+                      <a:endParaRPr lang="en-US" sz="1100" dirty="0">
+                        <a:latin typeface="Inter" charset="0"/>
+                        <a:ea typeface="Inter" charset="0"/>
+                        <a:cs typeface="Inter" charset="0"/>
+                      </a:endParaRPr>
+                    </a:p>
+                  </a:txBody>
+                  <a:tcPr marL="73152" marR="73152" marT="73152" marB="73152" anchor="ctr">
+                    <a:lnL w="12700" cap="flat" cmpd="sng" algn="ctr">
+                      <a:solidFill>
+                        <a:srgbClr val="ECEEF2"/>
+                      </a:solidFill>
+                      <a:prstDash val="solid"/>
+                      <a:round/>
+                      <a:headEnd type="none" w="med" len="med"/>
+                      <a:tailEnd type="none" w="med" len="med"/>
+                    </a:lnL>
+                    <a:lnR w="12700" cap="flat" cmpd="sng" algn="ctr">
+                      <a:solidFill>
+                        <a:srgbClr val="ECEEF2"/>
+                      </a:solidFill>
+                      <a:prstDash val="solid"/>
+                      <a:round/>
+                      <a:headEnd type="none" w="med" len="med"/>
+                      <a:tailEnd type="none" w="med" len="med"/>
+                    </a:lnR>
+                    <a:lnT w="12700" cap="flat" cmpd="sng" algn="ctr">
+                      <a:solidFill>
+                        <a:srgbClr val="ECEEF2"/>
+                      </a:solidFill>
+                      <a:prstDash val="solid"/>
+                      <a:round/>
+                      <a:headEnd type="none" w="med" len="med"/>
+                      <a:tailEnd type="none" w="med" len="med"/>
+                    </a:lnT>
+                    <a:lnB w="12700" cap="flat" cmpd="sng" algn="ctr">
+                      <a:solidFill>
+                        <a:srgbClr val="ECEEF2"/>
+                      </a:solidFill>
+                      <a:prstDash val="solid"/>
+                      <a:round/>
+                      <a:headEnd type="none" w="med" len="med"/>
+                      <a:tailEnd type="none" w="med" len="med"/>
+                    </a:lnB>
+                  </a:tcPr>
+                </a:tc>
+              </a:tr>
+              <a:tr h="457200">
+                <a:tc>
+                  <a:txBody>
+                    <a:bodyPr/>
+                    <a:lstStyle/>
+                    <a:p>
+                      <a:pPr indent="0" marL="0">
+                        <a:buNone/>
+                      </a:pPr>
+                      <a:r>
+                        <a:rPr lang="en-US" sz="1050" b="1" dirty="0">
+                          <a:solidFill>
+                            <a:srgbClr val="0B1526"/>
+                          </a:solidFill>
+                          <a:latin typeface="JetBrains Mono" pitchFamily="34" charset="0"/>
+                          <a:ea typeface="JetBrains Mono" pitchFamily="34" charset="-122"/>
+                          <a:cs typeface="JetBrains Mono" pitchFamily="34" charset="-120"/>
+                        </a:rPr>
+                        <a:t>ML</a:t>
+                      </a:r>
+                      <a:endParaRPr lang="en-US" sz="1050" dirty="0">
+                        <a:latin typeface="JetBrains Mono" charset="0"/>
+                        <a:ea typeface="JetBrains Mono" charset="0"/>
+                        <a:cs typeface="JetBrains Mono" charset="0"/>
+                      </a:endParaRPr>
+                    </a:p>
+                  </a:txBody>
+                  <a:tcPr marL="73152" marR="73152" marT="73152" marB="73152" anchor="ctr">
+                    <a:lnL w="12700" cap="flat" cmpd="sng" algn="ctr">
+                      <a:solidFill>
+                        <a:srgbClr val="ECEEF2"/>
+                      </a:solidFill>
+                      <a:prstDash val="solid"/>
+                      <a:round/>
+                      <a:headEnd type="none" w="med" len="med"/>
+                      <a:tailEnd type="none" w="med" len="med"/>
+                    </a:lnL>
+                    <a:lnR w="12700" cap="flat" cmpd="sng" algn="ctr">
+                      <a:solidFill>
+                        <a:srgbClr val="ECEEF2"/>
+                      </a:solidFill>
+                      <a:prstDash val="solid"/>
+                      <a:round/>
+                      <a:headEnd type="none" w="med" len="med"/>
+                      <a:tailEnd type="none" w="med" len="med"/>
+                    </a:lnR>
+                    <a:lnT w="12700" cap="flat" cmpd="sng" algn="ctr">
+                      <a:solidFill>
+                        <a:srgbClr val="ECEEF2"/>
+                      </a:solidFill>
+                      <a:prstDash val="solid"/>
+                      <a:round/>
+                      <a:headEnd type="none" w="med" len="med"/>
+                      <a:tailEnd type="none" w="med" len="med"/>
+                    </a:lnT>
+                    <a:lnB w="12700" cap="flat" cmpd="sng" algn="ctr">
+                      <a:solidFill>
+                        <a:srgbClr val="ECEEF2"/>
+                      </a:solidFill>
+                      <a:prstDash val="solid"/>
+                      <a:round/>
+                      <a:headEnd type="none" w="med" len="med"/>
+                      <a:tailEnd type="none" w="med" len="med"/>
+                    </a:lnB>
+                    <a:solidFill>
+                      <a:srgbClr val="F6F8FA"/>
+                    </a:solidFill>
+                  </a:tcPr>
+                </a:tc>
+                <a:tc>
+                  <a:txBody>
+                    <a:bodyPr/>
+                    <a:lstStyle/>
+                    <a:p>
+                      <a:pPr indent="0" marL="0">
+                        <a:buNone/>
+                      </a:pPr>
+                      <a:r>
+                        <a:rPr lang="en-US" sz="1100" dirty="0">
+                          <a:solidFill>
+                            <a:srgbClr val="4A5568"/>
+                          </a:solidFill>
+                          <a:latin typeface="Inter" pitchFamily="34" charset="0"/>
+                          <a:ea typeface="Inter" pitchFamily="34" charset="-122"/>
+                          <a:cs typeface="Inter" pitchFamily="34" charset="-120"/>
+                        </a:rPr>
+                        <a:t>Machine Learning (pembelajaran mesin)</a:t>
+                      </a:r>
+                      <a:endParaRPr lang="en-US" sz="1100" dirty="0">
+                        <a:latin typeface="Inter" charset="0"/>
+                        <a:ea typeface="Inter" charset="0"/>
+                        <a:cs typeface="Inter" charset="0"/>
+                      </a:endParaRPr>
+                    </a:p>
+                  </a:txBody>
+                  <a:tcPr marL="73152" marR="73152" marT="73152" marB="73152" anchor="ctr">
+                    <a:lnL w="12700" cap="flat" cmpd="sng" algn="ctr">
+                      <a:solidFill>
+                        <a:srgbClr val="ECEEF2"/>
+                      </a:solidFill>
+                      <a:prstDash val="solid"/>
+                      <a:round/>
+                      <a:headEnd type="none" w="med" len="med"/>
+                      <a:tailEnd type="none" w="med" len="med"/>
+                    </a:lnL>
+                    <a:lnR w="12700" cap="flat" cmpd="sng" algn="ctr">
+                      <a:solidFill>
+                        <a:srgbClr val="ECEEF2"/>
+                      </a:solidFill>
+                      <a:prstDash val="solid"/>
+                      <a:round/>
+                      <a:headEnd type="none" w="med" len="med"/>
+                      <a:tailEnd type="none" w="med" len="med"/>
+                    </a:lnR>
+                    <a:lnT w="12700" cap="flat" cmpd="sng" algn="ctr">
+                      <a:solidFill>
+                        <a:srgbClr val="ECEEF2"/>
+                      </a:solidFill>
+                      <a:prstDash val="solid"/>
+                      <a:round/>
+                      <a:headEnd type="none" w="med" len="med"/>
+                      <a:tailEnd type="none" w="med" len="med"/>
+                    </a:lnT>
+                    <a:lnB w="12700" cap="flat" cmpd="sng" algn="ctr">
+                      <a:solidFill>
+                        <a:srgbClr val="ECEEF2"/>
+                      </a:solidFill>
+                      <a:prstDash val="solid"/>
+                      <a:round/>
+                      <a:headEnd type="none" w="med" len="med"/>
+                      <a:tailEnd type="none" w="med" len="med"/>
+                    </a:lnB>
+                  </a:tcPr>
+                </a:tc>
+              </a:tr>
+              <a:tr h="457200">
+                <a:tc>
+                  <a:txBody>
+                    <a:bodyPr/>
+                    <a:lstStyle/>
+                    <a:p>
+                      <a:pPr indent="0" marL="0">
+                        <a:buNone/>
+                      </a:pPr>
+                      <a:r>
+                        <a:rPr lang="en-US" sz="1050" b="1" dirty="0">
+                          <a:solidFill>
+                            <a:srgbClr val="0B1526"/>
+                          </a:solidFill>
+                          <a:latin typeface="JetBrains Mono" pitchFamily="34" charset="0"/>
+                          <a:ea typeface="JetBrains Mono" pitchFamily="34" charset="-122"/>
+                          <a:cs typeface="JetBrains Mono" pitchFamily="34" charset="-120"/>
+                        </a:rPr>
+                        <a:t>LLM</a:t>
+                      </a:r>
+                      <a:endParaRPr lang="en-US" sz="1050" dirty="0">
+                        <a:latin typeface="JetBrains Mono" charset="0"/>
+                        <a:ea typeface="JetBrains Mono" charset="0"/>
+                        <a:cs typeface="JetBrains Mono" charset="0"/>
+                      </a:endParaRPr>
+                    </a:p>
+                  </a:txBody>
+                  <a:tcPr marL="73152" marR="73152" marT="73152" marB="73152" anchor="ctr">
+                    <a:lnL w="12700" cap="flat" cmpd="sng" algn="ctr">
+                      <a:solidFill>
+                        <a:srgbClr val="ECEEF2"/>
+                      </a:solidFill>
+                      <a:prstDash val="solid"/>
+                      <a:round/>
+                      <a:headEnd type="none" w="med" len="med"/>
+                      <a:tailEnd type="none" w="med" len="med"/>
+                    </a:lnL>
+                    <a:lnR w="12700" cap="flat" cmpd="sng" algn="ctr">
+                      <a:solidFill>
+                        <a:srgbClr val="ECEEF2"/>
+                      </a:solidFill>
+                      <a:prstDash val="solid"/>
+                      <a:round/>
+                      <a:headEnd type="none" w="med" len="med"/>
+                      <a:tailEnd type="none" w="med" len="med"/>
+                    </a:lnR>
+                    <a:lnT w="12700" cap="flat" cmpd="sng" algn="ctr">
+                      <a:solidFill>
+                        <a:srgbClr val="ECEEF2"/>
+                      </a:solidFill>
+                      <a:prstDash val="solid"/>
+                      <a:round/>
+                      <a:headEnd type="none" w="med" len="med"/>
+                      <a:tailEnd type="none" w="med" len="med"/>
+                    </a:lnT>
+                    <a:lnB w="12700" cap="flat" cmpd="sng" algn="ctr">
+                      <a:solidFill>
+                        <a:srgbClr val="ECEEF2"/>
+                      </a:solidFill>
+                      <a:prstDash val="solid"/>
+                      <a:round/>
+                      <a:headEnd type="none" w="med" len="med"/>
+                      <a:tailEnd type="none" w="med" len="med"/>
+                    </a:lnB>
+                    <a:solidFill>
+                      <a:srgbClr val="F6F8FA"/>
+                    </a:solidFill>
+                  </a:tcPr>
+                </a:tc>
+                <a:tc>
+                  <a:txBody>
+                    <a:bodyPr/>
+                    <a:lstStyle/>
+                    <a:p>
+                      <a:pPr indent="0" marL="0">
+                        <a:buNone/>
+                      </a:pPr>
+                      <a:r>
+                        <a:rPr lang="en-US" sz="1100" dirty="0">
+                          <a:solidFill>
+                            <a:srgbClr val="4A5568"/>
+                          </a:solidFill>
+                          <a:latin typeface="Inter" pitchFamily="34" charset="0"/>
+                          <a:ea typeface="Inter" pitchFamily="34" charset="-122"/>
+                          <a:cs typeface="Inter" pitchFamily="34" charset="-120"/>
+                        </a:rPr>
+                        <a:t>Large Language Model</a:t>
+                      </a:r>
+                      <a:endParaRPr lang="en-US" sz="1100" dirty="0">
+                        <a:latin typeface="Inter" charset="0"/>
+                        <a:ea typeface="Inter" charset="0"/>
+                        <a:cs typeface="Inter" charset="0"/>
+                      </a:endParaRPr>
+                    </a:p>
+                  </a:txBody>
+                  <a:tcPr marL="73152" marR="73152" marT="73152" marB="73152" anchor="ctr">
+                    <a:lnL w="12700" cap="flat" cmpd="sng" algn="ctr">
+                      <a:solidFill>
+                        <a:srgbClr val="ECEEF2"/>
+                      </a:solidFill>
+                      <a:prstDash val="solid"/>
+                      <a:round/>
+                      <a:headEnd type="none" w="med" len="med"/>
+                      <a:tailEnd type="none" w="med" len="med"/>
+                    </a:lnL>
+                    <a:lnR w="12700" cap="flat" cmpd="sng" algn="ctr">
+                      <a:solidFill>
+                        <a:srgbClr val="ECEEF2"/>
+                      </a:solidFill>
+                      <a:prstDash val="solid"/>
+                      <a:round/>
+                      <a:headEnd type="none" w="med" len="med"/>
+                      <a:tailEnd type="none" w="med" len="med"/>
+                    </a:lnR>
+                    <a:lnT w="12700" cap="flat" cmpd="sng" algn="ctr">
+                      <a:solidFill>
+                        <a:srgbClr val="ECEEF2"/>
+                      </a:solidFill>
+                      <a:prstDash val="solid"/>
+                      <a:round/>
+                      <a:headEnd type="none" w="med" len="med"/>
+                      <a:tailEnd type="none" w="med" len="med"/>
+                    </a:lnT>
+                    <a:lnB w="12700" cap="flat" cmpd="sng" algn="ctr">
+                      <a:solidFill>
+                        <a:srgbClr val="ECEEF2"/>
+                      </a:solidFill>
+                      <a:prstDash val="solid"/>
+                      <a:round/>
+                      <a:headEnd type="none" w="med" len="med"/>
+                      <a:tailEnd type="none" w="med" len="med"/>
+                    </a:lnB>
+                  </a:tcPr>
+                </a:tc>
+              </a:tr>
+              <a:tr h="457200">
+                <a:tc>
+                  <a:txBody>
+                    <a:bodyPr/>
+                    <a:lstStyle/>
+                    <a:p>
+                      <a:pPr indent="0" marL="0">
+                        <a:buNone/>
+                      </a:pPr>
+                      <a:r>
+                        <a:rPr lang="en-US" sz="1050" b="1" dirty="0">
+                          <a:solidFill>
+                            <a:srgbClr val="0B1526"/>
+                          </a:solidFill>
+                          <a:latin typeface="JetBrains Mono" pitchFamily="34" charset="0"/>
+                          <a:ea typeface="JetBrains Mono" pitchFamily="34" charset="-122"/>
+                          <a:cs typeface="JetBrains Mono" pitchFamily="34" charset="-120"/>
+                        </a:rPr>
+                        <a:t>API</a:t>
+                      </a:r>
+                      <a:endParaRPr lang="en-US" sz="1050" dirty="0">
+                        <a:latin typeface="JetBrains Mono" charset="0"/>
+                        <a:ea typeface="JetBrains Mono" charset="0"/>
+                        <a:cs typeface="JetBrains Mono" charset="0"/>
+                      </a:endParaRPr>
+                    </a:p>
+                  </a:txBody>
+                  <a:tcPr marL="73152" marR="73152" marT="73152" marB="73152" anchor="ctr">
+                    <a:lnL w="12700" cap="flat" cmpd="sng" algn="ctr">
+                      <a:solidFill>
+                        <a:srgbClr val="ECEEF2"/>
+                      </a:solidFill>
+                      <a:prstDash val="solid"/>
+                      <a:round/>
+                      <a:headEnd type="none" w="med" len="med"/>
+                      <a:tailEnd type="none" w="med" len="med"/>
+                    </a:lnL>
+                    <a:lnR w="12700" cap="flat" cmpd="sng" algn="ctr">
+                      <a:solidFill>
+                        <a:srgbClr val="ECEEF2"/>
+                      </a:solidFill>
+                      <a:prstDash val="solid"/>
+                      <a:round/>
+                      <a:headEnd type="none" w="med" len="med"/>
+                      <a:tailEnd type="none" w="med" len="med"/>
+                    </a:lnR>
+                    <a:lnT w="12700" cap="flat" cmpd="sng" algn="ctr">
+                      <a:solidFill>
+                        <a:srgbClr val="ECEEF2"/>
+                      </a:solidFill>
+                      <a:prstDash val="solid"/>
+                      <a:round/>
+                      <a:headEnd type="none" w="med" len="med"/>
+                      <a:tailEnd type="none" w="med" len="med"/>
+                    </a:lnT>
+                    <a:lnB w="12700" cap="flat" cmpd="sng" algn="ctr">
+                      <a:solidFill>
+                        <a:srgbClr val="ECEEF2"/>
+                      </a:solidFill>
+                      <a:prstDash val="solid"/>
+                      <a:round/>
+                      <a:headEnd type="none" w="med" len="med"/>
+                      <a:tailEnd type="none" w="med" len="med"/>
+                    </a:lnB>
+                    <a:solidFill>
+                      <a:srgbClr val="F6F8FA"/>
+                    </a:solidFill>
+                  </a:tcPr>
+                </a:tc>
+                <a:tc>
+                  <a:txBody>
+                    <a:bodyPr/>
+                    <a:lstStyle/>
+                    <a:p>
+                      <a:pPr indent="0" marL="0">
+                        <a:buNone/>
+                      </a:pPr>
+                      <a:r>
+                        <a:rPr lang="en-US" sz="1100" dirty="0">
+                          <a:solidFill>
+                            <a:srgbClr val="4A5568"/>
+                          </a:solidFill>
+                          <a:latin typeface="Inter" pitchFamily="34" charset="0"/>
+                          <a:ea typeface="Inter" pitchFamily="34" charset="-122"/>
+                          <a:cs typeface="Inter" pitchFamily="34" charset="-120"/>
+                        </a:rPr>
+                        <a:t>Application Programming Interface</a:t>
+                      </a:r>
+                      <a:endParaRPr lang="en-US" sz="1100" dirty="0">
+                        <a:latin typeface="Inter" charset="0"/>
+                        <a:ea typeface="Inter" charset="0"/>
+                        <a:cs typeface="Inter" charset="0"/>
+                      </a:endParaRPr>
+                    </a:p>
+                  </a:txBody>
+                  <a:tcPr marL="73152" marR="73152" marT="73152" marB="73152" anchor="ctr">
+                    <a:lnL w="12700" cap="flat" cmpd="sng" algn="ctr">
+                      <a:solidFill>
+                        <a:srgbClr val="ECEEF2"/>
+                      </a:solidFill>
+                      <a:prstDash val="solid"/>
+                      <a:round/>
+                      <a:headEnd type="none" w="med" len="med"/>
+                      <a:tailEnd type="none" w="med" len="med"/>
+                    </a:lnL>
+                    <a:lnR w="12700" cap="flat" cmpd="sng" algn="ctr">
+                      <a:solidFill>
+                        <a:srgbClr val="ECEEF2"/>
+                      </a:solidFill>
+                      <a:prstDash val="solid"/>
+                      <a:round/>
+                      <a:headEnd type="none" w="med" len="med"/>
+                      <a:tailEnd type="none" w="med" len="med"/>
+                    </a:lnR>
+                    <a:lnT w="12700" cap="flat" cmpd="sng" algn="ctr">
+                      <a:solidFill>
+                        <a:srgbClr val="ECEEF2"/>
+                      </a:solidFill>
+                      <a:prstDash val="solid"/>
+                      <a:round/>
+                      <a:headEnd type="none" w="med" len="med"/>
+                      <a:tailEnd type="none" w="med" len="med"/>
+                    </a:lnT>
+                    <a:lnB w="12700" cap="flat" cmpd="sng" algn="ctr">
+                      <a:solidFill>
+                        <a:srgbClr val="ECEEF2"/>
+                      </a:solidFill>
+                      <a:prstDash val="solid"/>
+                      <a:round/>
+                      <a:headEnd type="none" w="med" len="med"/>
+                      <a:tailEnd type="none" w="med" len="med"/>
+                    </a:lnB>
+                  </a:tcPr>
+                </a:tc>
+              </a:tr>
+              <a:tr h="457200">
+                <a:tc>
+                  <a:txBody>
+                    <a:bodyPr/>
+                    <a:lstStyle/>
+                    <a:p>
+                      <a:pPr indent="0" marL="0">
+                        <a:buNone/>
+                      </a:pPr>
+                      <a:r>
+                        <a:rPr lang="en-US" sz="1050" b="1" dirty="0">
+                          <a:solidFill>
+                            <a:srgbClr val="0B1526"/>
+                          </a:solidFill>
+                          <a:latin typeface="JetBrains Mono" pitchFamily="34" charset="0"/>
+                          <a:ea typeface="JetBrains Mono" pitchFamily="34" charset="-122"/>
+                          <a:cs typeface="JetBrains Mono" pitchFamily="34" charset="-120"/>
+                        </a:rPr>
+                        <a:t>RBAC</a:t>
+                      </a:r>
+                      <a:endParaRPr lang="en-US" sz="1050" dirty="0">
+                        <a:latin typeface="JetBrains Mono" charset="0"/>
+                        <a:ea typeface="JetBrains Mono" charset="0"/>
+                        <a:cs typeface="JetBrains Mono" charset="0"/>
+                      </a:endParaRPr>
+                    </a:p>
+                  </a:txBody>
+                  <a:tcPr marL="73152" marR="73152" marT="73152" marB="73152" anchor="ctr">
+                    <a:lnL w="12700" cap="flat" cmpd="sng" algn="ctr">
+                      <a:solidFill>
+                        <a:srgbClr val="ECEEF2"/>
+                      </a:solidFill>
+                      <a:prstDash val="solid"/>
+                      <a:round/>
+                      <a:headEnd type="none" w="med" len="med"/>
+                      <a:tailEnd type="none" w="med" len="med"/>
+                    </a:lnL>
+                    <a:lnR w="12700" cap="flat" cmpd="sng" algn="ctr">
+                      <a:solidFill>
+                        <a:srgbClr val="ECEEF2"/>
+                      </a:solidFill>
+                      <a:prstDash val="solid"/>
+                      <a:round/>
+                      <a:headEnd type="none" w="med" len="med"/>
+                      <a:tailEnd type="none" w="med" len="med"/>
+                    </a:lnR>
+                    <a:lnT w="12700" cap="flat" cmpd="sng" algn="ctr">
+                      <a:solidFill>
+                        <a:srgbClr val="ECEEF2"/>
+                      </a:solidFill>
+                      <a:prstDash val="solid"/>
+                      <a:round/>
+                      <a:headEnd type="none" w="med" len="med"/>
+                      <a:tailEnd type="none" w="med" len="med"/>
+                    </a:lnT>
+                    <a:lnB w="12700" cap="flat" cmpd="sng" algn="ctr">
+                      <a:solidFill>
+                        <a:srgbClr val="ECEEF2"/>
+                      </a:solidFill>
+                      <a:prstDash val="solid"/>
+                      <a:round/>
+                      <a:headEnd type="none" w="med" len="med"/>
+                      <a:tailEnd type="none" w="med" len="med"/>
+                    </a:lnB>
+                    <a:solidFill>
+                      <a:srgbClr val="F6F8FA"/>
+                    </a:solidFill>
+                  </a:tcPr>
+                </a:tc>
+                <a:tc>
+                  <a:txBody>
+                    <a:bodyPr/>
+                    <a:lstStyle/>
+                    <a:p>
+                      <a:pPr indent="0" marL="0">
+                        <a:buNone/>
+                      </a:pPr>
+                      <a:r>
+                        <a:rPr lang="en-US" sz="1100" dirty="0">
+                          <a:solidFill>
+                            <a:srgbClr val="4A5568"/>
+                          </a:solidFill>
+                          <a:latin typeface="Inter" pitchFamily="34" charset="0"/>
+                          <a:ea typeface="Inter" pitchFamily="34" charset="-122"/>
+                          <a:cs typeface="Inter" pitchFamily="34" charset="-120"/>
+                        </a:rPr>
+                        <a:t>Role-Based Access Control (hak akses per peran)</a:t>
+                      </a:r>
+                      <a:endParaRPr lang="en-US" sz="1100" dirty="0">
+                        <a:latin typeface="Inter" charset="0"/>
+                        <a:ea typeface="Inter" charset="0"/>
+                        <a:cs typeface="Inter" charset="0"/>
+                      </a:endParaRPr>
+                    </a:p>
+                  </a:txBody>
+                  <a:tcPr marL="73152" marR="73152" marT="73152" marB="73152" anchor="ctr">
+                    <a:lnL w="12700" cap="flat" cmpd="sng" algn="ctr">
+                      <a:solidFill>
+                        <a:srgbClr val="ECEEF2"/>
+                      </a:solidFill>
+                      <a:prstDash val="solid"/>
+                      <a:round/>
+                      <a:headEnd type="none" w="med" len="med"/>
+                      <a:tailEnd type="none" w="med" len="med"/>
+                    </a:lnL>
+                    <a:lnR w="12700" cap="flat" cmpd="sng" algn="ctr">
+                      <a:solidFill>
+                        <a:srgbClr val="ECEEF2"/>
+                      </a:solidFill>
+                      <a:prstDash val="solid"/>
+                      <a:round/>
+                      <a:headEnd type="none" w="med" len="med"/>
+                      <a:tailEnd type="none" w="med" len="med"/>
+                    </a:lnR>
+                    <a:lnT w="12700" cap="flat" cmpd="sng" algn="ctr">
+                      <a:solidFill>
+                        <a:srgbClr val="ECEEF2"/>
+                      </a:solidFill>
+                      <a:prstDash val="solid"/>
+                      <a:round/>
+                      <a:headEnd type="none" w="med" len="med"/>
+                      <a:tailEnd type="none" w="med" len="med"/>
+                    </a:lnT>
+                    <a:lnB w="12700" cap="flat" cmpd="sng" algn="ctr">
+                      <a:solidFill>
+                        <a:srgbClr val="ECEEF2"/>
+                      </a:solidFill>
+                      <a:prstDash val="solid"/>
+                      <a:round/>
+                      <a:headEnd type="none" w="med" len="med"/>
+                      <a:tailEnd type="none" w="med" len="med"/>
+                    </a:lnB>
+                  </a:tcPr>
+                </a:tc>
+              </a:tr>
+              <a:tr h="457200">
+                <a:tc>
+                  <a:txBody>
+                    <a:bodyPr/>
+                    <a:lstStyle/>
+                    <a:p>
+                      <a:pPr indent="0" marL="0">
+                        <a:buNone/>
+                      </a:pPr>
+                      <a:r>
+                        <a:rPr lang="en-US" sz="1050" b="1" dirty="0">
+                          <a:solidFill>
+                            <a:srgbClr val="0B1526"/>
+                          </a:solidFill>
+                          <a:latin typeface="JetBrains Mono" pitchFamily="34" charset="0"/>
+                          <a:ea typeface="JetBrains Mono" pitchFamily="34" charset="-122"/>
+                          <a:cs typeface="JetBrains Mono" pitchFamily="34" charset="-120"/>
+                        </a:rPr>
+                        <a:t>UU PDP</a:t>
+                      </a:r>
+                      <a:endParaRPr lang="en-US" sz="1050" dirty="0">
+                        <a:latin typeface="JetBrains Mono" charset="0"/>
+                        <a:ea typeface="JetBrains Mono" charset="0"/>
+                        <a:cs typeface="JetBrains Mono" charset="0"/>
+                      </a:endParaRPr>
+                    </a:p>
+                  </a:txBody>
+                  <a:tcPr marL="73152" marR="73152" marT="73152" marB="73152" anchor="ctr">
+                    <a:lnL w="12700" cap="flat" cmpd="sng" algn="ctr">
+                      <a:solidFill>
+                        <a:srgbClr val="ECEEF2"/>
+                      </a:solidFill>
+                      <a:prstDash val="solid"/>
+                      <a:round/>
+                      <a:headEnd type="none" w="med" len="med"/>
+                      <a:tailEnd type="none" w="med" len="med"/>
+                    </a:lnL>
+                    <a:lnR w="12700" cap="flat" cmpd="sng" algn="ctr">
+                      <a:solidFill>
+                        <a:srgbClr val="ECEEF2"/>
+                      </a:solidFill>
+                      <a:prstDash val="solid"/>
+                      <a:round/>
+                      <a:headEnd type="none" w="med" len="med"/>
+                      <a:tailEnd type="none" w="med" len="med"/>
+                    </a:lnR>
+                    <a:lnT w="12700" cap="flat" cmpd="sng" algn="ctr">
+                      <a:solidFill>
+                        <a:srgbClr val="ECEEF2"/>
+                      </a:solidFill>
+                      <a:prstDash val="solid"/>
+                      <a:round/>
+                      <a:headEnd type="none" w="med" len="med"/>
+                      <a:tailEnd type="none" w="med" len="med"/>
+                    </a:lnT>
+                    <a:lnB w="12700" cap="flat" cmpd="sng" algn="ctr">
+                      <a:solidFill>
+                        <a:srgbClr val="ECEEF2"/>
+                      </a:solidFill>
+                      <a:prstDash val="solid"/>
+                      <a:round/>
+                      <a:headEnd type="none" w="med" len="med"/>
+                      <a:tailEnd type="none" w="med" len="med"/>
+                    </a:lnB>
+                    <a:solidFill>
+                      <a:srgbClr val="F6F8FA"/>
+                    </a:solidFill>
+                  </a:tcPr>
+                </a:tc>
+                <a:tc>
+                  <a:txBody>
+                    <a:bodyPr/>
+                    <a:lstStyle/>
+                    <a:p>
+                      <a:pPr indent="0" marL="0">
+                        <a:buNone/>
+                      </a:pPr>
+                      <a:r>
+                        <a:rPr lang="en-US" sz="1100" dirty="0">
+                          <a:solidFill>
+                            <a:srgbClr val="4A5568"/>
+                          </a:solidFill>
+                          <a:latin typeface="Inter" pitchFamily="34" charset="0"/>
+                          <a:ea typeface="Inter" pitchFamily="34" charset="-122"/>
+                          <a:cs typeface="Inter" pitchFamily="34" charset="-120"/>
+                        </a:rPr>
+                        <a:t>Undang-Undang Pelindungan Data Pribadi</a:t>
+                      </a:r>
+                      <a:endParaRPr lang="en-US" sz="1100" dirty="0">
+                        <a:latin typeface="Inter" charset="0"/>
+                        <a:ea typeface="Inter" charset="0"/>
+                        <a:cs typeface="Inter" charset="0"/>
+                      </a:endParaRPr>
+                    </a:p>
+                  </a:txBody>
+                  <a:tcPr marL="73152" marR="73152" marT="73152" marB="73152" anchor="ctr">
+                    <a:lnL w="12700" cap="flat" cmpd="sng" algn="ctr">
+                      <a:solidFill>
+                        <a:srgbClr val="ECEEF2"/>
+                      </a:solidFill>
+                      <a:prstDash val="solid"/>
+                      <a:round/>
+                      <a:headEnd type="none" w="med" len="med"/>
+                      <a:tailEnd type="none" w="med" len="med"/>
+                    </a:lnL>
+                    <a:lnR w="12700" cap="flat" cmpd="sng" algn="ctr">
+                      <a:solidFill>
+                        <a:srgbClr val="ECEEF2"/>
+                      </a:solidFill>
+                      <a:prstDash val="solid"/>
+                      <a:round/>
+                      <a:headEnd type="none" w="med" len="med"/>
+                      <a:tailEnd type="none" w="med" len="med"/>
+                    </a:lnR>
+                    <a:lnT w="12700" cap="flat" cmpd="sng" algn="ctr">
+                      <a:solidFill>
+                        <a:srgbClr val="ECEEF2"/>
+                      </a:solidFill>
+                      <a:prstDash val="solid"/>
+                      <a:round/>
+                      <a:headEnd type="none" w="med" len="med"/>
+                      <a:tailEnd type="none" w="med" len="med"/>
+                    </a:lnT>
+                    <a:lnB w="12700" cap="flat" cmpd="sng" algn="ctr">
+                      <a:solidFill>
+                        <a:srgbClr val="ECEEF2"/>
+                      </a:solidFill>
+                      <a:prstDash val="solid"/>
+                      <a:round/>
+                      <a:headEnd type="none" w="med" len="med"/>
+                      <a:tailEnd type="none" w="med" len="med"/>
+                    </a:lnB>
+                  </a:tcPr>
+                </a:tc>
+              </a:tr>
+              <a:tr h="457200">
+                <a:tc>
+                  <a:txBody>
+                    <a:bodyPr/>
+                    <a:lstStyle/>
+                    <a:p>
+                      <a:pPr indent="0" marL="0">
+                        <a:buNone/>
+                      </a:pPr>
+                      <a:r>
+                        <a:rPr lang="en-US" sz="1050" b="1" dirty="0">
+                          <a:solidFill>
+                            <a:srgbClr val="0B1526"/>
+                          </a:solidFill>
+                          <a:latin typeface="JetBrains Mono" pitchFamily="34" charset="0"/>
+                          <a:ea typeface="JetBrains Mono" pitchFamily="34" charset="-122"/>
+                          <a:cs typeface="JetBrains Mono" pitchFamily="34" charset="-120"/>
+                        </a:rPr>
+                        <a:t>KC/PC</a:t>
+                      </a:r>
+                      <a:endParaRPr lang="en-US" sz="1050" dirty="0">
+                        <a:latin typeface="JetBrains Mono" charset="0"/>
+                        <a:ea typeface="JetBrains Mono" charset="0"/>
+                        <a:cs typeface="JetBrains Mono" charset="0"/>
+                      </a:endParaRPr>
+                    </a:p>
+                  </a:txBody>
+                  <a:tcPr marL="73152" marR="73152" marT="73152" marB="73152" anchor="ctr">
+                    <a:lnL w="12700" cap="flat" cmpd="sng" algn="ctr">
+                      <a:solidFill>
+                        <a:srgbClr val="ECEEF2"/>
+                      </a:solidFill>
+                      <a:prstDash val="solid"/>
+                      <a:round/>
+                      <a:headEnd type="none" w="med" len="med"/>
+                      <a:tailEnd type="none" w="med" len="med"/>
+                    </a:lnL>
+                    <a:lnR w="12700" cap="flat" cmpd="sng" algn="ctr">
+                      <a:solidFill>
+                        <a:srgbClr val="ECEEF2"/>
+                      </a:solidFill>
+                      <a:prstDash val="solid"/>
+                      <a:round/>
+                      <a:headEnd type="none" w="med" len="med"/>
+                      <a:tailEnd type="none" w="med" len="med"/>
+                    </a:lnR>
+                    <a:lnT w="12700" cap="flat" cmpd="sng" algn="ctr">
+                      <a:solidFill>
+                        <a:srgbClr val="ECEEF2"/>
+                      </a:solidFill>
+                      <a:prstDash val="solid"/>
+                      <a:round/>
+                      <a:headEnd type="none" w="med" len="med"/>
+                      <a:tailEnd type="none" w="med" len="med"/>
+                    </a:lnT>
+                    <a:lnB w="12700" cap="flat" cmpd="sng" algn="ctr">
+                      <a:solidFill>
+                        <a:srgbClr val="ECEEF2"/>
+                      </a:solidFill>
+                      <a:prstDash val="solid"/>
+                      <a:round/>
+                      <a:headEnd type="none" w="med" len="med"/>
+                      <a:tailEnd type="none" w="med" len="med"/>
+                    </a:lnB>
+                    <a:solidFill>
+                      <a:srgbClr val="F6F8FA"/>
+                    </a:solidFill>
+                  </a:tcPr>
+                </a:tc>
+                <a:tc>
+                  <a:txBody>
+                    <a:bodyPr/>
+                    <a:lstStyle/>
+                    <a:p>
+                      <a:pPr indent="0" marL="0">
+                        <a:buNone/>
+                      </a:pPr>
+                      <a:r>
+                        <a:rPr lang="en-US" sz="1100" dirty="0">
+                          <a:solidFill>
+                            <a:srgbClr val="4A5568"/>
+                          </a:solidFill>
+                          <a:latin typeface="Inter" pitchFamily="34" charset="0"/>
+                          <a:ea typeface="Inter" pitchFamily="34" charset="-122"/>
+                          <a:cs typeface="Inter" pitchFamily="34" charset="-120"/>
+                        </a:rPr>
+                        <a:t>Kantor Cabang / Kantor Cabang Pembantu</a:t>
+                      </a:r>
+                      <a:endParaRPr lang="en-US" sz="1100" dirty="0">
+                        <a:latin typeface="Inter" charset="0"/>
+                        <a:ea typeface="Inter" charset="0"/>
+                        <a:cs typeface="Inter" charset="0"/>
+                      </a:endParaRPr>
+                    </a:p>
+                  </a:txBody>
+                  <a:tcPr marL="73152" marR="73152" marT="73152" marB="73152" anchor="ctr">
+                    <a:lnL w="12700" cap="flat" cmpd="sng" algn="ctr">
+                      <a:solidFill>
+                        <a:srgbClr val="ECEEF2"/>
+                      </a:solidFill>
+                      <a:prstDash val="solid"/>
+                      <a:round/>
+                      <a:headEnd type="none" w="med" len="med"/>
+                      <a:tailEnd type="none" w="med" len="med"/>
+                    </a:lnL>
+                    <a:lnR w="12700" cap="flat" cmpd="sng" algn="ctr">
+                      <a:solidFill>
+                        <a:srgbClr val="ECEEF2"/>
+                      </a:solidFill>
+                      <a:prstDash val="solid"/>
+                      <a:round/>
+                      <a:headEnd type="none" w="med" len="med"/>
+                      <a:tailEnd type="none" w="med" len="med"/>
+                    </a:lnR>
+                    <a:lnT w="12700" cap="flat" cmpd="sng" algn="ctr">
+                      <a:solidFill>
+                        <a:srgbClr val="ECEEF2"/>
+                      </a:solidFill>
+                      <a:prstDash val="solid"/>
+                      <a:round/>
+                      <a:headEnd type="none" w="med" len="med"/>
+                      <a:tailEnd type="none" w="med" len="med"/>
+                    </a:lnT>
+                    <a:lnB w="12700" cap="flat" cmpd="sng" algn="ctr">
+                      <a:solidFill>
+                        <a:srgbClr val="ECEEF2"/>
+                      </a:solidFill>
+                      <a:prstDash val="solid"/>
+                      <a:round/>
+                      <a:headEnd type="none" w="med" len="med"/>
+                      <a:tailEnd type="none" w="med" len="med"/>
+                    </a:lnB>
+                  </a:tcPr>
+                </a:tc>
+              </a:tr>
+            </a:tbl>
+          </a:graphicData>
+        </a:graphic>
+      </p:graphicFrame>
+      <p:sp>
+        <p:nvSpPr>
+          <p:cNvPr id="6" name="Text 2"/>
+          <p:cNvSpPr/>
+          <p:nvPr/>
+        </p:nvSpPr>
+        <p:spPr>
+          <a:xfrm>
+            <a:off x="457200" y="6035040"/>
+            <a:ext cx="11247120" cy="256032"/>
+          </a:xfrm>
+          <a:prstGeom prst="rect">
+            <a:avLst/>
+          </a:prstGeom>
+          <a:noFill/>
+          <a:ln/>
+        </p:spPr>
+        <p:txBody>
+          <a:bodyPr wrap="square" lIns="0" tIns="0" rIns="0" bIns="0" rtlCol="0" anchor="ctr"/>
+          <a:lstStyle/>
+          <a:p>
+            <a:pPr indent="0" marL="0">
+              <a:buNone/>
+            </a:pPr>
+            <a:r>
+              <a:rPr lang="en-US" sz="1050" dirty="0">
+                <a:solidFill>
+                  <a:srgbClr val="8291A6"/>
+                </a:solidFill>
+                <a:latin typeface="Inter" pitchFamily="34" charset="0"/>
+                <a:ea typeface="Inter" pitchFamily="34" charset="-122"/>
+                <a:cs typeface="Inter" pitchFamily="34" charset="-120"/>
+              </a:rPr>
+              <a:t>Pipeline A1, A2, A3 adalah tiga agen audit SiKePo: aturan deterministik, machine learning, dan adjudikasi LLM.</a:t>
+            </a:r>
+            <a:endParaRPr lang="en-US" sz="1050" dirty="0"/>
+          </a:p>
+        </p:txBody>
+      </p:sp>
+      <p:sp>
+        <p:nvSpPr>
+          <p:cNvPr id="7" name="Text 3"/>
+          <p:cNvSpPr/>
+          <p:nvPr/>
+        </p:nvSpPr>
+        <p:spPr>
+          <a:xfrm>
+            <a:off x="457200" y="6510528"/>
+            <a:ext cx="4572000" cy="237744"/>
+          </a:xfrm>
+          <a:prstGeom prst="rect">
+            <a:avLst/>
+          </a:prstGeom>
+          <a:noFill/>
+          <a:ln/>
+        </p:spPr>
+        <p:txBody>
+          <a:bodyPr wrap="square" lIns="0" tIns="0" rIns="0" bIns="0" rtlCol="0" anchor="ctr"/>
+          <a:lstStyle/>
+          <a:p>
+            <a:pPr indent="0" marL="0">
+              <a:buNone/>
+            </a:pPr>
+            <a:r>
+              <a:rPr lang="en-US" sz="900" dirty="0">
+                <a:solidFill>
+                  <a:srgbClr val="8291A6"/>
+                </a:solidFill>
+                <a:latin typeface="Inter" pitchFamily="34" charset="0"/>
+                <a:ea typeface="Inter" pitchFamily="34" charset="-122"/>
+                <a:cs typeface="Inter" pitchFamily="34" charset="-120"/>
+              </a:rPr>
+              <a:t>SiKePo · Healthkathon BPJS Kesehatan 2026</a:t>
+            </a:r>
+            <a:endParaRPr lang="en-US" sz="900" dirty="0"/>
+          </a:p>
+        </p:txBody>
+      </p:sp>
+      <p:sp>
+        <p:nvSpPr>
+          <p:cNvPr id="8" name="Text 4"/>
+          <p:cNvSpPr/>
+          <p:nvPr/>
+        </p:nvSpPr>
+        <p:spPr>
+          <a:xfrm>
+            <a:off x="11274552" y="6510528"/>
+            <a:ext cx="457200" cy="237744"/>
+          </a:xfrm>
+          <a:prstGeom prst="rect">
+            <a:avLst/>
+          </a:prstGeom>
+          <a:noFill/>
+          <a:ln/>
+        </p:spPr>
+        <p:txBody>
+          <a:bodyPr wrap="square" lIns="0" tIns="0" rIns="0" bIns="0" rtlCol="0" anchor="ctr"/>
+          <a:lstStyle/>
+          <a:p>
+            <a:pPr algn="r" indent="0" marL="0">
+              <a:buNone/>
+            </a:pPr>
+            <a:r>
+              <a:rPr lang="en-US" sz="900" dirty="0">
+                <a:solidFill>
+                  <a:srgbClr val="8291A6"/>
+                </a:solidFill>
+                <a:latin typeface="JetBrains Mono" pitchFamily="34" charset="0"/>
+                <a:ea typeface="JetBrains Mono" pitchFamily="34" charset="-122"/>
+                <a:cs typeface="JetBrains Mono" pitchFamily="34" charset="-120"/>
+              </a:rPr>
+              <a:t>14</a:t>
+            </a:r>
+            <a:endParaRPr lang="en-US" sz="900" dirty="0"/>
+          </a:p>
+        </p:txBody>
+      </p:sp>
+    </p:spTree>
+  </p:cSld>
+  <p:clrMapOvr>
+    <a:masterClrMapping/>
+  </p:clrMapOvr>
+</p:sld>
+</file>
+
+<file path=ppt/slides/slide15.xml><?xml version="1.0" encoding="utf-8"?>
+<p:sld xmlns:a="http://schemas.openxmlformats.org/drawingml/2006/main" xmlns:r="http://schemas.openxmlformats.org/officeDocument/2006/relationships" xmlns:p="http://schemas.openxmlformats.org/presentationml/2006/main">
+  <p:cSld name="Slide 15">
     <p:bg>
       <p:bgPr>
         <a:solidFill>
@@ -7397,7 +9933,7 @@
                 <a:ea typeface="Inter" pitchFamily="34" charset="-122"/>
                 <a:cs typeface="Inter" pitchFamily="34" charset="-120"/>
               </a:rPr>
-              <a:t>deckafadhila@gmail.com · decka.xyz</a:t>
+              <a:t>deckafadhila@gmail.com · dktirta.tech</a:t>
             </a:r>
             <a:endParaRPr lang="en-US" sz="1300" dirty="0"/>
           </a:p>
@@ -7411,7 +9947,46 @@
         </p:nvSpPr>
         <p:spPr>
           <a:xfrm>
-            <a:off x="457200" y="6263640"/>
+            <a:off x="457200" y="6053328"/>
+            <a:ext cx="11247120" cy="274320"/>
+          </a:xfrm>
+          <a:prstGeom prst="rect">
+            <a:avLst/>
+          </a:prstGeom>
+          <a:noFill/>
+          <a:ln/>
+        </p:spPr>
+        <p:txBody>
+          <a:bodyPr wrap="square" lIns="0" tIns="0" rIns="0" bIns="0" rtlCol="0" anchor="ctr"/>
+          <a:lstStyle/>
+          <a:p>
+            <a:pPr indent="0" marL="0">
+              <a:buNone/>
+            </a:pPr>
+            <a:r>
+              <a:rPr lang="en-US" sz="1050" dirty="0">
+                <a:solidFill>
+                  <a:srgbClr val="64809F"/>
+                </a:solidFill>
+                <a:latin typeface="Inter" pitchFamily="34" charset="0"/>
+                <a:ea typeface="Inter" pitchFamily="34" charset="-122"/>
+                <a:cs typeface="Inter" pitchFamily="34" charset="-120"/>
+              </a:rPr>
+              <a:t>Disclaimer: seluruh angka dan data yang ditampilkan berasal dari dataset demo sintetis, bukan data operasional BPJS Kesehatan.</a:t>
+            </a:r>
+            <a:endParaRPr lang="en-US" sz="1050" dirty="0"/>
+          </a:p>
+        </p:txBody>
+      </p:sp>
+      <p:sp>
+        <p:nvSpPr>
+          <p:cNvPr id="9" name="Text 6"/>
+          <p:cNvSpPr/>
+          <p:nvPr/>
+        </p:nvSpPr>
+        <p:spPr>
+          <a:xfrm>
+            <a:off x="457200" y="6355080"/>
             <a:ext cx="7315200" cy="274320"/>
           </a:xfrm>
           <a:prstGeom prst="rect">
@@ -7668,7 +10243,7 @@
                 <a:ea typeface="Inter" pitchFamily="34" charset="-122"/>
                 <a:cs typeface="Inter" pitchFamily="34" charset="-120"/>
               </a:rPr>
-              <a:t>Empat sub-kategori fokus, semuanya dideteksi otomatis oleh SiKePo:</a:t>
+              <a:t>Sub-kategori fokus (nomor sesuai daftar resmi panitia), dideteksi otomatis oleh SiKePo:</a:t>
             </a:r>
             <a:endParaRPr lang="en-US" sz="1350" dirty="0"/>
           </a:p>
@@ -7741,7 +10316,7 @@
                 <a:ea typeface="Plus Jakarta Sans" pitchFamily="34" charset="-122"/>
                 <a:cs typeface="Plus Jakarta Sans" pitchFamily="34" charset="-120"/>
               </a:rPr>
-              <a:t>Upcoding &amp; Unbundling</a:t>
+              <a:t>No. 4 · Upcoding</a:t>
             </a:r>
             <a:endParaRPr lang="en-US" sz="1450" dirty="0"/>
           </a:p>
@@ -7783,7 +10358,7 @@
                 <a:ea typeface="Inter" pitchFamily="34" charset="-122"/>
                 <a:cs typeface="Inter" pitchFamily="34" charset="-120"/>
               </a:rPr>
-              <a:t>Diagnosa digelembungkan agar tarif masuk kelas INA-CBG yang lebih mahal, atau paket dipecah.</a:t>
+              <a:t>Manipulasi diagnosis dan/atau tindakan untuk meningkatkan besaran klaim.</a:t>
             </a:r>
             <a:endParaRPr lang="en-US" sz="1150" dirty="0"/>
           </a:p>
@@ -7895,7 +10470,7 @@
                 <a:ea typeface="Plus Jakarta Sans" pitchFamily="34" charset="-122"/>
                 <a:cs typeface="Plus Jakarta Sans" pitchFamily="34" charset="-120"/>
               </a:rPr>
-              <a:t>Phantom &amp; Repeat Billing</a:t>
+              <a:t>No. 6 · Phantom billing</a:t>
             </a:r>
             <a:endParaRPr lang="en-US" sz="1450" dirty="0"/>
           </a:p>
@@ -7937,7 +10512,7 @@
                 <a:ea typeface="Inter" pitchFamily="34" charset="-122"/>
                 <a:cs typeface="Inter" pitchFamily="34" charset="-120"/>
               </a:rPr>
-              <a:t>Penagihan atas layanan yang tidak pernah diberikan atau episode yang diklaim ulang.</a:t>
+              <a:t>Klaim atas layanan yang tidak pernah diberikan kepada pasien.</a:t>
             </a:r>
             <a:endParaRPr lang="en-US" sz="1150" dirty="0"/>
           </a:p>
@@ -8049,7 +10624,7 @@
                 <a:ea typeface="Plus Jakarta Sans" pitchFamily="34" charset="-122"/>
                 <a:cs typeface="Plus Jakarta Sans" pitchFamily="34" charset="-120"/>
               </a:rPr>
-              <a:t>Inflated Bills &amp; Cloning</a:t>
+              <a:t>No. 7 · Inflated bills</a:t>
             </a:r>
             <a:endParaRPr lang="en-US" sz="1450" dirty="0"/>
           </a:p>
@@ -8091,7 +10666,7 @@
                 <a:ea typeface="Inter" pitchFamily="34" charset="-122"/>
                 <a:cs typeface="Inter" pitchFamily="34" charset="-120"/>
               </a:rPr>
-              <a:t>Obat di luar formularium dengan harga tinggi; resume medis dijiplak antar pasien.</a:t>
+              <a:t>Biaya obat/alkes ditagih lebih besar dari biaya sebenarnya.</a:t>
             </a:r>
             <a:endParaRPr lang="en-US" sz="1150" dirty="0"/>
           </a:p>
@@ -8130,7 +10705,7 @@
                 <a:ea typeface="JetBrains Mono" pitchFamily="34" charset="-122"/>
                 <a:cs typeface="JetBrains Mono" pitchFamily="34" charset="-120"/>
               </a:rPr>
-              <a:t>19 kasus · kemiripan resume tinggi</a:t>
+              <a:t>19 kasus · obat di luar e-Fornas</a:t>
             </a:r>
             <a:endParaRPr lang="en-US" sz="1000" dirty="0"/>
           </a:p>
@@ -8203,7 +10778,7 @@
                 <a:ea typeface="Plus Jakarta Sans" pitchFamily="34" charset="-122"/>
                 <a:cs typeface="Plus Jakarta Sans" pitchFamily="34" charset="-120"/>
               </a:rPr>
-              <a:t>Prolonged Stay &amp; Readmisi</a:t>
+              <a:t>No. 5 · Cloning</a:t>
             </a:r>
             <a:endParaRPr lang="en-US" sz="1450" dirty="0"/>
           </a:p>
@@ -8245,7 +10820,7 @@
                 <a:ea typeface="Inter" pitchFamily="34" charset="-122"/>
                 <a:cs typeface="Inter" pitchFamily="34" charset="-120"/>
               </a:rPr>
-              <a:t>Hari rawat diperpanjang di luar indikasi medis atau episode diklaim berulang.</a:t>
+              <a:t>Klaim dibuat dengan menyalin klaim atau rekam medis pasien lain.</a:t>
             </a:r>
             <a:endParaRPr lang="en-US" sz="1150" dirty="0"/>
           </a:p>
@@ -8284,7 +10859,7 @@
                 <a:ea typeface="JetBrains Mono" pitchFamily="34" charset="-122"/>
                 <a:cs typeface="JetBrains Mono" pitchFamily="34" charset="-120"/>
               </a:rPr>
-              <a:t>LOS vs norma klinis dipantau per klaim</a:t>
+              <a:t>8 kasus · kemiripan resume tinggi</a:t>
             </a:r>
             <a:endParaRPr lang="en-US" sz="1000" dirty="0"/>
           </a:p>
@@ -8323,7 +10898,7 @@
                 <a:ea typeface="Inter" pitchFamily="34" charset="-122"/>
                 <a:cs typeface="Inter" pitchFamily="34" charset="-120"/>
               </a:rPr>
-              <a:t>Kasus = sebaran modus pada dataset 150 klaim yang dipakai membangun dan menguji SiKePo.</a:t>
+              <a:t>Cakupan lanjutan: prolonged length of stay (No. 12), readmisi (No. 16), repeat billing (No. 11), dan unbundling/fragmentasi (No. 9) dipantau melalui pemeriksaan LOS dan pola episode. Kasus = sebaran modus pada dataset 150 klaim uji.</a:t>
             </a:r>
             <a:endParaRPr lang="en-US" sz="950" dirty="0"/>
           </a:p>
@@ -13273,7 +15848,7 @@
                 <a:ea typeface="Inter" pitchFamily="34" charset="-122"/>
                 <a:cs typeface="Inter" pitchFamily="34" charset="-120"/>
               </a:rPr>
-              <a:t>A1 rules (risiko awal 0-99) → A2 IsolationForest (fusi 45:55) → A3 LLM medis + fallback aturan</a:t>
+              <a:t>A1 rules (risiko awal 0-99) → A2 IsolationForest (fusi 45:55) → A3 LLM medis Ling 3.0 Flash Sante + fallback aturan</a:t>
             </a:r>
             <a:endParaRPr lang="en-US" sz="1200" dirty="0"/>
           </a:p>

</xml_diff>

<commit_message>
style: revisi bahasa EYD/KBBI + perampingan teks seluruh slide
</commit_message>
<xml_diff>
--- a/proposal/Proposal_SiKePo_Healthkathon2026.pptx
+++ b/proposal/Proposal_SiKePo_Healthkathon2026.pptx
@@ -2348,7 +2348,7 @@
                 <a:ea typeface="Inter" pitchFamily="34" charset="-122"/>
                 <a:cs typeface="Inter" pitchFamily="34" charset="-120"/>
               </a:rPr>
-              <a:t>Pipeline audit A1 Triage, A2 Investigator, dan A3 Adjudicator bertumpu pada LLM medis Ling 3.0 Flash Sante. Skor risiko 0-100 dengan bukti terbaca, keputusan akhir tetap milik verifikator.</a:t>
+              <a:t>Pipeline A1 Triage, A2 Investigator, dan A3 Adjudicator menilai setiap klaim dalam hitungan detik. Skor risiko 0–100 disertai bukti yang dapat dibaca; keputusan akhir tetap milik verifikator.</a:t>
             </a:r>
             <a:endParaRPr lang="en-US" sz="1350" dirty="0"/>
           </a:p>
@@ -2770,7 +2770,7 @@
                 <a:ea typeface="Inter" pitchFamily="34" charset="-122"/>
                 <a:cs typeface="Inter" pitchFamily="34" charset="-120"/>
               </a:rPr>
-              <a:t>PostgreSQL + container Docker</a:t>
+              <a:t>PostgreSQL dan Docker</a:t>
             </a:r>
             <a:endParaRPr lang="en-US" sz="1050" dirty="0"/>
           </a:p>
@@ -2794,7 +2794,7 @@
                 <a:ea typeface="Inter" pitchFamily="34" charset="-122"/>
                 <a:cs typeface="Inter" pitchFamily="34" charset="-120"/>
               </a:rPr>
-              <a:t>Pemindahan seluruh API dari file ke DB</a:t>
+              <a:t>Seluruh API dipindah ke database</a:t>
             </a:r>
             <a:endParaRPr lang="en-US" sz="1050" dirty="0"/>
           </a:p>
@@ -2818,7 +2818,7 @@
                 <a:ea typeface="Inter" pitchFamily="34" charset="-122"/>
                 <a:cs typeface="Inter" pitchFamily="34" charset="-120"/>
               </a:rPr>
-              <a:t>Penguatan keamanan: minimasi PII, backup</a:t>
+              <a:t>Penguatan keamanan dan pencadangan</a:t>
             </a:r>
             <a:endParaRPr lang="en-US" sz="1050" dirty="0"/>
           </a:p>
@@ -2883,7 +2883,7 @@
                 <a:ea typeface="Inter" pitchFamily="34" charset="-122"/>
                 <a:cs typeface="Inter" pitchFamily="34" charset="-120"/>
               </a:rPr>
-              <a:t>Deliverable: versi production-ready internal</a:t>
+              <a:t>Hasil: versi siap produksi internal</a:t>
             </a:r>
             <a:endParaRPr lang="en-US" sz="1000" dirty="0"/>
           </a:p>
@@ -3083,7 +3083,7 @@
                 <a:ea typeface="Inter" pitchFamily="34" charset="-122"/>
                 <a:cs typeface="Inter" pitchFamily="34" charset="-120"/>
               </a:rPr>
-              <a:t>Berjalan di 1 KC mode bayangan</a:t>
+              <a:t>Mode bayangan di satu KC</a:t>
             </a:r>
             <a:endParaRPr lang="en-US" sz="1050" dirty="0"/>
           </a:p>
@@ -3131,7 +3131,7 @@
                 <a:ea typeface="Inter" pitchFamily="34" charset="-122"/>
                 <a:cs typeface="Inter" pitchFamily="34" charset="-120"/>
               </a:rPr>
-              <a:t>Ukur presisi/recall per modus fraud</a:t>
+              <a:t>Mengukur presisi dan recall per modus</a:t>
             </a:r>
             <a:endParaRPr lang="en-US" sz="1050" dirty="0"/>
           </a:p>
@@ -3196,7 +3196,7 @@
                 <a:ea typeface="Inter" pitchFamily="34" charset="-122"/>
                 <a:cs typeface="Inter" pitchFamily="34" charset="-120"/>
               </a:rPr>
-              <a:t>Deliverable: laporan evaluasi 4 minggu</a:t>
+              <a:t>Hasil: laporan evaluasi empat pekan</a:t>
             </a:r>
             <a:endParaRPr lang="en-US" sz="1000" dirty="0"/>
           </a:p>
@@ -3396,7 +3396,7 @@
                 <a:ea typeface="Inter" pitchFamily="34" charset="-122"/>
                 <a:cs typeface="Inter" pitchFamily="34" charset="-120"/>
               </a:rPr>
-              <a:t>Klaim hijau lanjut otomatis di 1 KC</a:t>
+              <a:t>Klaim hijau lanjut otomatis di satu KC</a:t>
             </a:r>
             <a:endParaRPr lang="en-US" sz="1050" dirty="0"/>
           </a:p>
@@ -3420,7 +3420,7 @@
                 <a:ea typeface="Inter" pitchFamily="34" charset="-122"/>
                 <a:cs typeface="Inter" pitchFamily="34" charset="-120"/>
               </a:rPr>
-              <a:t>SOP + pelatihan verifikator</a:t>
+              <a:t>SOP dan pelatihan verifikator</a:t>
             </a:r>
             <a:endParaRPr lang="en-US" sz="1050" dirty="0"/>
           </a:p>
@@ -3444,7 +3444,7 @@
                 <a:ea typeface="Inter" pitchFamily="34" charset="-122"/>
                 <a:cs typeface="Inter" pitchFamily="34" charset="-120"/>
               </a:rPr>
-              <a:t>Rollback plan &lt; 15 menit</a:t>
+              <a:t>Rencana mundur di bawah 15 menit</a:t>
             </a:r>
             <a:endParaRPr lang="en-US" sz="1050" dirty="0"/>
           </a:p>
@@ -3509,7 +3509,7 @@
                 <a:ea typeface="Inter" pitchFamily="34" charset="-122"/>
                 <a:cs typeface="Inter" pitchFamily="34" charset="-120"/>
               </a:rPr>
-              <a:t>Deliverable: 1 KC beroperasi dengan SiKePo</a:t>
+              <a:t>Hasil: satu KC beroperasi dengan SiKePo</a:t>
             </a:r>
             <a:endParaRPr lang="en-US" sz="1000" dirty="0"/>
           </a:p>
@@ -3709,7 +3709,7 @@
                 <a:ea typeface="Inter" pitchFamily="34" charset="-122"/>
                 <a:cs typeface="Inter" pitchFamily="34" charset="-120"/>
               </a:rPr>
-              <a:t>Perluasan KC + onboarding SIMRS</a:t>
+              <a:t>Perluasan KC dan onboarding SIMRS</a:t>
             </a:r>
             <a:endParaRPr lang="en-US" sz="1050" dirty="0"/>
           </a:p>
@@ -3733,7 +3733,7 @@
                 <a:ea typeface="Inter" pitchFamily="34" charset="-122"/>
                 <a:cs typeface="Inter" pitchFamily="34" charset="-120"/>
               </a:rPr>
-              <a:t>Dashboard analitik nasional</a:t>
+              <a:t>Dasbor analitik nasional</a:t>
             </a:r>
             <a:endParaRPr lang="en-US" sz="1050" dirty="0"/>
           </a:p>
@@ -3822,7 +3822,7 @@
                 <a:ea typeface="Inter" pitchFamily="34" charset="-122"/>
                 <a:cs typeface="Inter" pitchFamily="34" charset="-120"/>
               </a:rPr>
-              <a:t>Deliverable: laporan dampak kuartalan</a:t>
+              <a:t>Hasil: laporan dampak triwulanan</a:t>
             </a:r>
             <a:endParaRPr lang="en-US" sz="1000" dirty="0"/>
           </a:p>
@@ -3861,7 +3861,7 @@
                 <a:ea typeface="Inter" pitchFamily="34" charset="-122"/>
                 <a:cs typeface="Inter" pitchFamily="34" charset="-120"/>
               </a:rPr>
-              <a:t>Sumber daya: 1-3 orang tim + akses data uji terbatas berizin; kebutuhan utama berupa satu KC mitra untuk fase pilot shadow.</a:t>
+              <a:t>Kebutuhan utama: satu KC mitra untuk pilot shadow, dengan akses data uji terbatas berizin.</a:t>
             </a:r>
             <a:endParaRPr lang="en-US" sz="1050" dirty="0"/>
           </a:p>
@@ -4371,7 +4371,7 @@
                           <a:ea typeface="Inter" pitchFamily="34" charset="-122"/>
                           <a:cs typeface="Inter" pitchFamily="34" charset="-120"/>
                         </a:rPr>
-                        <a:t>Sampling sebagian berkas</a:t>
+                        <a:t>Hanya sampel berkas</a:t>
                       </a:r>
                       <a:endParaRPr lang="en-US" sz="1150" dirty="0">
                         <a:latin typeface="Inter" charset="0"/>
@@ -4436,7 +4436,7 @@
                           <a:ea typeface="Inter" pitchFamily="34" charset="-122"/>
                           <a:cs typeface="Inter" pitchFamily="34" charset="-120"/>
                         </a:rPr>
-                        <a:t>100% klaim dibaca mesin sebelum cair</a:t>
+                        <a:t>Seluruh klaim dibaca mesin</a:t>
                       </a:r>
                       <a:endParaRPr lang="en-US" sz="1150" dirty="0">
                         <a:latin typeface="Inter" charset="0"/>
@@ -4503,7 +4503,7 @@
                           <a:ea typeface="Inter" pitchFamily="34" charset="-122"/>
                           <a:cs typeface="Inter" pitchFamily="34" charset="-120"/>
                         </a:rPr>
-                        <a:t>Waktu penilaian per berkas</a:t>
+                        <a:t>Waktu penilaian</a:t>
                       </a:r>
                       <a:endParaRPr lang="en-US" sz="1150" dirty="0">
                         <a:latin typeface="Inter" charset="0"/>
@@ -4568,7 +4568,7 @@
                           <a:ea typeface="Inter" pitchFamily="34" charset="-122"/>
                           <a:cs typeface="Inter" pitchFamily="34" charset="-120"/>
                         </a:rPr>
-                        <a:t>Belasan menit hingga jam</a:t>
+                        <a:t>Belasan menit atau lebih</a:t>
                       </a:r>
                       <a:endParaRPr lang="en-US" sz="1150" dirty="0">
                         <a:latin typeface="Inter" charset="0"/>
@@ -4633,7 +4633,7 @@
                           <a:ea typeface="Inter" pitchFamily="34" charset="-122"/>
                           <a:cs typeface="Inter" pitchFamily="34" charset="-120"/>
                         </a:rPr>
-                        <a:t>&lt; 2 detik per klaim (terukur pada demo)</a:t>
+                        <a:t>Kurang dari 2 detik (terukur)</a:t>
                       </a:r>
                       <a:endParaRPr lang="en-US" sz="1150" dirty="0">
                         <a:latin typeface="Inter" charset="0"/>
@@ -4765,7 +4765,7 @@
                           <a:ea typeface="Inter" pitchFamily="34" charset="-122"/>
                           <a:cs typeface="Inter" pitchFamily="34" charset="-120"/>
                         </a:rPr>
-                        <a:t>Subjektif antar pemeriksa</a:t>
+                        <a:t>Bervariasi antarpemeriksa</a:t>
                       </a:r>
                       <a:endParaRPr lang="en-US" sz="1150" dirty="0">
                         <a:latin typeface="Inter" charset="0"/>
@@ -4830,7 +4830,7 @@
                           <a:ea typeface="Inter" pitchFamily="34" charset="-122"/>
                           <a:cs typeface="Inter" pitchFamily="34" charset="-120"/>
                         </a:rPr>
-                        <a:t>Skor 0-100 + alasan per tahap, konsisten</a:t>
+                        <a:t>Skor 0–100 dan alasan yang konsisten</a:t>
                       </a:r>
                       <a:endParaRPr lang="en-US" sz="1150" dirty="0">
                         <a:latin typeface="Inter" charset="0"/>
@@ -4962,7 +4962,7 @@
                           <a:ea typeface="Inter" pitchFamily="34" charset="-122"/>
                           <a:cs typeface="Inter" pitchFamily="34" charset="-120"/>
                         </a:rPr>
-                        <a:t>Catatan manual, tersebar</a:t>
+                        <a:t>Catatan manual dan tersebar</a:t>
                       </a:r>
                       <a:endParaRPr lang="en-US" sz="1150" dirty="0">
                         <a:latin typeface="Inter" charset="0"/>
@@ -5027,7 +5027,7 @@
                           <a:ea typeface="Inter" pitchFamily="34" charset="-122"/>
                           <a:cs typeface="Inter" pitchFamily="34" charset="-120"/>
                         </a:rPr>
-                        <a:t>Tersimpan otomatis per verdict, immutable</a:t>
+                        <a:t>Tersimpan otomatis per verdict</a:t>
                       </a:r>
                       <a:endParaRPr lang="en-US" sz="1150" dirty="0">
                         <a:latin typeface="Inter" charset="0"/>
@@ -5094,7 +5094,7 @@
                           <a:ea typeface="Inter" pitchFamily="34" charset="-122"/>
                           <a:cs typeface="Inter" pitchFamily="34" charset="-120"/>
                         </a:rPr>
-                        <a:t>Deteksi pola baru</a:t>
+                        <a:t>Deteksi pola</a:t>
                       </a:r>
                       <a:endParaRPr lang="en-US" sz="1150" dirty="0">
                         <a:latin typeface="Inter" charset="0"/>
@@ -5224,7 +5224,7 @@
                           <a:ea typeface="Inter" pitchFamily="34" charset="-122"/>
                           <a:cs typeface="Inter" pitchFamily="34" charset="-120"/>
                         </a:rPr>
-                        <a:t>ML ter-retrain dari label verdict terbaru</a:t>
+                        <a:t>Model dilatih ulang dari verdict terbaru</a:t>
                       </a:r>
                       <a:endParaRPr lang="en-US" sz="1150" dirty="0">
                         <a:latin typeface="Inter" charset="0"/>
@@ -5413,7 +5413,7 @@
                 <a:ea typeface="Inter" pitchFamily="34" charset="-122"/>
                 <a:cs typeface="Inter" pitchFamily="34" charset="-120"/>
               </a:rPr>
-              <a:t>Iuran terjaga dari kebocoran; layak-dapat layak-bayar</a:t>
+              <a:t>Iuran terjaga dari kebocoran dana</a:t>
             </a:r>
             <a:endParaRPr lang="en-US" sz="1050" dirty="0"/>
           </a:p>
@@ -5516,7 +5516,7 @@
                 <a:ea typeface="Inter" pitchFamily="34" charset="-122"/>
                 <a:cs typeface="Inter" pitchFamily="34" charset="-120"/>
               </a:rPr>
-              <a:t>Klaim bersih cair lebih cepat; bukti objektif saat diaudit</a:t>
+              <a:t>Klaim bersih cair lebih cepat dan bukti objektif</a:t>
             </a:r>
             <a:endParaRPr lang="en-US" sz="1050" dirty="0"/>
           </a:p>
@@ -5619,7 +5619,7 @@
                 <a:ea typeface="Inter" pitchFamily="34" charset="-122"/>
                 <a:cs typeface="Inter" pitchFamily="34" charset="-120"/>
               </a:rPr>
-              <a:t>Efisiensi risiko terukur dan jejak audit kuartalan</a:t>
+              <a:t>Efisiensi risiko terukur tiap triwulan</a:t>
             </a:r>
             <a:endParaRPr lang="en-US" sz="1050" dirty="0"/>
           </a:p>
@@ -5658,7 +5658,7 @@
                 <a:ea typeface="Inter" pitchFamily="34" charset="-122"/>
                 <a:cs typeface="Inter" pitchFamily="34" charset="-120"/>
               </a:rPr>
-              <a:t>Dampak berbasis demo internal (150 klaim); angka lapangan divalidasi saat pilot shadow. Waktu &lt; 2 detik diukur dari latency endpoint audit.</a:t>
+              <a:t>Catatan: dampak diukur pada demo internal (150 klaim); angka lapangan divalidasi saat pilot. Waktu kurang dari 2 detik diukur dari latensi endpoint audit.</a:t>
             </a:r>
             <a:endParaRPr lang="en-US" sz="950" dirty="0"/>
           </a:p>
@@ -5961,7 +5961,7 @@
                 <a:ea typeface="Inter" pitchFamily="34" charset="-122"/>
                 <a:cs typeface="Inter" pitchFamily="34" charset="-120"/>
               </a:rPr>
-              <a:t>Saat ini memakai 150 klaim sintetis, tanpa data peserta riil. Password ber-hash PBKDF2, sesi terkelola, RBAC 4 peran, jejak audit per keputusan. Produksi: minimasi PII, enkripsi at-rest, perjanjian kerahasiaan.</a:t>
+              <a:t>Memakai 150 klaim sintetis, tanpa data peserta riil. Kata sandi berhash PBKDF2, RBAC empat peran, dan jejak audit per keputusan. Produksi: minimasi data pribadi dan enkripsi.</a:t>
             </a:r>
             <a:endParaRPr lang="en-US" sz="1150" dirty="0"/>
           </a:p>
@@ -6076,7 +6076,7 @@
                 <a:ea typeface="Inter" pitchFamily="34" charset="-122"/>
                 <a:cs typeface="Inter" pitchFamily="34" charset="-120"/>
               </a:rPr>
-              <a:t>IsolationForest bisa keliru pada kasus langka; LLM dapat keliru memahami konteks. Mitigasi: skor adalah fusi aturan + ML, threshold konservatif, retrain berkala dari label verdict, dan semua alasan tampil untuk bisa dibantah.</a:t>
+              <a:t>Model dapat keliru pada kasus langka. Mitigasi: skor merupakan gabungan aturan dan ML, ambang konservatif, pelatihan ulang berkala, serta alasan yang terbuka untuk dibantah.</a:t>
             </a:r>
             <a:endParaRPr lang="en-US" sz="1150" dirty="0"/>
           </a:p>
@@ -6191,7 +6191,7 @@
                 <a:ea typeface="Inter" pitchFamily="34" charset="-122"/>
                 <a:cs typeface="Inter" pitchFamily="34" charset="-120"/>
               </a:rPr>
-              <a:t>Mesin hanya memberi rekomendasi berstatus; klaim berisiko wajib melewati verifikator, eskalasi ke Satgas Anti-Fraud, dan setiap perubahan verdict manusia tercatat namanya.</a:t>
+              <a:t>Mesin hanya memberi rekomendasi. Klaim berisiko wajib melewati verifikator dan eskalasi Satgas Anti-Fraud; setiap perubahan keputusan tercatat.</a:t>
             </a:r>
             <a:endParaRPr lang="en-US" sz="1150" dirty="0"/>
           </a:p>
@@ -6306,7 +6306,7 @@
                 <a:ea typeface="Inter" pitchFamily="34" charset="-122"/>
                 <a:cs typeface="Inter" pitchFamily="34" charset="-120"/>
               </a:rPr>
-              <a:t>1) LLM gagal: fallback aturan deterministik menjaga layanan. 2) Kunci API bocor: rotasi per faskes + rate limit. 3) Faskes jujur tertolak: threshold konservatif + evaluasi pilot sebelum enforcement.</a:t>
+              <a:t>1) LLM gagal: fallback aturan menjaga layanan. 2) Kunci API bocor: rotasi per faskes dan rate limit. 3) Faskes jujur tertolak: ambang konservatif dan evaluasi pilot.</a:t>
             </a:r>
             <a:endParaRPr lang="en-US" sz="1150" dirty="0"/>
           </a:p>
@@ -6345,7 +6345,7 @@
                 <a:ea typeface="Inter" pitchFamily="34" charset="-122"/>
                 <a:cs typeface="Inter" pitchFamily="34" charset="-120"/>
               </a:rPr>
-              <a:t>Prinsip: transparan soal keterbatasan, tidak memakai data peserta JKN riil tanpa izin resmi, dan setiap klaim tetap dapat dibantah manusia.</a:t>
+              <a:t>Prinsip: transparan tentang keterbatasan, tidak memakai data peserta JKN riil tanpa izin resmi, dan setiap klaim tetap dapat dibantah manusia.</a:t>
             </a:r>
             <a:endParaRPr lang="en-US" sz="1050" dirty="0"/>
           </a:p>
@@ -6791,7 +6791,7 @@
                 <a:ea typeface="Inter" pitchFamily="34" charset="-122"/>
                 <a:cs typeface="Inter" pitchFamily="34" charset="-120"/>
               </a:rPr>
-              <a:t>Backend FastAPI + pipeline AI (rules, IsolationForest, integrasi LLM) dan frontend vanilla JS, tanpa framework berat agar mudah diaudit dan di-deploy.</a:t>
+              <a:t>Backend FastAPI, pipeline AI (aturan, IsolationForest, LLM), dan frontend vanilla JS yang ringan.</a:t>
             </a:r>
             <a:endParaRPr lang="en-US" sz="1150" dirty="0"/>
           </a:p>
@@ -6872,7 +6872,7 @@
                 <a:ea typeface="Inter" pitchFamily="34" charset="-122"/>
                 <a:cs typeface="Inter" pitchFamily="34" charset="-120"/>
               </a:rPr>
-              <a:t>Analisis dinamika atmosfer kejadian banjir Kabupaten Kudus memakai Python pada 10.000+ titik data; asisten lab Fisika Komputasi dan Sistem Digital UNY.</a:t>
+              <a:t>Analisis banjir Kabupaten Kudus dengan Python pada 10.000+ titik data; asisten lab Fisika Komputasi dan Sistem Digital UNY.</a:t>
             </a:r>
             <a:endParaRPr lang="en-US" sz="1150" dirty="0"/>
           </a:p>
@@ -6953,7 +6953,7 @@
                 <a:ea typeface="Inter" pitchFamily="34" charset="-122"/>
                 <a:cs typeface="Inter" pitchFamily="34" charset="-120"/>
               </a:rPr>
-              <a:t>Praktik AI-assisted research dan agent workflow (n8n, knowledge base) yang dipakai langsung dalam pipeline adjudikasi dan dokumen proyek ini.</a:t>
+              <a:t>Praktik riset berbantuan AI dan agent workflow yang dipakai langsung pada pipeline adjudikasi.</a:t>
             </a:r>
             <a:endParaRPr lang="en-US" sz="1150" dirty="0"/>
           </a:p>
@@ -7034,7 +7034,7 @@
                 <a:ea typeface="Inter" pitchFamily="34" charset="-122"/>
                 <a:cs typeface="Inter" pitchFamily="34" charset="-120"/>
               </a:rPr>
-              <a:t>Evaluasi 300+ kampanye proyek Web3 (aktivitas, insentif, protokol); intern BPBD Kabupaten Kudus untuk pemetaan risiko bencana.</a:t>
+              <a:t>Evaluasi 300+ proyek Web3; magang BPBD Kabupaten Kudus untuk pemetaan risiko bencana.</a:t>
             </a:r>
             <a:endParaRPr lang="en-US" sz="1150" dirty="0"/>
           </a:p>
@@ -7109,7 +7109,7 @@
                 <a:ea typeface="Inter" pitchFamily="34" charset="-122"/>
                 <a:cs typeface="Inter" pitchFamily="34" charset="-120"/>
               </a:rPr>
-              <a:t>satu orang menguasai data, AI, backend, dan tampilan, sehingga iterasi dari masukan juri berlangsung cepat tanpa koordinasi antar tim.</a:t>
+              <a:t>satu orang menguasai data, AI, backend, dan antarmuka, sehingga iterasi cepat tanpa koordinasi lintas tim.</a:t>
             </a:r>
             <a:endParaRPr lang="en-US" sz="1150" dirty="0"/>
           </a:p>
@@ -10243,7 +10243,7 @@
                 <a:ea typeface="Inter" pitchFamily="34" charset="-122"/>
                 <a:cs typeface="Inter" pitchFamily="34" charset="-120"/>
               </a:rPr>
-              <a:t>Sub-kategori fokus (nomor sesuai daftar resmi panitia), dideteksi otomatis oleh SiKePo:</a:t>
+              <a:t>Sub-kategori fokus (nomor mengikuti daftar resmi panitia), terdeteksi otomatis oleh SiKePo:</a:t>
             </a:r>
             <a:endParaRPr lang="en-US" sz="1350" dirty="0"/>
           </a:p>
@@ -10358,7 +10358,7 @@
                 <a:ea typeface="Inter" pitchFamily="34" charset="-122"/>
                 <a:cs typeface="Inter" pitchFamily="34" charset="-120"/>
               </a:rPr>
-              <a:t>Manipulasi diagnosis dan/atau tindakan untuk meningkatkan besaran klaim.</a:t>
+              <a:t>Diagnosis atau tindakan dimanipulasi agar nilai klaim meningkat.</a:t>
             </a:r>
             <a:endParaRPr lang="en-US" sz="1150" dirty="0"/>
           </a:p>
@@ -10666,7 +10666,7 @@
                 <a:ea typeface="Inter" pitchFamily="34" charset="-122"/>
                 <a:cs typeface="Inter" pitchFamily="34" charset="-120"/>
               </a:rPr>
-              <a:t>Biaya obat/alkes ditagih lebih besar dari biaya sebenarnya.</a:t>
+              <a:t>Biaya obat dan alkes ditagih melebihi biaya sebenarnya.</a:t>
             </a:r>
             <a:endParaRPr lang="en-US" sz="1150" dirty="0"/>
           </a:p>
@@ -10898,7 +10898,7 @@
                 <a:ea typeface="Inter" pitchFamily="34" charset="-122"/>
                 <a:cs typeface="Inter" pitchFamily="34" charset="-120"/>
               </a:rPr>
-              <a:t>Cakupan lanjutan: prolonged length of stay (No. 12), readmisi (No. 16), repeat billing (No. 11), dan unbundling/fragmentasi (No. 9) dipantau melalui pemeriksaan LOS dan pola episode. Kasus = sebaran modus pada dataset 150 klaim uji.</a:t>
+              <a:t>Cakupan lanjutan: prolonged length of stay (No. 12), readmisi (No. 16), repeat billing (No. 11), dan unbundling/fragmentasi (No. 9) dipantau melalui pemeriksaan LOS dan pola episode. Kasus = sebaran modus pada 150 klaim uji SiKePo.</a:t>
             </a:r>
             <a:endParaRPr lang="en-US" sz="950" dirty="0"/>
           </a:p>
@@ -11162,7 +11162,7 @@
                 <a:ea typeface="Inter" pitchFamily="34" charset="-122"/>
                 <a:cs typeface="Inter" pitchFamily="34" charset="-120"/>
               </a:rPr>
-              <a:t>SiKePo membaca setiap berkas klaim dalam hitungan detik, memberi skor risiko 0-100 beserta bukti yang bisa dibaca, lalu menyerahkan keputusan akhir kepada verifikator.</a:t>
+              <a:t>SiKePo membaca setiap berkas klaim dalam hitungan detik, memberi skor risiko 0–100 beserta bukti yang dapat dibaca, lalu menyerahkan keputusan akhir kepada verifikator.</a:t>
             </a:r>
             <a:endParaRPr lang="en-US" sz="1100" dirty="0"/>
           </a:p>
@@ -11244,7 +11244,7 @@
                 <a:ea typeface="Inter" pitchFamily="34" charset="-122"/>
                 <a:cs typeface="Inter" pitchFamily="34" charset="-120"/>
               </a:rPr>
-              <a:t>Bukan alat laporan sesudah kejadian: audit berjalan di dalam alur klaim, sebelum dana cair.</a:t>
+              <a:t>Audit berjalan di dalam alur klaim, sebelum dana cair.</a:t>
             </a:r>
             <a:endParaRPr lang="en-US" sz="1300" dirty="0"/>
           </a:p>
@@ -11265,7 +11265,7 @@
                 <a:ea typeface="Inter" pitchFamily="34" charset="-122"/>
                 <a:cs typeface="Inter" pitchFamily="34" charset="-120"/>
               </a:rPr>
-              <a:t>Bukan kotak hitam: setiap skor disertai alasan deterministik, bukti ML, dan rekomendasi berbahasa Indonesia.</a:t>
+              <a:t>Setiap skor disertai alasan yang dapat dibaca dan diaudit.</a:t>
             </a:r>
             <a:endParaRPr lang="en-US" sz="1300" dirty="0"/>
           </a:p>
@@ -11286,7 +11286,7 @@
                 <a:ea typeface="Inter" pitchFamily="34" charset="-122"/>
                 <a:cs typeface="Inter" pitchFamily="34" charset="-120"/>
               </a:rPr>
-              <a:t>Bukan pengganti manusia: AI memberi rekomendasi, verifikator yang memutuskan.</a:t>
+              <a:t>AI memberi rekomendasi; verifikator yang memutuskan.</a:t>
             </a:r>
             <a:endParaRPr lang="en-US" sz="1300" dirty="0"/>
           </a:p>
@@ -11683,7 +11683,7 @@
                 <a:ea typeface="Inter" pitchFamily="34" charset="-122"/>
                 <a:cs typeface="Inter" pitchFamily="34" charset="-120"/>
               </a:rPr>
-              <a:t>1 orang, peran menyeluruh: konsep, bangun, uji, dan rancang skala.</a:t>
+              <a:t>1 orang, peran menyeluruh: konsep, pembangunan, pengujian, dan perancangan skala.</a:t>
             </a:r>
             <a:endParaRPr lang="en-US" sz="1050" dirty="0"/>
           </a:p>
@@ -11986,7 +11986,7 @@
                 <a:ea typeface="Inter" pitchFamily="34" charset="-122"/>
                 <a:cs typeface="Inter" pitchFamily="34" charset="-120"/>
               </a:rPr>
-              <a:t>kerugian akibat klaim fraudulent yang ditemukan BPJS Kesehatan sepanjang 2023</a:t>
+              <a:t>kerugian klaim fraudulent yang ditemukan BPJS Kesehatan pada 2023</a:t>
             </a:r>
             <a:endParaRPr lang="en-US" sz="1100" dirty="0"/>
           </a:p>
@@ -12140,7 +12140,7 @@
                 <a:ea typeface="Inter" pitchFamily="34" charset="-122"/>
                 <a:cs typeface="Inter" pitchFamily="34" charset="-120"/>
               </a:rPr>
-              <a:t>estimasi potensi kebocoran dana JKN per tahun akibat fraudulent claims</a:t>
+              <a:t>estimasi potensi kebocoran dana JKN per tahun</a:t>
             </a:r>
             <a:endParaRPr lang="en-US" sz="1100" dirty="0"/>
           </a:p>
@@ -12294,7 +12294,7 @@
                 <a:ea typeface="Inter" pitchFamily="34" charset="-122"/>
                 <a:cs typeface="Inter" pitchFamily="34" charset="-120"/>
               </a:rPr>
-              <a:t>berkas klaim yang harus ditinjau tiap verifikator setiap hari, secara manual</a:t>
+              <a:t>berkas klaim ditangani manual oleh setiap verifikator setiap hari</a:t>
             </a:r>
             <a:endParaRPr lang="en-US" sz="1100" dirty="0"/>
           </a:p>
@@ -12415,7 +12415,7 @@
                 <a:ea typeface="Inter" pitchFamily="34" charset="-122"/>
                 <a:cs typeface="Inter" pitchFamily="34" charset="-120"/>
               </a:rPr>
-              <a:t>Pemeriksaan manual hanya mampu sampling: mayoritas berkas cair tanpa dibaca menyeluruh.</a:t>
+              <a:t>Pemeriksaan manual hanya mampu mengambil sampel berkas.</a:t>
             </a:r>
             <a:endParaRPr lang="en-US" sz="1300" dirty="0"/>
           </a:p>
@@ -12436,7 +12436,7 @@
                 <a:ea typeface="Inter" pitchFamily="34" charset="-122"/>
                 <a:cs typeface="Inter" pitchFamily="34" charset="-120"/>
               </a:rPr>
-              <a:t>Pola fraud terus berganti (upcoding, phantom, cloning), pemeriksa manual sulit mengikuti konsisten.</a:t>
+              <a:t>Pola fraud terus berubah dan sulit diikuti secara konsisten.</a:t>
             </a:r>
             <a:endParaRPr lang="en-US" sz="1300" dirty="0"/>
           </a:p>
@@ -12457,7 +12457,7 @@
                 <a:ea typeface="Inter" pitchFamily="34" charset="-122"/>
                 <a:cs typeface="Inter" pitchFamily="34" charset="-120"/>
               </a:rPr>
-              <a:t>Dana yang bocor adalah iuran peserta JKN; integritas program bergantung pada kecepatan deteksi.</a:t>
+              <a:t>Dana yang bocor adalah iuran peserta JKN.</a:t>
             </a:r>
             <a:endParaRPr lang="en-US" sz="1300" dirty="0"/>
           </a:p>
@@ -12563,7 +12563,7 @@
                 <a:ea typeface="Inter" pitchFamily="34" charset="-122"/>
                 <a:cs typeface="Inter" pitchFamily="34" charset="-120"/>
               </a:rPr>
-              <a:t>Klaim tidak layak terbayar lebih dulu daripada yang layak
+              <a:t>Klaim tidak layak terbayar lebih dahulu
 </a:t>
             </a:r>
             <a:endParaRPr lang="en-US" sz="1200" dirty="0"/>
@@ -12587,7 +12587,7 @@
                 <a:ea typeface="Inter" pitchFamily="34" charset="-122"/>
                 <a:cs typeface="Inter" pitchFamily="34" charset="-120"/>
               </a:rPr>
-              <a:t>Salah tuduh kepada faskes jujur karena pemeriksaan tidak berbasis bukti</a:t>
+              <a:t>Faskes jujur dapat tertuduh tanpa dasar bukti</a:t>
             </a:r>
             <a:endParaRPr lang="en-US" sz="1200" dirty="0"/>
           </a:p>
@@ -12626,7 +12626,7 @@
                 <a:ea typeface="Inter" pitchFamily="34" charset="-122"/>
                 <a:cs typeface="Inter" pitchFamily="34" charset="-120"/>
               </a:rPr>
-              <a:t>Sumber: publikasi media nasional atas keterangan BPJS Kesehatan dan BPJS Watch; angka bersifat temuan/estimasi, digunakan sebagai konteks urgensi.</a:t>
+              <a:t>Sumber: publikasi media nasional atas keterangan BPJS Kesehatan dan BPJS Watch; angka merupakan temuan atau estimasi.</a:t>
             </a:r>
             <a:endParaRPr lang="en-US" sz="950" dirty="0"/>
           </a:p>
@@ -12971,7 +12971,7 @@
                 <a:ea typeface="Inter" pitchFamily="34" charset="-122"/>
                 <a:cs typeface="Inter" pitchFamily="34" charset="-120"/>
               </a:rPr>
-              <a:t>klaim masuk otomatis via API berkunci</a:t>
+              <a:t>klaim masuk otomatis, berkunci API</a:t>
             </a:r>
             <a:endParaRPr lang="en-US" sz="1000" dirty="0"/>
           </a:p>
@@ -13167,7 +13167,7 @@
                 <a:ea typeface="Inter" pitchFamily="34" charset="-122"/>
                 <a:cs typeface="Inter" pitchFamily="34" charset="-120"/>
               </a:rPr>
-              <a:t>rasio tarif, LOS vs norma, obat e-Fornas</a:t>
+              <a:t>rasio tarif, lama rawat, obat e-Fornas</a:t>
             </a:r>
             <a:endParaRPr lang="en-US" sz="1000" dirty="0"/>
           </a:p>
@@ -13755,7 +13755,7 @@
                 <a:ea typeface="Inter" pitchFamily="34" charset="-122"/>
                 <a:cs typeface="Inter" pitchFamily="34" charset="-120"/>
               </a:rPr>
-              <a:t>Setujui / Tahan / Tolak dengan bukti</a:t>
+              <a:t>Setujui, Tahan, atau Tolak berdasar bukti</a:t>
             </a:r>
             <a:endParaRPr lang="en-US" sz="1000" dirty="0"/>
           </a:p>
@@ -14091,7 +14091,7 @@
                 <a:ea typeface="Inter" pitchFamily="34" charset="-122"/>
                 <a:cs typeface="Inter" pitchFamily="34" charset="-120"/>
               </a:rPr>
-              <a:t>setiap klaim dibaca, bukan sampling; fraud tak lagi lolos karena keumpetan keberuntungan.</a:t>
+              <a:t>Setiap klaim dibaca mesin, bukan sampel.</a:t>
             </a:r>
             <a:endParaRPr lang="en-US" sz="1150" dirty="0"/>
           </a:p>
@@ -14172,7 +14172,7 @@
                 <a:ea typeface="Inter" pitchFamily="34" charset="-122"/>
                 <a:cs typeface="Inter" pitchFamily="34" charset="-120"/>
               </a:rPr>
-              <a:t>rules + ML cepat dan auditable; LLM medis Ling 3.0 Flash Sante hanya untuk adjudikasi, dengan fallback aturan.</a:t>
+              <a:t>Aturan dan ML cepat serta dapat diaudit; LLM hanya untuk adjudikasi.</a:t>
             </a:r>
             <a:endParaRPr lang="en-US" sz="1150" dirty="0"/>
           </a:p>
@@ -14253,7 +14253,7 @@
                 <a:ea typeface="Inter" pitchFamily="34" charset="-122"/>
                 <a:cs typeface="Inter" pitchFamily="34" charset="-120"/>
               </a:rPr>
-              <a:t>verdict satu klik, keyboard-first, sinkron otomatis dari portal faskes; jejak audit terekam per keputusan.</a:t>
+              <a:t>Verdict satu klik; klaim faskes masuk otomatis.</a:t>
             </a:r>
             <a:endParaRPr lang="en-US" sz="1150" dirty="0"/>
           </a:p>
@@ -14571,7 +14571,7 @@
                 <a:ea typeface="Inter" pitchFamily="34" charset="-122"/>
                 <a:cs typeface="Inter" pitchFamily="34" charset="-120"/>
               </a:rPr>
-              <a:t>150 klaim terurut risiko; badge hijau, kuning, merah mengikuti skor 0-100</a:t>
+              <a:t>150 klaim terurut; badge risiko hijau, kuning, merah (skor 0–100)</a:t>
             </a:r>
             <a:endParaRPr lang="en-US" sz="1150" dirty="0"/>
           </a:p>
@@ -14595,7 +14595,7 @@
                 <a:ea typeface="Inter" pitchFamily="34" charset="-122"/>
                 <a:cs typeface="Inter" pitchFamily="34" charset="-120"/>
               </a:rPr>
-              <a:t>Filter status, modus, faskes, rentang risiko, dan pencarian SEP sampai ICD-10</a:t>
+              <a:t>Filter status, modus, faskes, rentang risiko, dan pencarian</a:t>
             </a:r>
             <a:endParaRPr lang="en-US" sz="1150" dirty="0"/>
           </a:p>
@@ -14619,7 +14619,7 @@
                 <a:ea typeface="Inter" pitchFamily="34" charset="-122"/>
                 <a:cs typeface="Inter" pitchFamily="34" charset="-120"/>
               </a:rPr>
-              <a:t>Klik baris: inspector berisi bukti per tahap A1-A3, obat restriksi, dan selisih biaya</a:t>
+              <a:t>Klik baris: inspector memuat bukti A1–A3, obat restriksi, dan selisih biaya</a:t>
             </a:r>
             <a:endParaRPr lang="en-US" sz="1150" dirty="0"/>
           </a:p>
@@ -14643,7 +14643,7 @@
                 <a:ea typeface="Inter" pitchFamily="34" charset="-122"/>
                 <a:cs typeface="Inter" pitchFamily="34" charset="-120"/>
               </a:rPr>
-              <a:t>Verdict satu klik (Setujui / Tahan / Tolak) tersimpan dengan jejak audit</a:t>
+              <a:t>Verdict satu klik dengan jejak audit</a:t>
             </a:r>
             <a:endParaRPr lang="en-US" sz="1150" dirty="0"/>
           </a:p>
@@ -14667,7 +14667,7 @@
                 <a:ea typeface="Inter" pitchFamily="34" charset="-122"/>
                 <a:cs typeface="Inter" pitchFamily="34" charset="-120"/>
               </a:rPr>
-              <a:t>Navigasi keyboard j/k, Enter, a/h/r untuk kerja cepat</a:t>
+              <a:t>Navigasi keyboard: j/k, Enter, a/h/r</a:t>
             </a:r>
             <a:endParaRPr lang="en-US" sz="1150" dirty="0"/>
           </a:p>
@@ -14959,7 +14959,7 @@
                 <a:ea typeface="Inter" pitchFamily="34" charset="-122"/>
                 <a:cs typeface="Inter" pitchFamily="34" charset="-120"/>
               </a:rPr>
-              <a:t>KPI live, tren status, distribusi risiko, rata-rata per faskes, simulator intake SIMRS.</a:t>
+              <a:t>KPI live, tren status, distribusi risiko, dan intake SIMRS.</a:t>
             </a:r>
             <a:endParaRPr lang="en-US" sz="1150" dirty="0"/>
           </a:p>
@@ -15063,7 +15063,7 @@
                 <a:ea typeface="Inter" pitchFamily="34" charset="-122"/>
                 <a:cs typeface="Inter" pitchFamily="34" charset="-120"/>
               </a:rPr>
-              <a:t>Uji klaim hipotesis tanpa menyentuh data: hasil skor, alasan, dan jejak A1-A3.</a:t>
+              <a:t>Uji klaim hipotesis: skor, alasan, dan jejak A1–A3.</a:t>
             </a:r>
             <a:endParaRPr lang="en-US" sz="1150" dirty="0"/>
           </a:p>
@@ -15167,7 +15167,7 @@
                 <a:ea typeface="Inter" pitchFamily="34" charset="-122"/>
                 <a:cs typeface="Inter" pitchFamily="34" charset="-120"/>
               </a:rPr>
-              <a:t>Faskes mengirim klaim ber-kunci API; hasil audit tampil seketika dan masuk antrean.</a:t>
+              <a:t>Faskes mengirim klaim berkunci API; hasil audit tampil seketika.</a:t>
             </a:r>
             <a:endParaRPr lang="en-US" sz="1150" dirty="0"/>
           </a:p>
@@ -15239,7 +15239,7 @@
                 <a:ea typeface="Inter" pitchFamily="34" charset="-122"/>
                 <a:cs typeface="Inter" pitchFamily="34" charset="-120"/>
               </a:rPr>
-              <a:t>klaim yang dikirim faskes muncul sendiri di antrean Cockpit dalam hitungan detik, disertai notifikasi, tanpa reload.</a:t>
+              <a:t>Klaim dari faskes muncul otomatis di antrean Cockpit dalam hitungan detik, disertai notifikasi.</a:t>
             </a:r>
             <a:endParaRPr lang="en-US" sz="1250" dirty="0"/>
           </a:p>
@@ -15597,7 +15597,7 @@
                 <a:ea typeface="Inter" pitchFamily="34" charset="-122"/>
                 <a:cs typeface="Inter" pitchFamily="34" charset="-120"/>
               </a:rPr>
-              <a:t>Data klaim rawat inap: SEP, ICD-10, tarif INA-CBG, biaya, LOS, farmasi</a:t>
+              <a:t>SEP, ICD-10, tarif INA-CBG, biaya, LOS, dan farmasi</a:t>
             </a:r>
             <a:endParaRPr lang="en-US" sz="1200" dirty="0"/>
           </a:p>
@@ -15639,7 +15639,7 @@
                 <a:ea typeface="Inter" pitchFamily="34" charset="-122"/>
                 <a:cs typeface="Inter" pitchFamily="34" charset="-120"/>
               </a:rPr>
-              <a:t>Sumber: SIMRS faskes (API berkunci), Portal Faskes, dataset uji 150 klaim</a:t>
+              <a:t>Sumber: API SIMRS berkunci, Portal Faskes, dan data uji</a:t>
             </a:r>
             <a:endParaRPr lang="en-US" sz="1050" dirty="0"/>
           </a:p>
@@ -15848,7 +15848,7 @@
                 <a:ea typeface="Inter" pitchFamily="34" charset="-122"/>
                 <a:cs typeface="Inter" pitchFamily="34" charset="-120"/>
               </a:rPr>
-              <a:t>A1 rules (risiko awal 0-99) → A2 IsolationForest (fusi 45:55) → A3 LLM medis Ling 3.0 Flash Sante + fallback aturan</a:t>
+              <a:t>A1 aturan (risiko awal) → A2 IsolationForest (fusi 45:55) → A3 Ling 3.0 Flash Sante, dengan fallback aturan</a:t>
             </a:r>
             <a:endParaRPr lang="en-US" sz="1200" dirty="0"/>
           </a:p>
@@ -15890,7 +15890,7 @@
                 <a:ea typeface="Inter" pitchFamily="34" charset="-122"/>
                 <a:cs typeface="Inter" pitchFamily="34" charset="-120"/>
               </a:rPr>
-              <a:t>Setiap tahap menghasilkan bukti yang disimpan per klaim</a:t>
+              <a:t>Setiap tahap menghasilkan bukti yang tersimpan per klaim</a:t>
             </a:r>
             <a:endParaRPr lang="en-US" sz="1050" dirty="0"/>
           </a:p>
@@ -16099,7 +16099,7 @@
                 <a:ea typeface="Inter" pitchFamily="34" charset="-122"/>
                 <a:cs typeface="Inter" pitchFamily="34" charset="-120"/>
               </a:rPr>
-              <a:t>Rekomendasi status + antrean Cockpit + verdict verifikator dengan jejak audit</a:t>
+              <a:t>Rekomendasi status, antrean Cockpit, dan verdict berjejak audit</a:t>
             </a:r>
             <a:endParaRPr lang="en-US" sz="1200" dirty="0"/>
           </a:p>
@@ -16141,7 +16141,7 @@
                 <a:ea typeface="Inter" pitchFamily="34" charset="-122"/>
                 <a:cs typeface="Inter" pitchFamily="34" charset="-120"/>
               </a:rPr>
-              <a:t>Label verdict menjadi data latih retrain berkala</a:t>
+              <a:t>Label verdict menjadi data latih pelatihan ulang berkala</a:t>
             </a:r>
             <a:endParaRPr lang="en-US" sz="1050" dirty="0"/>
           </a:p>
@@ -16213,7 +16213,7 @@
                 <a:ea typeface="Inter" pitchFamily="34" charset="-122"/>
                 <a:cs typeface="Inter" pitchFamily="34" charset="-120"/>
               </a:rPr>
-              <a:t>kunci API per faskes · password PBKDF2 · RBAC 4 peran · rate limit · jejak audit immutable · data uji bersifat sintetis</a:t>
+              <a:t>kunci API per faskes · kata sandi PBKDF2 · RBAC 4 peran · rate limit · jejak audit · data uji sintetis</a:t>
             </a:r>
             <a:endParaRPr lang="en-US" sz="1150" dirty="0"/>
           </a:p>
@@ -16926,7 +16926,7 @@
                 <a:ea typeface="Inter" pitchFamily="34" charset="-122"/>
                 <a:cs typeface="Inter" pitchFamily="34" charset="-120"/>
               </a:rPr>
-              <a:t>Posisi saat ini: Prototype fitur lengkap, dengan jalur jelas menuju MVP lewat pilot shadow di satu KC.</a:t>
+              <a:t>Posisi saat ini: prototype fitur lengkap, dengan jalur jelas menuju MVP melalui pilot shadow di satu KC.</a:t>
             </a:r>
             <a:endParaRPr lang="en-US" sz="1300" dirty="0"/>
           </a:p>
@@ -17038,7 +17038,7 @@
                 <a:ea typeface="Inter" pitchFamily="34" charset="-122"/>
                 <a:cs typeface="Inter" pitchFamily="34" charset="-120"/>
               </a:rPr>
-              <a:t>Antrean + inspector + verdict ber-kunci dan ber-jejak audit</a:t>
+              <a:t>Antrean, inspector, dan verdict berjejak audit</a:t>
             </a:r>
             <a:endParaRPr lang="en-US" sz="1100" dirty="0"/>
           </a:p>
@@ -17062,7 +17062,7 @@
                 <a:ea typeface="Inter" pitchFamily="34" charset="-122"/>
                 <a:cs typeface="Inter" pitchFamily="34" charset="-120"/>
               </a:rPr>
-              <a:t>Pipeline A1-A3 dengan fallback deterministik</a:t>
+              <a:t>Pipeline A1–A3 dengan fallback deterministik</a:t>
             </a:r>
             <a:endParaRPr lang="en-US" sz="1100" dirty="0"/>
           </a:p>
@@ -17086,7 +17086,7 @@
                 <a:ea typeface="Inter" pitchFamily="34" charset="-122"/>
                 <a:cs typeface="Inter" pitchFamily="34" charset="-120"/>
               </a:rPr>
-              <a:t>Portal faskes + sinkron otomatis ke antrean</a:t>
+              <a:t>Portal faskes dan sinkronisasi otomatis</a:t>
             </a:r>
             <a:endParaRPr lang="en-US" sz="1100" dirty="0"/>
           </a:p>
@@ -17110,7 +17110,7 @@
                 <a:ea typeface="Inter" pitchFamily="34" charset="-122"/>
                 <a:cs typeface="Inter" pitchFamily="34" charset="-120"/>
               </a:rPr>
-              <a:t>Sandbox audit, tren data, manajemen pengguna</a:t>
+              <a:t>Sandbox, tren data, dan manajemen pengguna</a:t>
             </a:r>
             <a:endParaRPr lang="en-US" sz="1100" dirty="0"/>
           </a:p>
@@ -17134,7 +17134,7 @@
                 <a:ea typeface="Inter" pitchFamily="34" charset="-122"/>
                 <a:cs typeface="Inter" pitchFamily="34" charset="-120"/>
               </a:rPr>
-              <a:t>Retrain IsolationForest dari label verdict</a:t>
+              <a:t>Pelatihan ulang ML dari label verdict</a:t>
             </a:r>
             <a:endParaRPr lang="en-US" sz="1100" dirty="0"/>
           </a:p>
@@ -17246,7 +17246,7 @@
                 <a:ea typeface="Inter" pitchFamily="34" charset="-122"/>
                 <a:cs typeface="Inter" pitchFamily="34" charset="-120"/>
               </a:rPr>
-              <a:t>Alur end-to-end: ingest API → audit → verdict tersimpan</a:t>
+              <a:t>Alur ujung ke ujung: ingest, audit, hingga verdict tersimpan</a:t>
             </a:r>
             <a:endParaRPr lang="en-US" sz="1100" dirty="0"/>
           </a:p>
@@ -17270,7 +17270,7 @@
                 <a:ea typeface="Inter" pitchFamily="34" charset="-122"/>
                 <a:cs typeface="Inter" pitchFamily="34" charset="-120"/>
               </a:rPr>
-              <a:t>150 klaim teraudit otomatis (89 bersih / 61 anomali)</a:t>
+              <a:t>150 klaim teraudit otomatis (89 bersih, 61 anomali)</a:t>
             </a:r>
             <a:endParaRPr lang="en-US" sz="1100" dirty="0"/>
           </a:p>
@@ -17318,7 +17318,7 @@
                 <a:ea typeface="Inter" pitchFamily="34" charset="-122"/>
                 <a:cs typeface="Inter" pitchFamily="34" charset="-120"/>
               </a:rPr>
-              <a:t>Rate limit login + kunci API per faskes diuji</a:t>
+              <a:t>Pembatasan laju login dan kunci API teruji</a:t>
             </a:r>
             <a:endParaRPr lang="en-US" sz="1100" dirty="0"/>
           </a:p>
@@ -17342,7 +17342,7 @@
                 <a:ea typeface="Inter" pitchFamily="34" charset="-122"/>
                 <a:cs typeface="Inter" pitchFamily="34" charset="-120"/>
               </a:rPr>
-              <a:t>Tampilan diverifikasi pada 390px hingga 1440px</a:t>
+              <a:t>Tampilan teruji pada lebar 390 hingga 1440 piksel</a:t>
             </a:r>
             <a:endParaRPr lang="en-US" sz="1100" dirty="0"/>
           </a:p>
@@ -17454,7 +17454,7 @@
                 <a:ea typeface="Inter" pitchFamily="34" charset="-122"/>
                 <a:cs typeface="Inter" pitchFamily="34" charset="-120"/>
               </a:rPr>
-              <a:t>Belum terhubung data produksi BPJS</a:t>
+              <a:t>Belum terhubung dengan data produksi</a:t>
             </a:r>
             <a:endParaRPr lang="en-US" sz="1100" dirty="0"/>
           </a:p>
@@ -17478,7 +17478,7 @@
                 <a:ea typeface="Inter" pitchFamily="34" charset="-122"/>
                 <a:cs typeface="Inter" pitchFamily="34" charset="-120"/>
               </a:rPr>
-              <a:t>Belum ada uji lapangan dengan verifikator asli</a:t>
+              <a:t>Belum ada uji lapangan bersama verifikator</a:t>
             </a:r>
             <a:endParaRPr lang="en-US" sz="1100" dirty="0"/>
           </a:p>
@@ -17502,7 +17502,7 @@
                 <a:ea typeface="Inter" pitchFamily="34" charset="-122"/>
                 <a:cs typeface="Inter" pitchFamily="34" charset="-120"/>
               </a:rPr>
-              <a:t>Akurasi presisi/recall baru terukur setelah pilot</a:t>
+              <a:t>Presisi dan recall terukur setelah pilot</a:t>
             </a:r>
             <a:endParaRPr lang="en-US" sz="1100" dirty="0"/>
           </a:p>
@@ -17526,7 +17526,7 @@
                 <a:ea typeface="Inter" pitchFamily="34" charset="-122"/>
                 <a:cs typeface="Inter" pitchFamily="34" charset="-120"/>
               </a:rPr>
-              <a:t>Database produksi (PostgreSQL) masuk rencana</a:t>
+              <a:t>PostgreSQL masuk rencana fase berikutnya</a:t>
             </a:r>
             <a:endParaRPr lang="en-US" sz="1100" dirty="0"/>
           </a:p>
@@ -17550,7 +17550,7 @@
                 <a:ea typeface="Inter" pitchFamily="34" charset="-122"/>
                 <a:cs typeface="Inter" pitchFamily="34" charset="-120"/>
               </a:rPr>
-              <a:t>Belum di-deploy ke infrastruktur resmi</a:t>
+              <a:t>Belum diterapkan pada infrastruktur resmi</a:t>
             </a:r>
             <a:endParaRPr lang="en-US" sz="1100" dirty="0"/>
           </a:p>

</xml_diff>

<commit_message>
style: slide 3 dirombak (kartu TIM dihapus, strip produk), body text justify + spasi lega
</commit_message>
<xml_diff>
--- a/proposal/Proposal_SiKePo_Healthkathon2026.pptx
+++ b/proposal/Proposal_SiKePo_Healthkathon2026.pptx
@@ -2333,9 +2333,9 @@
           <a:bodyPr wrap="square" lIns="0" tIns="0" rIns="0" bIns="0" rtlCol="0" anchor="ctr"/>
           <a:lstStyle/>
           <a:p>
-            <a:pPr indent="0" marL="0">
+            <a:pPr algn="just" indent="0" marL="0">
               <a:lnSpc>
-                <a:spcPct val="140000"/>
+                <a:spcPct val="150000"/>
               </a:lnSpc>
               <a:buNone/>
             </a:pPr>
@@ -2709,9 +2709,9 @@
           <a:bodyPr wrap="square" lIns="0" tIns="0" rIns="0" bIns="0" rtlCol="0" anchor="ctr"/>
           <a:lstStyle/>
           <a:p>
-            <a:pPr indent="0" marL="0">
+            <a:pPr algn="just" indent="0" marL="0">
               <a:lnSpc>
-                <a:spcPct val="135000"/>
+                <a:spcPct val="150000"/>
               </a:lnSpc>
               <a:buNone/>
             </a:pPr>
@@ -2751,9 +2751,9 @@
           <a:bodyPr wrap="square" lIns="0" tIns="0" rIns="0" bIns="0" rtlCol="0" anchor="ctr"/>
           <a:lstStyle/>
           <a:p>
-            <a:pPr marL="152400" indent="-152400">
+            <a:pPr algn="just" marL="152400" indent="-152400">
               <a:lnSpc>
-                <a:spcPct val="135000"/>
+                <a:spcPct val="150000"/>
               </a:lnSpc>
               <a:spcAft>
                 <a:spcPts val="700"/>
@@ -2775,9 +2775,9 @@
             <a:endParaRPr lang="en-US" sz="1050" dirty="0"/>
           </a:p>
           <a:p>
-            <a:pPr marL="152400" indent="-152400">
+            <a:pPr algn="just" marL="152400" indent="-152400">
               <a:lnSpc>
-                <a:spcPct val="135000"/>
+                <a:spcPct val="150000"/>
               </a:lnSpc>
               <a:spcAft>
                 <a:spcPts val="700"/>
@@ -2799,9 +2799,9 @@
             <a:endParaRPr lang="en-US" sz="1050" dirty="0"/>
           </a:p>
           <a:p>
-            <a:pPr marL="152400" indent="-152400">
+            <a:pPr algn="just" marL="152400" indent="-152400">
               <a:lnSpc>
-                <a:spcPct val="135000"/>
+                <a:spcPct val="150000"/>
               </a:lnSpc>
               <a:spcAft>
                 <a:spcPts val="700"/>
@@ -2868,9 +2868,9 @@
           <a:bodyPr wrap="square" lIns="0" tIns="0" rIns="0" bIns="0" rtlCol="0" anchor="ctr"/>
           <a:lstStyle/>
           <a:p>
-            <a:pPr indent="0" marL="0">
+            <a:pPr algn="just" indent="0" marL="0">
               <a:lnSpc>
-                <a:spcPct val="130000"/>
+                <a:spcPct val="145000"/>
               </a:lnSpc>
               <a:buNone/>
             </a:pPr>
@@ -3022,9 +3022,9 @@
           <a:bodyPr wrap="square" lIns="0" tIns="0" rIns="0" bIns="0" rtlCol="0" anchor="ctr"/>
           <a:lstStyle/>
           <a:p>
-            <a:pPr indent="0" marL="0">
+            <a:pPr algn="just" indent="0" marL="0">
               <a:lnSpc>
-                <a:spcPct val="135000"/>
+                <a:spcPct val="150000"/>
               </a:lnSpc>
               <a:buNone/>
             </a:pPr>
@@ -3064,9 +3064,9 @@
           <a:bodyPr wrap="square" lIns="0" tIns="0" rIns="0" bIns="0" rtlCol="0" anchor="ctr"/>
           <a:lstStyle/>
           <a:p>
-            <a:pPr marL="152400" indent="-152400">
+            <a:pPr algn="just" marL="152400" indent="-152400">
               <a:lnSpc>
-                <a:spcPct val="135000"/>
+                <a:spcPct val="150000"/>
               </a:lnSpc>
               <a:spcAft>
                 <a:spcPts val="700"/>
@@ -3088,9 +3088,9 @@
             <a:endParaRPr lang="en-US" sz="1050" dirty="0"/>
           </a:p>
           <a:p>
-            <a:pPr marL="152400" indent="-152400">
+            <a:pPr algn="just" marL="152400" indent="-152400">
               <a:lnSpc>
-                <a:spcPct val="135000"/>
+                <a:spcPct val="150000"/>
               </a:lnSpc>
               <a:spcAft>
                 <a:spcPts val="700"/>
@@ -3112,9 +3112,9 @@
             <a:endParaRPr lang="en-US" sz="1050" dirty="0"/>
           </a:p>
           <a:p>
-            <a:pPr marL="152400" indent="-152400">
+            <a:pPr algn="just" marL="152400" indent="-152400">
               <a:lnSpc>
-                <a:spcPct val="135000"/>
+                <a:spcPct val="150000"/>
               </a:lnSpc>
               <a:spcAft>
                 <a:spcPts val="700"/>
@@ -3181,9 +3181,9 @@
           <a:bodyPr wrap="square" lIns="0" tIns="0" rIns="0" bIns="0" rtlCol="0" anchor="ctr"/>
           <a:lstStyle/>
           <a:p>
-            <a:pPr indent="0" marL="0">
+            <a:pPr algn="just" indent="0" marL="0">
               <a:lnSpc>
-                <a:spcPct val="130000"/>
+                <a:spcPct val="145000"/>
               </a:lnSpc>
               <a:buNone/>
             </a:pPr>
@@ -3335,9 +3335,9 @@
           <a:bodyPr wrap="square" lIns="0" tIns="0" rIns="0" bIns="0" rtlCol="0" anchor="ctr"/>
           <a:lstStyle/>
           <a:p>
-            <a:pPr indent="0" marL="0">
+            <a:pPr algn="just" indent="0" marL="0">
               <a:lnSpc>
-                <a:spcPct val="135000"/>
+                <a:spcPct val="150000"/>
               </a:lnSpc>
               <a:buNone/>
             </a:pPr>
@@ -3377,9 +3377,9 @@
           <a:bodyPr wrap="square" lIns="0" tIns="0" rIns="0" bIns="0" rtlCol="0" anchor="ctr"/>
           <a:lstStyle/>
           <a:p>
-            <a:pPr marL="152400" indent="-152400">
+            <a:pPr algn="just" marL="152400" indent="-152400">
               <a:lnSpc>
-                <a:spcPct val="135000"/>
+                <a:spcPct val="150000"/>
               </a:lnSpc>
               <a:spcAft>
                 <a:spcPts val="700"/>
@@ -3401,9 +3401,9 @@
             <a:endParaRPr lang="en-US" sz="1050" dirty="0"/>
           </a:p>
           <a:p>
-            <a:pPr marL="152400" indent="-152400">
+            <a:pPr algn="just" marL="152400" indent="-152400">
               <a:lnSpc>
-                <a:spcPct val="135000"/>
+                <a:spcPct val="150000"/>
               </a:lnSpc>
               <a:spcAft>
                 <a:spcPts val="700"/>
@@ -3425,9 +3425,9 @@
             <a:endParaRPr lang="en-US" sz="1050" dirty="0"/>
           </a:p>
           <a:p>
-            <a:pPr marL="152400" indent="-152400">
+            <a:pPr algn="just" marL="152400" indent="-152400">
               <a:lnSpc>
-                <a:spcPct val="135000"/>
+                <a:spcPct val="150000"/>
               </a:lnSpc>
               <a:spcAft>
                 <a:spcPts val="700"/>
@@ -3494,9 +3494,9 @@
           <a:bodyPr wrap="square" lIns="0" tIns="0" rIns="0" bIns="0" rtlCol="0" anchor="ctr"/>
           <a:lstStyle/>
           <a:p>
-            <a:pPr indent="0" marL="0">
+            <a:pPr algn="just" indent="0" marL="0">
               <a:lnSpc>
-                <a:spcPct val="130000"/>
+                <a:spcPct val="145000"/>
               </a:lnSpc>
               <a:buNone/>
             </a:pPr>
@@ -3648,9 +3648,9 @@
           <a:bodyPr wrap="square" lIns="0" tIns="0" rIns="0" bIns="0" rtlCol="0" anchor="ctr"/>
           <a:lstStyle/>
           <a:p>
-            <a:pPr indent="0" marL="0">
+            <a:pPr algn="just" indent="0" marL="0">
               <a:lnSpc>
-                <a:spcPct val="135000"/>
+                <a:spcPct val="150000"/>
               </a:lnSpc>
               <a:buNone/>
             </a:pPr>
@@ -3690,9 +3690,9 @@
           <a:bodyPr wrap="square" lIns="0" tIns="0" rIns="0" bIns="0" rtlCol="0" anchor="ctr"/>
           <a:lstStyle/>
           <a:p>
-            <a:pPr marL="152400" indent="-152400">
+            <a:pPr algn="just" marL="152400" indent="-152400">
               <a:lnSpc>
-                <a:spcPct val="135000"/>
+                <a:spcPct val="150000"/>
               </a:lnSpc>
               <a:spcAft>
                 <a:spcPts val="700"/>
@@ -3714,9 +3714,9 @@
             <a:endParaRPr lang="en-US" sz="1050" dirty="0"/>
           </a:p>
           <a:p>
-            <a:pPr marL="152400" indent="-152400">
+            <a:pPr algn="just" marL="152400" indent="-152400">
               <a:lnSpc>
-                <a:spcPct val="135000"/>
+                <a:spcPct val="150000"/>
               </a:lnSpc>
               <a:spcAft>
                 <a:spcPts val="700"/>
@@ -3738,9 +3738,9 @@
             <a:endParaRPr lang="en-US" sz="1050" dirty="0"/>
           </a:p>
           <a:p>
-            <a:pPr marL="152400" indent="-152400">
+            <a:pPr algn="just" marL="152400" indent="-152400">
               <a:lnSpc>
-                <a:spcPct val="135000"/>
+                <a:spcPct val="150000"/>
               </a:lnSpc>
               <a:spcAft>
                 <a:spcPts val="700"/>
@@ -3807,9 +3807,9 @@
           <a:bodyPr wrap="square" lIns="0" tIns="0" rIns="0" bIns="0" rtlCol="0" anchor="ctr"/>
           <a:lstStyle/>
           <a:p>
-            <a:pPr indent="0" marL="0">
+            <a:pPr algn="just" indent="0" marL="0">
               <a:lnSpc>
-                <a:spcPct val="130000"/>
+                <a:spcPct val="145000"/>
               </a:lnSpc>
               <a:buNone/>
             </a:pPr>
@@ -5398,9 +5398,9 @@
           <a:bodyPr wrap="square" lIns="0" tIns="0" rIns="0" bIns="0" rtlCol="0" anchor="ctr"/>
           <a:lstStyle/>
           <a:p>
-            <a:pPr indent="0" marL="0">
+            <a:pPr algn="just" indent="0" marL="0">
               <a:lnSpc>
-                <a:spcPct val="130000"/>
+                <a:spcPct val="145000"/>
               </a:lnSpc>
               <a:buNone/>
             </a:pPr>
@@ -5501,9 +5501,9 @@
           <a:bodyPr wrap="square" lIns="0" tIns="0" rIns="0" bIns="0" rtlCol="0" anchor="ctr"/>
           <a:lstStyle/>
           <a:p>
-            <a:pPr indent="0" marL="0">
+            <a:pPr algn="just" indent="0" marL="0">
               <a:lnSpc>
-                <a:spcPct val="130000"/>
+                <a:spcPct val="145000"/>
               </a:lnSpc>
               <a:buNone/>
             </a:pPr>
@@ -5604,9 +5604,9 @@
           <a:bodyPr wrap="square" lIns="0" tIns="0" rIns="0" bIns="0" rtlCol="0" anchor="ctr"/>
           <a:lstStyle/>
           <a:p>
-            <a:pPr indent="0" marL="0">
+            <a:pPr algn="just" indent="0" marL="0">
               <a:lnSpc>
-                <a:spcPct val="130000"/>
+                <a:spcPct val="145000"/>
               </a:lnSpc>
               <a:buNone/>
             </a:pPr>
@@ -5946,9 +5946,9 @@
           <a:bodyPr wrap="square" lIns="0" tIns="0" rIns="0" bIns="0" rtlCol="0" anchor="ctr"/>
           <a:lstStyle/>
           <a:p>
-            <a:pPr indent="0" marL="0">
+            <a:pPr algn="just" indent="0" marL="0">
               <a:lnSpc>
-                <a:spcPct val="138000"/>
+                <a:spcPct val="150000"/>
               </a:lnSpc>
               <a:buNone/>
             </a:pPr>
@@ -6061,9 +6061,9 @@
           <a:bodyPr wrap="square" lIns="0" tIns="0" rIns="0" bIns="0" rtlCol="0" anchor="ctr"/>
           <a:lstStyle/>
           <a:p>
-            <a:pPr indent="0" marL="0">
+            <a:pPr algn="just" indent="0" marL="0">
               <a:lnSpc>
-                <a:spcPct val="138000"/>
+                <a:spcPct val="150000"/>
               </a:lnSpc>
               <a:buNone/>
             </a:pPr>
@@ -6176,9 +6176,9 @@
           <a:bodyPr wrap="square" lIns="0" tIns="0" rIns="0" bIns="0" rtlCol="0" anchor="ctr"/>
           <a:lstStyle/>
           <a:p>
-            <a:pPr indent="0" marL="0">
+            <a:pPr algn="just" indent="0" marL="0">
               <a:lnSpc>
-                <a:spcPct val="138000"/>
+                <a:spcPct val="150000"/>
               </a:lnSpc>
               <a:buNone/>
             </a:pPr>
@@ -6291,9 +6291,9 @@
           <a:bodyPr wrap="square" lIns="0" tIns="0" rIns="0" bIns="0" rtlCol="0" anchor="ctr"/>
           <a:lstStyle/>
           <a:p>
-            <a:pPr indent="0" marL="0">
+            <a:pPr algn="just" indent="0" marL="0">
               <a:lnSpc>
-                <a:spcPct val="138000"/>
+                <a:spcPct val="150000"/>
               </a:lnSpc>
               <a:buNone/>
             </a:pPr>
@@ -6605,9 +6605,9 @@
           <a:bodyPr wrap="square" lIns="0" tIns="0" rIns="0" bIns="0" rtlCol="0" anchor="ctr"/>
           <a:lstStyle/>
           <a:p>
-            <a:pPr indent="0" marL="0">
+            <a:pPr algn="just" indent="0" marL="0">
               <a:lnSpc>
-                <a:spcPct val="140000"/>
+                <a:spcPct val="150000"/>
               </a:lnSpc>
               <a:buNone/>
             </a:pPr>
@@ -6710,7 +6710,7 @@
                 <a:ea typeface="Inter" pitchFamily="34" charset="-122"/>
                 <a:cs typeface="Inter" pitchFamily="34" charset="-120"/>
               </a:rPr>
-              <a:t>Lead Engineer &amp; Product · S.Si. Fisika, Universitas Negeri Yogyakarta (2026)</a:t>
+              <a:t>Lead Engineer dan Product · S.Si. Fisika, Universitas Negeri Yogyakarta (2026)</a:t>
             </a:r>
             <a:endParaRPr lang="en-US" sz="1250" dirty="0"/>
           </a:p>
@@ -6776,9 +6776,9 @@
           <a:bodyPr wrap="square" lIns="0" tIns="0" rIns="0" bIns="0" rtlCol="0" anchor="ctr"/>
           <a:lstStyle/>
           <a:p>
-            <a:pPr indent="0" marL="0">
+            <a:pPr algn="just" indent="0" marL="0">
               <a:lnSpc>
-                <a:spcPct val="138000"/>
+                <a:spcPct val="150000"/>
               </a:lnSpc>
               <a:buNone/>
             </a:pPr>
@@ -6857,9 +6857,9 @@
           <a:bodyPr wrap="square" lIns="0" tIns="0" rIns="0" bIns="0" rtlCol="0" anchor="ctr"/>
           <a:lstStyle/>
           <a:p>
-            <a:pPr indent="0" marL="0">
+            <a:pPr algn="just" indent="0" marL="0">
               <a:lnSpc>
-                <a:spcPct val="138000"/>
+                <a:spcPct val="150000"/>
               </a:lnSpc>
               <a:buNone/>
             </a:pPr>
@@ -6938,9 +6938,9 @@
           <a:bodyPr wrap="square" lIns="0" tIns="0" rIns="0" bIns="0" rtlCol="0" anchor="ctr"/>
           <a:lstStyle/>
           <a:p>
-            <a:pPr indent="0" marL="0">
+            <a:pPr algn="just" indent="0" marL="0">
               <a:lnSpc>
-                <a:spcPct val="138000"/>
+                <a:spcPct val="150000"/>
               </a:lnSpc>
               <a:buNone/>
             </a:pPr>
@@ -7019,9 +7019,9 @@
           <a:bodyPr wrap="square" lIns="0" tIns="0" rIns="0" bIns="0" rtlCol="0" anchor="ctr"/>
           <a:lstStyle/>
           <a:p>
-            <a:pPr indent="0" marL="0">
+            <a:pPr algn="just" indent="0" marL="0">
               <a:lnSpc>
-                <a:spcPct val="138000"/>
+                <a:spcPct val="150000"/>
               </a:lnSpc>
               <a:buNone/>
             </a:pPr>
@@ -7083,9 +7083,9 @@
           <a:bodyPr wrap="square" lIns="0" tIns="0" rIns="0" bIns="0" rtlCol="0" anchor="ctr"/>
           <a:lstStyle/>
           <a:p>
-            <a:pPr indent="0" marL="0">
+            <a:pPr algn="just" indent="0" marL="0">
               <a:lnSpc>
-                <a:spcPct val="138000"/>
+                <a:spcPct val="150000"/>
               </a:lnSpc>
               <a:buNone/>
             </a:pPr>
@@ -9852,9 +9852,9 @@
           <a:bodyPr wrap="square" lIns="0" tIns="0" rIns="0" bIns="0" rtlCol="0" anchor="ctr"/>
           <a:lstStyle/>
           <a:p>
-            <a:pPr indent="0" marL="0">
+            <a:pPr algn="just" indent="0" marL="0">
               <a:lnSpc>
-                <a:spcPct val="140000"/>
+                <a:spcPct val="150000"/>
               </a:lnSpc>
               <a:buNone/>
             </a:pPr>
@@ -9906,9 +9906,9 @@
           <a:bodyPr wrap="square" lIns="0" tIns="0" rIns="0" bIns="0" rtlCol="0" anchor="ctr"/>
           <a:lstStyle/>
           <a:p>
-            <a:pPr indent="0" marL="0">
+            <a:pPr algn="just" indent="0" marL="0">
               <a:lnSpc>
-                <a:spcPct val="140000"/>
+                <a:spcPct val="150000"/>
               </a:lnSpc>
               <a:buNone/>
             </a:pPr>
@@ -10343,9 +10343,9 @@
           <a:bodyPr wrap="square" lIns="0" tIns="0" rIns="0" bIns="0" rtlCol="0" anchor="ctr"/>
           <a:lstStyle/>
           <a:p>
-            <a:pPr indent="0" marL="0">
+            <a:pPr algn="just" indent="0" marL="0">
               <a:lnSpc>
-                <a:spcPct val="138000"/>
+                <a:spcPct val="150000"/>
               </a:lnSpc>
               <a:buNone/>
             </a:pPr>
@@ -10497,9 +10497,9 @@
           <a:bodyPr wrap="square" lIns="0" tIns="0" rIns="0" bIns="0" rtlCol="0" anchor="ctr"/>
           <a:lstStyle/>
           <a:p>
-            <a:pPr indent="0" marL="0">
+            <a:pPr algn="just" indent="0" marL="0">
               <a:lnSpc>
-                <a:spcPct val="138000"/>
+                <a:spcPct val="150000"/>
               </a:lnSpc>
               <a:buNone/>
             </a:pPr>
@@ -10651,9 +10651,9 @@
           <a:bodyPr wrap="square" lIns="0" tIns="0" rIns="0" bIns="0" rtlCol="0" anchor="ctr"/>
           <a:lstStyle/>
           <a:p>
-            <a:pPr indent="0" marL="0">
+            <a:pPr algn="just" indent="0" marL="0">
               <a:lnSpc>
-                <a:spcPct val="138000"/>
+                <a:spcPct val="150000"/>
               </a:lnSpc>
               <a:buNone/>
             </a:pPr>
@@ -10805,9 +10805,9 @@
           <a:bodyPr wrap="square" lIns="0" tIns="0" rIns="0" bIns="0" rtlCol="0" anchor="ctr"/>
           <a:lstStyle/>
           <a:p>
-            <a:pPr indent="0" marL="0">
+            <a:pPr algn="just" indent="0" marL="0">
               <a:lnSpc>
-                <a:spcPct val="138000"/>
+                <a:spcPct val="150000"/>
               </a:lnSpc>
               <a:buNone/>
             </a:pPr>
@@ -11100,12 +11100,12 @@
         </p:nvSpPr>
         <p:spPr>
           <a:xfrm>
-            <a:off x="457200" y="1572768"/>
-            <a:ext cx="6766560" cy="2286000"/>
+            <a:off x="457200" y="1554480"/>
+            <a:ext cx="11274552" cy="1920240"/>
           </a:xfrm>
           <a:prstGeom prst="roundRect">
             <a:avLst>
-              <a:gd name="adj" fmla="val 4000"/>
+              <a:gd name="adj" fmla="val 4762"/>
             </a:avLst>
           </a:prstGeom>
           <a:solidFill>
@@ -11122,23 +11122,26 @@
         </p:nvSpPr>
         <p:spPr>
           <a:xfrm>
-            <a:off x="777240" y="1783080"/>
-            <a:ext cx="6126480" cy="1920240"/>
-          </a:xfrm>
-          <a:prstGeom prst="rect">
-            <a:avLst/>
-          </a:prstGeom>
-          <a:noFill/>
-          <a:ln/>
-        </p:spPr>
-        <p:txBody>
-          <a:bodyPr wrap="square" lIns="0" tIns="0" rIns="0" bIns="0" rtlCol="0" anchor="ctr"/>
-          <a:lstStyle/>
-          <a:p>
-            <a:pPr indent="0" marL="0">
+            <a:off x="822960" y="1783080"/>
+            <a:ext cx="10561320" cy="1554480"/>
+          </a:xfrm>
+          <a:prstGeom prst="rect">
+            <a:avLst/>
+          </a:prstGeom>
+          <a:noFill/>
+          <a:ln/>
+        </p:spPr>
+        <p:txBody>
+          <a:bodyPr wrap="square" lIns="0" tIns="0" rIns="0" bIns="0" rtlCol="0" anchor="ctr"/>
+          <a:lstStyle/>
+          <a:p>
+            <a:pPr algn="just" indent="0" marL="0">
               <a:lnSpc>
-                <a:spcPct val="140000"/>
+                <a:spcPct val="150000"/>
               </a:lnSpc>
+              <a:spcAft>
+                <a:spcPts val="600"/>
+              </a:spcAft>
               <a:buNone/>
             </a:pPr>
             <a:r>
@@ -11150,11 +11153,22 @@
                 <a:ea typeface="Inter" pitchFamily="34" charset="-122"/>
                 <a:cs typeface="Inter" pitchFamily="34" charset="-120"/>
               </a:rPr>
-              <a:t>Satu kalimat nilai
-</a:t>
-            </a:r>
-            <a:r>
-              <a:rPr lang="en-US" sz="1700" dirty="0">
+              <a:t>SATU KALIMAT NILAI</a:t>
+            </a:r>
+            <a:endParaRPr lang="en-US" sz="1100" dirty="0"/>
+          </a:p>
+          <a:p>
+            <a:pPr algn="just" indent="0" marL="0">
+              <a:lnSpc>
+                <a:spcPct val="150000"/>
+              </a:lnSpc>
+              <a:spcAft>
+                <a:spcPts val="600"/>
+              </a:spcAft>
+              <a:buNone/>
+            </a:pPr>
+            <a:r>
+              <a:rPr lang="en-US" sz="1800" dirty="0">
                 <a:solidFill>
                   <a:srgbClr val="0B1526"/>
                 </a:solidFill>
@@ -11176,8 +11190,8 @@
         </p:nvSpPr>
         <p:spPr>
           <a:xfrm>
-            <a:off x="457200" y="4160520"/>
-            <a:ext cx="5486400" cy="274320"/>
+            <a:off x="457200" y="3675888"/>
+            <a:ext cx="5486400" cy="292608"/>
           </a:xfrm>
           <a:prstGeom prst="rect">
             <a:avLst/>
@@ -11215,28 +11229,31 @@
         </p:nvSpPr>
         <p:spPr>
           <a:xfrm>
-            <a:off x="457200" y="4480560"/>
-            <a:ext cx="6675120" cy="1554480"/>
-          </a:xfrm>
-          <a:prstGeom prst="rect">
-            <a:avLst/>
-          </a:prstGeom>
-          <a:noFill/>
-          <a:ln/>
-        </p:spPr>
-        <p:txBody>
-          <a:bodyPr wrap="square" lIns="0" tIns="0" rIns="0" bIns="0" rtlCol="0" anchor="ctr"/>
-          <a:lstStyle/>
-          <a:p>
-            <a:pPr marL="152400" indent="-152400">
+            <a:off x="457200" y="4023360"/>
+            <a:ext cx="11274552" cy="914400"/>
+          </a:xfrm>
+          <a:prstGeom prst="rect">
+            <a:avLst/>
+          </a:prstGeom>
+          <a:noFill/>
+          <a:ln/>
+        </p:spPr>
+        <p:txBody>
+          <a:bodyPr wrap="square" lIns="0" tIns="0" rIns="0" bIns="0" rtlCol="0" anchor="ctr"/>
+          <a:lstStyle/>
+          <a:p>
+            <a:pPr algn="just" marL="152400" indent="-152400">
+              <a:lnSpc>
+                <a:spcPct val="145000"/>
+              </a:lnSpc>
               <a:spcAft>
-                <a:spcPts val="800"/>
+                <a:spcPts val="1200"/>
               </a:spcAft>
               <a:buSzPct val="100000"/>
               <a:buChar char="▸"/>
             </a:pPr>
             <a:r>
-              <a:rPr lang="en-US" sz="1300" dirty="0">
+              <a:rPr lang="en-US" sz="1350" dirty="0">
                 <a:solidFill>
                   <a:srgbClr val="4A5568"/>
                 </a:solidFill>
@@ -11244,20 +11261,23 @@
                 <a:ea typeface="Inter" pitchFamily="34" charset="-122"/>
                 <a:cs typeface="Inter" pitchFamily="34" charset="-120"/>
               </a:rPr>
-              <a:t>Audit berjalan di dalam alur klaim, sebelum dana cair.</a:t>
-            </a:r>
-            <a:endParaRPr lang="en-US" sz="1300" dirty="0"/>
-          </a:p>
-          <a:p>
-            <a:pPr marL="152400" indent="-152400">
+              <a:t>Audit berjalan di dalam alur klaim, sebelum dana cair, bukan laporan setelah kejadian.</a:t>
+            </a:r>
+            <a:endParaRPr lang="en-US" sz="1350" dirty="0"/>
+          </a:p>
+          <a:p>
+            <a:pPr algn="just" marL="152400" indent="-152400">
+              <a:lnSpc>
+                <a:spcPct val="145000"/>
+              </a:lnSpc>
               <a:spcAft>
-                <a:spcPts val="800"/>
+                <a:spcPts val="1200"/>
               </a:spcAft>
               <a:buSzPct val="100000"/>
               <a:buChar char="▸"/>
             </a:pPr>
             <a:r>
-              <a:rPr lang="en-US" sz="1300" dirty="0">
+              <a:rPr lang="en-US" sz="1350" dirty="0">
                 <a:solidFill>
                   <a:srgbClr val="4A5568"/>
                 </a:solidFill>
@@ -11267,18 +11287,21 @@
               </a:rPr>
               <a:t>Setiap skor disertai alasan yang dapat dibaca dan diaudit.</a:t>
             </a:r>
-            <a:endParaRPr lang="en-US" sz="1300" dirty="0"/>
-          </a:p>
-          <a:p>
-            <a:pPr marL="152400" indent="-152400">
+            <a:endParaRPr lang="en-US" sz="1350" dirty="0"/>
+          </a:p>
+          <a:p>
+            <a:pPr algn="just" marL="152400" indent="-152400">
+              <a:lnSpc>
+                <a:spcPct val="145000"/>
+              </a:lnSpc>
               <a:spcAft>
-                <a:spcPts val="800"/>
+                <a:spcPts val="1200"/>
               </a:spcAft>
               <a:buSzPct val="100000"/>
               <a:buChar char="▸"/>
             </a:pPr>
             <a:r>
-              <a:rPr lang="en-US" sz="1300" dirty="0">
+              <a:rPr lang="en-US" sz="1350" dirty="0">
                 <a:solidFill>
                   <a:srgbClr val="4A5568"/>
                 </a:solidFill>
@@ -11288,42 +11311,43 @@
               </a:rPr>
               <a:t>AI memberi rekomendasi; verifikator yang memutuskan.</a:t>
             </a:r>
-            <a:endParaRPr lang="en-US" sz="1300" dirty="0"/>
-          </a:p>
-        </p:txBody>
-      </p:sp>
-      <p:sp>
-        <p:nvSpPr>
-          <p:cNvPr id="8" name="Shape 6"/>
-          <p:cNvSpPr/>
-          <p:nvPr/>
-        </p:nvSpPr>
-        <p:spPr>
-          <a:xfrm>
-            <a:off x="7635240" y="1572768"/>
-            <a:ext cx="4096512" cy="4462272"/>
-          </a:xfrm>
-          <a:prstGeom prst="roundRect">
-            <a:avLst>
-              <a:gd name="adj" fmla="val 2679"/>
-            </a:avLst>
-          </a:prstGeom>
-          <a:solidFill>
-            <a:srgbClr val="0B1526"/>
-          </a:solidFill>
-          <a:ln/>
-        </p:spPr>
-      </p:sp>
-      <p:sp>
-        <p:nvSpPr>
-          <p:cNvPr id="9" name="Text 7"/>
-          <p:cNvSpPr/>
-          <p:nvPr/>
-        </p:nvSpPr>
-        <p:spPr>
-          <a:xfrm>
-            <a:off x="7955280" y="1828800"/>
-            <a:ext cx="2743200" cy="256032"/>
+            <a:endParaRPr lang="en-US" sz="1350" dirty="0"/>
+          </a:p>
+        </p:txBody>
+      </p:sp>
+      <p:pic>
+        <p:nvPicPr>
+          <p:cNvPr id="8" name="Image 0" descr="D:/FamilyAgent/Nox/workspace/sikepo-app/proposal/assets/shot-claims.png">    </p:cNvPr>
+          <p:cNvPicPr>
+            <a:picLocks noChangeAspect="1"/>
+          </p:cNvPicPr>
+          <p:nvPr/>
+        </p:nvPicPr>
+        <p:blipFill>
+          <a:blip r:embed="rId1"/>
+          <a:srcRect l="0" r="0" t="0" b="0"/>
+          <a:stretch/>
+        </p:blipFill>
+        <p:spPr>
+          <a:xfrm>
+            <a:off x="457200" y="5138928"/>
+            <a:ext cx="11274552" cy="1371600"/>
+          </a:xfrm>
+          <a:prstGeom prst="rect">
+            <a:avLst/>
+          </a:prstGeom>
+        </p:spPr>
+      </p:pic>
+      <p:sp>
+        <p:nvSpPr>
+          <p:cNvPr id="9" name="Text 6"/>
+          <p:cNvSpPr/>
+          <p:nvPr/>
+        </p:nvSpPr>
+        <p:spPr>
+          <a:xfrm>
+            <a:off x="457200" y="6510528"/>
+            <a:ext cx="4572000" cy="237744"/>
           </a:xfrm>
           <a:prstGeom prst="rect">
             <a:avLst/>
@@ -11339,389 +11363,14 @@
               <a:buNone/>
             </a:pPr>
             <a:r>
-              <a:rPr lang="en-US" sz="1000" b="1" spc="300" kern="0" dirty="0">
-                <a:solidFill>
-                  <a:srgbClr val="35D08F"/>
+              <a:rPr lang="en-US" sz="900" dirty="0">
+                <a:solidFill>
+                  <a:srgbClr val="8291A6"/>
                 </a:solidFill>
                 <a:latin typeface="Inter" pitchFamily="34" charset="0"/>
                 <a:ea typeface="Inter" pitchFamily="34" charset="-122"/>
                 <a:cs typeface="Inter" pitchFamily="34" charset="-120"/>
               </a:rPr>
-              <a:t>TIM</a:t>
-            </a:r>
-            <a:endParaRPr lang="en-US" sz="1000" dirty="0"/>
-          </a:p>
-        </p:txBody>
-      </p:sp>
-      <p:sp>
-        <p:nvSpPr>
-          <p:cNvPr id="10" name="Text 8"/>
-          <p:cNvSpPr/>
-          <p:nvPr/>
-        </p:nvSpPr>
-        <p:spPr>
-          <a:xfrm>
-            <a:off x="7955280" y="2103120"/>
-            <a:ext cx="3474720" cy="411480"/>
-          </a:xfrm>
-          <a:prstGeom prst="rect">
-            <a:avLst/>
-          </a:prstGeom>
-          <a:noFill/>
-          <a:ln/>
-        </p:spPr>
-        <p:txBody>
-          <a:bodyPr wrap="square" lIns="0" tIns="0" rIns="0" bIns="0" rtlCol="0" anchor="ctr"/>
-          <a:lstStyle/>
-          <a:p>
-            <a:pPr indent="0" marL="0">
-              <a:buNone/>
-            </a:pPr>
-            <a:r>
-              <a:rPr lang="en-US" sz="2200" b="1" dirty="0">
-                <a:solidFill>
-                  <a:srgbClr val="FFFFFF"/>
-                </a:solidFill>
-                <a:latin typeface="Plus Jakarta Sans" pitchFamily="34" charset="0"/>
-                <a:ea typeface="Plus Jakarta Sans" pitchFamily="34" charset="-122"/>
-                <a:cs typeface="Plus Jakarta Sans" pitchFamily="34" charset="-120"/>
-              </a:rPr>
-              <a:t>Coba Namanya Ini</a:t>
-            </a:r>
-            <a:endParaRPr lang="en-US" sz="2200" dirty="0"/>
-          </a:p>
-        </p:txBody>
-      </p:sp>
-      <p:sp>
-        <p:nvSpPr>
-          <p:cNvPr id="11" name="Text 9"/>
-          <p:cNvSpPr/>
-          <p:nvPr/>
-        </p:nvSpPr>
-        <p:spPr>
-          <a:xfrm>
-            <a:off x="7955280" y="2578608"/>
-            <a:ext cx="3474720" cy="548640"/>
-          </a:xfrm>
-          <a:prstGeom prst="rect">
-            <a:avLst/>
-          </a:prstGeom>
-          <a:noFill/>
-          <a:ln/>
-        </p:spPr>
-        <p:txBody>
-          <a:bodyPr wrap="square" lIns="0" tIns="0" rIns="0" bIns="0" rtlCol="0" anchor="ctr"/>
-          <a:lstStyle/>
-          <a:p>
-            <a:pPr indent="0" marL="0">
-              <a:lnSpc>
-                <a:spcPct val="140000"/>
-              </a:lnSpc>
-              <a:buNone/>
-            </a:pPr>
-            <a:r>
-              <a:rPr lang="en-US" sz="1200" i="1" dirty="0">
-                <a:solidFill>
-                  <a:srgbClr val="9DB2CC"/>
-                </a:solidFill>
-                <a:latin typeface="Inter" pitchFamily="34" charset="0"/>
-                <a:ea typeface="Inter" pitchFamily="34" charset="-122"/>
-                <a:cs typeface="Inter" pitchFamily="34" charset="-120"/>
-              </a:rPr>
-              <a:t>Namanya konyol, kerjaannya serius.</a:t>
-            </a:r>
-            <a:endParaRPr lang="en-US" sz="1200" dirty="0"/>
-          </a:p>
-        </p:txBody>
-      </p:sp>
-      <p:sp>
-        <p:nvSpPr>
-          <p:cNvPr id="12" name="Shape 10"/>
-          <p:cNvSpPr/>
-          <p:nvPr/>
-        </p:nvSpPr>
-        <p:spPr>
-          <a:xfrm>
-            <a:off x="7955280" y="3310128"/>
-            <a:ext cx="3429000" cy="0"/>
-          </a:xfrm>
-          <a:prstGeom prst="line">
-            <a:avLst/>
-          </a:prstGeom>
-          <a:noFill/>
-          <a:ln w="12700">
-            <a:solidFill>
-              <a:srgbClr val="24406B"/>
-            </a:solidFill>
-            <a:prstDash val="solid"/>
-          </a:ln>
-        </p:spPr>
-      </p:sp>
-      <p:sp>
-        <p:nvSpPr>
-          <p:cNvPr id="13" name="Text 11"/>
-          <p:cNvSpPr/>
-          <p:nvPr/>
-        </p:nvSpPr>
-        <p:spPr>
-          <a:xfrm>
-            <a:off x="7955280" y="3474720"/>
-            <a:ext cx="3474720" cy="292608"/>
-          </a:xfrm>
-          <a:prstGeom prst="rect">
-            <a:avLst/>
-          </a:prstGeom>
-          <a:noFill/>
-          <a:ln/>
-        </p:spPr>
-        <p:txBody>
-          <a:bodyPr wrap="square" lIns="0" tIns="0" rIns="0" bIns="0" rtlCol="0" anchor="ctr"/>
-          <a:lstStyle/>
-          <a:p>
-            <a:pPr indent="0" marL="0">
-              <a:buNone/>
-            </a:pPr>
-            <a:r>
-              <a:rPr lang="en-US" sz="1500" b="1" dirty="0">
-                <a:solidFill>
-                  <a:srgbClr val="FFFFFF"/>
-                </a:solidFill>
-                <a:latin typeface="Plus Jakarta Sans" pitchFamily="34" charset="0"/>
-                <a:ea typeface="Plus Jakarta Sans" pitchFamily="34" charset="-122"/>
-                <a:cs typeface="Plus Jakarta Sans" pitchFamily="34" charset="-120"/>
-              </a:rPr>
-              <a:t>Decka Fadhila Tirta</a:t>
-            </a:r>
-            <a:endParaRPr lang="en-US" sz="1500" dirty="0"/>
-          </a:p>
-        </p:txBody>
-      </p:sp>
-      <p:sp>
-        <p:nvSpPr>
-          <p:cNvPr id="14" name="Text 12"/>
-          <p:cNvSpPr/>
-          <p:nvPr/>
-        </p:nvSpPr>
-        <p:spPr>
-          <a:xfrm>
-            <a:off x="7955280" y="3785616"/>
-            <a:ext cx="3474720" cy="502920"/>
-          </a:xfrm>
-          <a:prstGeom prst="rect">
-            <a:avLst/>
-          </a:prstGeom>
-          <a:noFill/>
-          <a:ln/>
-        </p:spPr>
-        <p:txBody>
-          <a:bodyPr wrap="square" lIns="0" tIns="0" rIns="0" bIns="0" rtlCol="0" anchor="ctr"/>
-          <a:lstStyle/>
-          <a:p>
-            <a:pPr indent="0" marL="0">
-              <a:lnSpc>
-                <a:spcPct val="138000"/>
-              </a:lnSpc>
-              <a:buNone/>
-            </a:pPr>
-            <a:r>
-              <a:rPr lang="en-US" sz="1150" dirty="0">
-                <a:solidFill>
-                  <a:srgbClr val="AAB9CB"/>
-                </a:solidFill>
-                <a:latin typeface="Inter" pitchFamily="34" charset="0"/>
-                <a:ea typeface="Inter" pitchFamily="34" charset="-122"/>
-                <a:cs typeface="Inter" pitchFamily="34" charset="-120"/>
-              </a:rPr>
-              <a:t>Lead Engineer &amp; Product</a:t>
-            </a:r>
-            <a:endParaRPr lang="en-US" sz="1150" dirty="0"/>
-          </a:p>
-          <a:p>
-            <a:pPr indent="0" marL="0">
-              <a:lnSpc>
-                <a:spcPct val="138000"/>
-              </a:lnSpc>
-              <a:buNone/>
-            </a:pPr>
-            <a:r>
-              <a:rPr lang="en-US" sz="1150" dirty="0">
-                <a:solidFill>
-                  <a:srgbClr val="AAB9CB"/>
-                </a:solidFill>
-                <a:latin typeface="Inter" pitchFamily="34" charset="0"/>
-                <a:ea typeface="Inter" pitchFamily="34" charset="-122"/>
-                <a:cs typeface="Inter" pitchFamily="34" charset="-120"/>
-              </a:rPr>
-              <a:t>S.Si. Fisika, Universitas Negeri Yogyakarta</a:t>
-            </a:r>
-            <a:endParaRPr lang="en-US" sz="1150" dirty="0"/>
-          </a:p>
-        </p:txBody>
-      </p:sp>
-      <p:sp>
-        <p:nvSpPr>
-          <p:cNvPr id="15" name="Text 13"/>
-          <p:cNvSpPr/>
-          <p:nvPr/>
-        </p:nvSpPr>
-        <p:spPr>
-          <a:xfrm>
-            <a:off x="7955280" y="4434840"/>
-            <a:ext cx="3474720" cy="914400"/>
-          </a:xfrm>
-          <a:prstGeom prst="rect">
-            <a:avLst/>
-          </a:prstGeom>
-          <a:noFill/>
-          <a:ln/>
-        </p:spPr>
-        <p:txBody>
-          <a:bodyPr wrap="square" lIns="0" tIns="0" rIns="0" bIns="0" rtlCol="0" anchor="ctr"/>
-          <a:lstStyle/>
-          <a:p>
-            <a:pPr indent="0" marL="0">
-              <a:spcAft>
-                <a:spcPts val="500"/>
-              </a:spcAft>
-              <a:buNone/>
-            </a:pPr>
-            <a:r>
-              <a:rPr lang="en-US" sz="1150" dirty="0">
-                <a:solidFill>
-                  <a:srgbClr val="AAB9CB"/>
-                </a:solidFill>
-                <a:latin typeface="Inter" pitchFamily="34" charset="0"/>
-                <a:ea typeface="Inter" pitchFamily="34" charset="-122"/>
-                <a:cs typeface="Inter" pitchFamily="34" charset="-120"/>
-              </a:rPr>
-              <a:t>Full-stack aplikasi (Python + web)
-</a:t>
-            </a:r>
-            <a:r>
-              <a:rPr lang="en-US" sz="1150" dirty="0">
-                <a:solidFill>
-                  <a:srgbClr val="AAB9CB"/>
-                </a:solidFill>
-                <a:latin typeface="Inter" pitchFamily="34" charset="0"/>
-                <a:ea typeface="Inter" pitchFamily="34" charset="-122"/>
-                <a:cs typeface="Inter" pitchFamily="34" charset="-120"/>
-              </a:rPr>
-              <a:t>Pipeline AI &amp; integrasi LLM
-</a:t>
-            </a:r>
-            <a:r>
-              <a:rPr lang="en-US" sz="1150" dirty="0">
-                <a:solidFill>
-                  <a:srgbClr val="AAB9CB"/>
-                </a:solidFill>
-                <a:latin typeface="Inter" pitchFamily="34" charset="0"/>
-                <a:ea typeface="Inter" pitchFamily="34" charset="-122"/>
-                <a:cs typeface="Inter" pitchFamily="34" charset="-120"/>
-              </a:rPr>
-              <a:t>Desain UI/UX &amp; konten</a:t>
-            </a:r>
-            <a:endParaRPr lang="en-US" sz="1150" dirty="0"/>
-          </a:p>
-        </p:txBody>
-      </p:sp>
-      <p:sp>
-        <p:nvSpPr>
-          <p:cNvPr id="16" name="Shape 14"/>
-          <p:cNvSpPr/>
-          <p:nvPr/>
-        </p:nvSpPr>
-        <p:spPr>
-          <a:xfrm>
-            <a:off x="7955280" y="5440680"/>
-            <a:ext cx="3429000" cy="0"/>
-          </a:xfrm>
-          <a:prstGeom prst="line">
-            <a:avLst/>
-          </a:prstGeom>
-          <a:noFill/>
-          <a:ln w="12700">
-            <a:solidFill>
-              <a:srgbClr val="24406B"/>
-            </a:solidFill>
-            <a:prstDash val="solid"/>
-          </a:ln>
-        </p:spPr>
-      </p:sp>
-      <p:sp>
-        <p:nvSpPr>
-          <p:cNvPr id="17" name="Text 15"/>
-          <p:cNvSpPr/>
-          <p:nvPr/>
-        </p:nvSpPr>
-        <p:spPr>
-          <a:xfrm>
-            <a:off x="7955280" y="5559552"/>
-            <a:ext cx="3474720" cy="457200"/>
-          </a:xfrm>
-          <a:prstGeom prst="rect">
-            <a:avLst/>
-          </a:prstGeom>
-          <a:noFill/>
-          <a:ln/>
-        </p:spPr>
-        <p:txBody>
-          <a:bodyPr wrap="square" lIns="0" tIns="0" rIns="0" bIns="0" rtlCol="0" anchor="ctr"/>
-          <a:lstStyle/>
-          <a:p>
-            <a:pPr indent="0" marL="0">
-              <a:lnSpc>
-                <a:spcPct val="135000"/>
-              </a:lnSpc>
-              <a:buNone/>
-            </a:pPr>
-            <a:r>
-              <a:rPr lang="en-US" sz="1050" dirty="0">
-                <a:solidFill>
-                  <a:srgbClr val="64809F"/>
-                </a:solidFill>
-                <a:latin typeface="Inter" pitchFamily="34" charset="0"/>
-                <a:ea typeface="Inter" pitchFamily="34" charset="-122"/>
-                <a:cs typeface="Inter" pitchFamily="34" charset="-120"/>
-              </a:rPr>
-              <a:t>1 orang, peran menyeluruh: konsep, pembangunan, pengujian, dan perancangan skala.</a:t>
-            </a:r>
-            <a:endParaRPr lang="en-US" sz="1050" dirty="0"/>
-          </a:p>
-        </p:txBody>
-      </p:sp>
-      <p:sp>
-        <p:nvSpPr>
-          <p:cNvPr id="18" name="Text 16"/>
-          <p:cNvSpPr/>
-          <p:nvPr/>
-        </p:nvSpPr>
-        <p:spPr>
-          <a:xfrm>
-            <a:off x="457200" y="6510528"/>
-            <a:ext cx="4572000" cy="237744"/>
-          </a:xfrm>
-          <a:prstGeom prst="rect">
-            <a:avLst/>
-          </a:prstGeom>
-          <a:noFill/>
-          <a:ln/>
-        </p:spPr>
-        <p:txBody>
-          <a:bodyPr wrap="square" lIns="0" tIns="0" rIns="0" bIns="0" rtlCol="0" anchor="ctr"/>
-          <a:lstStyle/>
-          <a:p>
-            <a:pPr indent="0" marL="0">
-              <a:buNone/>
-            </a:pPr>
-            <a:r>
-              <a:rPr lang="en-US" sz="900" dirty="0">
-                <a:solidFill>
-                  <a:srgbClr val="8291A6"/>
-                </a:solidFill>
-                <a:latin typeface="Inter" pitchFamily="34" charset="0"/>
-                <a:ea typeface="Inter" pitchFamily="34" charset="-122"/>
-                <a:cs typeface="Inter" pitchFamily="34" charset="-120"/>
-              </a:rPr>
               <a:t>SiKePo · Healthkathon BPJS Kesehatan 2026</a:t>
             </a:r>
             <a:endParaRPr lang="en-US" sz="900" dirty="0"/>
@@ -11730,7 +11379,7 @@
       </p:sp>
       <p:sp>
         <p:nvSpPr>
-          <p:cNvPr id="19" name="Text 17"/>
+          <p:cNvPr id="10" name="Text 7"/>
           <p:cNvSpPr/>
           <p:nvPr/>
         </p:nvSpPr>
@@ -11971,9 +11620,9 @@
           <a:bodyPr wrap="square" lIns="0" tIns="0" rIns="0" bIns="0" rtlCol="0" anchor="ctr"/>
           <a:lstStyle/>
           <a:p>
-            <a:pPr indent="0" marL="0">
+            <a:pPr algn="just" indent="0" marL="0">
               <a:lnSpc>
-                <a:spcPct val="135000"/>
+                <a:spcPct val="150000"/>
               </a:lnSpc>
               <a:buNone/>
             </a:pPr>
@@ -12125,9 +11774,9 @@
           <a:bodyPr wrap="square" lIns="0" tIns="0" rIns="0" bIns="0" rtlCol="0" anchor="ctr"/>
           <a:lstStyle/>
           <a:p>
-            <a:pPr indent="0" marL="0">
+            <a:pPr algn="just" indent="0" marL="0">
               <a:lnSpc>
-                <a:spcPct val="135000"/>
+                <a:spcPct val="150000"/>
               </a:lnSpc>
               <a:buNone/>
             </a:pPr>
@@ -12279,9 +11928,9 @@
           <a:bodyPr wrap="square" lIns="0" tIns="0" rIns="0" bIns="0" rtlCol="0" anchor="ctr"/>
           <a:lstStyle/>
           <a:p>
-            <a:pPr indent="0" marL="0">
+            <a:pPr algn="just" indent="0" marL="0">
               <a:lnSpc>
-                <a:spcPct val="135000"/>
+                <a:spcPct val="150000"/>
               </a:lnSpc>
               <a:buNone/>
             </a:pPr>
@@ -12399,9 +12048,9 @@
           <a:bodyPr wrap="square" lIns="0" tIns="0" rIns="0" bIns="0" rtlCol="0" anchor="ctr"/>
           <a:lstStyle/>
           <a:p>
-            <a:pPr marL="152400" indent="-152400">
+            <a:pPr algn="just" marL="152400" indent="-152400">
               <a:spcAft>
-                <a:spcPts val="900"/>
+                <a:spcPts val="1100"/>
               </a:spcAft>
               <a:buSzPct val="100000"/>
               <a:buChar char="▸"/>
@@ -12420,9 +12069,9 @@
             <a:endParaRPr lang="en-US" sz="1300" dirty="0"/>
           </a:p>
           <a:p>
-            <a:pPr marL="152400" indent="-152400">
+            <a:pPr algn="just" marL="152400" indent="-152400">
               <a:spcAft>
-                <a:spcPts val="900"/>
+                <a:spcPts val="1100"/>
               </a:spcAft>
               <a:buSzPct val="100000"/>
               <a:buChar char="▸"/>
@@ -12441,9 +12090,9 @@
             <a:endParaRPr lang="en-US" sz="1300" dirty="0"/>
           </a:p>
           <a:p>
-            <a:pPr marL="152400" indent="-152400">
+            <a:pPr algn="just" marL="152400" indent="-152400">
               <a:spcAft>
-                <a:spcPts val="900"/>
+                <a:spcPts val="1100"/>
               </a:spcAft>
               <a:buSzPct val="100000"/>
               <a:buChar char="▸"/>
@@ -12545,9 +12194,9 @@
           <a:bodyPr wrap="square" lIns="0" tIns="0" rIns="0" bIns="0" rtlCol="0" anchor="ctr"/>
           <a:lstStyle/>
           <a:p>
-            <a:pPr indent="0" marL="0">
+            <a:pPr algn="just" indent="0" marL="0">
               <a:lnSpc>
-                <a:spcPct val="140000"/>
+                <a:spcPct val="150000"/>
               </a:lnSpc>
               <a:spcAft>
                 <a:spcPts val="800"/>
@@ -12569,9 +12218,9 @@
             <a:endParaRPr lang="en-US" sz="1200" dirty="0"/>
           </a:p>
           <a:p>
-            <a:pPr indent="0" marL="0">
+            <a:pPr algn="just" indent="0" marL="0">
               <a:lnSpc>
-                <a:spcPct val="140000"/>
+                <a:spcPct val="150000"/>
               </a:lnSpc>
               <a:spcAft>
                 <a:spcPts val="800"/>
@@ -12914,9 +12563,9 @@
           <a:bodyPr wrap="square" lIns="0" tIns="0" rIns="0" bIns="0" rtlCol="0" anchor="ctr"/>
           <a:lstStyle/>
           <a:p>
-            <a:pPr indent="0" marL="0">
+            <a:pPr algn="just" indent="0" marL="0">
               <a:lnSpc>
-                <a:spcPct val="140000"/>
+                <a:spcPct val="150000"/>
               </a:lnSpc>
               <a:buNone/>
             </a:pPr>
@@ -12956,9 +12605,9 @@
           <a:bodyPr wrap="square" lIns="0" tIns="0" rIns="0" bIns="0" rtlCol="0" anchor="ctr"/>
           <a:lstStyle/>
           <a:p>
-            <a:pPr indent="0" marL="0">
+            <a:pPr algn="just" indent="0" marL="0">
               <a:lnSpc>
-                <a:spcPct val="130000"/>
+                <a:spcPct val="145000"/>
               </a:lnSpc>
               <a:buNone/>
             </a:pPr>
@@ -13110,9 +12759,9 @@
           <a:bodyPr wrap="square" lIns="0" tIns="0" rIns="0" bIns="0" rtlCol="0" anchor="ctr"/>
           <a:lstStyle/>
           <a:p>
-            <a:pPr indent="0" marL="0">
+            <a:pPr algn="just" indent="0" marL="0">
               <a:lnSpc>
-                <a:spcPct val="140000"/>
+                <a:spcPct val="150000"/>
               </a:lnSpc>
               <a:buNone/>
             </a:pPr>
@@ -13152,9 +12801,9 @@
           <a:bodyPr wrap="square" lIns="0" tIns="0" rIns="0" bIns="0" rtlCol="0" anchor="ctr"/>
           <a:lstStyle/>
           <a:p>
-            <a:pPr indent="0" marL="0">
+            <a:pPr algn="just" indent="0" marL="0">
               <a:lnSpc>
-                <a:spcPct val="130000"/>
+                <a:spcPct val="145000"/>
               </a:lnSpc>
               <a:buNone/>
             </a:pPr>
@@ -13306,9 +12955,9 @@
           <a:bodyPr wrap="square" lIns="0" tIns="0" rIns="0" bIns="0" rtlCol="0" anchor="ctr"/>
           <a:lstStyle/>
           <a:p>
-            <a:pPr indent="0" marL="0">
+            <a:pPr algn="just" indent="0" marL="0">
               <a:lnSpc>
-                <a:spcPct val="140000"/>
+                <a:spcPct val="150000"/>
               </a:lnSpc>
               <a:buNone/>
             </a:pPr>
@@ -13348,9 +12997,9 @@
           <a:bodyPr wrap="square" lIns="0" tIns="0" rIns="0" bIns="0" rtlCol="0" anchor="ctr"/>
           <a:lstStyle/>
           <a:p>
-            <a:pPr indent="0" marL="0">
+            <a:pPr algn="just" indent="0" marL="0">
               <a:lnSpc>
-                <a:spcPct val="130000"/>
+                <a:spcPct val="145000"/>
               </a:lnSpc>
               <a:buNone/>
             </a:pPr>
@@ -13502,9 +13151,9 @@
           <a:bodyPr wrap="square" lIns="0" tIns="0" rIns="0" bIns="0" rtlCol="0" anchor="ctr"/>
           <a:lstStyle/>
           <a:p>
-            <a:pPr indent="0" marL="0">
+            <a:pPr algn="just" indent="0" marL="0">
               <a:lnSpc>
-                <a:spcPct val="140000"/>
+                <a:spcPct val="150000"/>
               </a:lnSpc>
               <a:buNone/>
             </a:pPr>
@@ -13544,9 +13193,9 @@
           <a:bodyPr wrap="square" lIns="0" tIns="0" rIns="0" bIns="0" rtlCol="0" anchor="ctr"/>
           <a:lstStyle/>
           <a:p>
-            <a:pPr indent="0" marL="0">
+            <a:pPr algn="just" indent="0" marL="0">
               <a:lnSpc>
-                <a:spcPct val="130000"/>
+                <a:spcPct val="145000"/>
               </a:lnSpc>
               <a:buNone/>
             </a:pPr>
@@ -13698,9 +13347,9 @@
           <a:bodyPr wrap="square" lIns="0" tIns="0" rIns="0" bIns="0" rtlCol="0" anchor="ctr"/>
           <a:lstStyle/>
           <a:p>
-            <a:pPr indent="0" marL="0">
+            <a:pPr algn="just" indent="0" marL="0">
               <a:lnSpc>
-                <a:spcPct val="140000"/>
+                <a:spcPct val="150000"/>
               </a:lnSpc>
               <a:buNone/>
             </a:pPr>
@@ -13740,9 +13389,9 @@
           <a:bodyPr wrap="square" lIns="0" tIns="0" rIns="0" bIns="0" rtlCol="0" anchor="ctr"/>
           <a:lstStyle/>
           <a:p>
-            <a:pPr indent="0" marL="0">
+            <a:pPr algn="just" indent="0" marL="0">
               <a:lnSpc>
-                <a:spcPct val="130000"/>
+                <a:spcPct val="145000"/>
               </a:lnSpc>
               <a:buNone/>
             </a:pPr>
@@ -14076,9 +13725,9 @@
           <a:bodyPr wrap="square" lIns="0" tIns="0" rIns="0" bIns="0" rtlCol="0" anchor="ctr"/>
           <a:lstStyle/>
           <a:p>
-            <a:pPr indent="0" marL="0">
+            <a:pPr algn="just" indent="0" marL="0">
               <a:lnSpc>
-                <a:spcPct val="138000"/>
+                <a:spcPct val="150000"/>
               </a:lnSpc>
               <a:buNone/>
             </a:pPr>
@@ -14157,9 +13806,9 @@
           <a:bodyPr wrap="square" lIns="0" tIns="0" rIns="0" bIns="0" rtlCol="0" anchor="ctr"/>
           <a:lstStyle/>
           <a:p>
-            <a:pPr indent="0" marL="0">
+            <a:pPr algn="just" indent="0" marL="0">
               <a:lnSpc>
-                <a:spcPct val="138000"/>
+                <a:spcPct val="150000"/>
               </a:lnSpc>
               <a:buNone/>
             </a:pPr>
@@ -14238,9 +13887,9 @@
           <a:bodyPr wrap="square" lIns="0" tIns="0" rIns="0" bIns="0" rtlCol="0" anchor="ctr"/>
           <a:lstStyle/>
           <a:p>
-            <a:pPr indent="0" marL="0">
+            <a:pPr algn="just" indent="0" marL="0">
               <a:lnSpc>
-                <a:spcPct val="138000"/>
+                <a:spcPct val="150000"/>
               </a:lnSpc>
               <a:buNone/>
             </a:pPr>
@@ -14552,9 +14201,9 @@
           <a:bodyPr wrap="square" lIns="0" tIns="0" rIns="0" bIns="0" rtlCol="0" anchor="ctr"/>
           <a:lstStyle/>
           <a:p>
-            <a:pPr marL="152400" indent="-152400">
+            <a:pPr algn="just" marL="152400" indent="-152400">
               <a:lnSpc>
-                <a:spcPct val="138000"/>
+                <a:spcPct val="150000"/>
               </a:lnSpc>
               <a:spcAft>
                 <a:spcPts val="1000"/>
@@ -14576,9 +14225,9 @@
             <a:endParaRPr lang="en-US" sz="1150" dirty="0"/>
           </a:p>
           <a:p>
-            <a:pPr marL="152400" indent="-152400">
+            <a:pPr algn="just" marL="152400" indent="-152400">
               <a:lnSpc>
-                <a:spcPct val="138000"/>
+                <a:spcPct val="150000"/>
               </a:lnSpc>
               <a:spcAft>
                 <a:spcPts val="1000"/>
@@ -14600,9 +14249,9 @@
             <a:endParaRPr lang="en-US" sz="1150" dirty="0"/>
           </a:p>
           <a:p>
-            <a:pPr marL="152400" indent="-152400">
+            <a:pPr algn="just" marL="152400" indent="-152400">
               <a:lnSpc>
-                <a:spcPct val="138000"/>
+                <a:spcPct val="150000"/>
               </a:lnSpc>
               <a:spcAft>
                 <a:spcPts val="1000"/>
@@ -14624,9 +14273,9 @@
             <a:endParaRPr lang="en-US" sz="1150" dirty="0"/>
           </a:p>
           <a:p>
-            <a:pPr marL="152400" indent="-152400">
+            <a:pPr algn="just" marL="152400" indent="-152400">
               <a:lnSpc>
-                <a:spcPct val="138000"/>
+                <a:spcPct val="150000"/>
               </a:lnSpc>
               <a:spcAft>
                 <a:spcPts val="1000"/>
@@ -14648,9 +14297,9 @@
             <a:endParaRPr lang="en-US" sz="1150" dirty="0"/>
           </a:p>
           <a:p>
-            <a:pPr marL="152400" indent="-152400">
+            <a:pPr algn="just" marL="152400" indent="-152400">
               <a:lnSpc>
-                <a:spcPct val="138000"/>
+                <a:spcPct val="150000"/>
               </a:lnSpc>
               <a:spcAft>
                 <a:spcPts val="1000"/>
@@ -14944,9 +14593,9 @@
           <a:bodyPr wrap="square" lIns="0" tIns="0" rIns="0" bIns="0" rtlCol="0" anchor="ctr"/>
           <a:lstStyle/>
           <a:p>
-            <a:pPr indent="0" marL="0">
+            <a:pPr algn="just" indent="0" marL="0">
               <a:lnSpc>
-                <a:spcPct val="138000"/>
+                <a:spcPct val="150000"/>
               </a:lnSpc>
               <a:buNone/>
             </a:pPr>
@@ -15048,9 +14697,9 @@
           <a:bodyPr wrap="square" lIns="0" tIns="0" rIns="0" bIns="0" rtlCol="0" anchor="ctr"/>
           <a:lstStyle/>
           <a:p>
-            <a:pPr indent="0" marL="0">
+            <a:pPr algn="just" indent="0" marL="0">
               <a:lnSpc>
-                <a:spcPct val="138000"/>
+                <a:spcPct val="150000"/>
               </a:lnSpc>
               <a:buNone/>
             </a:pPr>
@@ -15152,9 +14801,9 @@
           <a:bodyPr wrap="square" lIns="0" tIns="0" rIns="0" bIns="0" rtlCol="0" anchor="ctr"/>
           <a:lstStyle/>
           <a:p>
-            <a:pPr indent="0" marL="0">
+            <a:pPr algn="just" indent="0" marL="0">
               <a:lnSpc>
-                <a:spcPct val="138000"/>
+                <a:spcPct val="150000"/>
               </a:lnSpc>
               <a:buNone/>
             </a:pPr>
@@ -15540,9 +15189,9 @@
           <a:bodyPr wrap="square" lIns="0" tIns="0" rIns="0" bIns="0" rtlCol="0" anchor="ctr"/>
           <a:lstStyle/>
           <a:p>
-            <a:pPr indent="0" marL="0">
+            <a:pPr algn="just" indent="0" marL="0">
               <a:lnSpc>
-                <a:spcPct val="135000"/>
+                <a:spcPct val="150000"/>
               </a:lnSpc>
               <a:buNone/>
             </a:pPr>
@@ -15582,9 +15231,9 @@
           <a:bodyPr wrap="square" lIns="0" tIns="0" rIns="0" bIns="0" rtlCol="0" anchor="ctr"/>
           <a:lstStyle/>
           <a:p>
-            <a:pPr indent="0" marL="0">
+            <a:pPr algn="just" indent="0" marL="0">
               <a:lnSpc>
-                <a:spcPct val="140000"/>
+                <a:spcPct val="150000"/>
               </a:lnSpc>
               <a:buNone/>
             </a:pPr>
@@ -15624,9 +15273,9 @@
           <a:bodyPr wrap="square" lIns="0" tIns="0" rIns="0" bIns="0" rtlCol="0" anchor="ctr"/>
           <a:lstStyle/>
           <a:p>
-            <a:pPr indent="0" marL="0">
+            <a:pPr algn="just" indent="0" marL="0">
               <a:lnSpc>
-                <a:spcPct val="135000"/>
+                <a:spcPct val="150000"/>
               </a:lnSpc>
               <a:buNone/>
             </a:pPr>
@@ -15791,9 +15440,9 @@
           <a:bodyPr wrap="square" lIns="0" tIns="0" rIns="0" bIns="0" rtlCol="0" anchor="ctr"/>
           <a:lstStyle/>
           <a:p>
-            <a:pPr indent="0" marL="0">
+            <a:pPr algn="just" indent="0" marL="0">
               <a:lnSpc>
-                <a:spcPct val="135000"/>
+                <a:spcPct val="150000"/>
               </a:lnSpc>
               <a:buNone/>
             </a:pPr>
@@ -15833,9 +15482,9 @@
           <a:bodyPr wrap="square" lIns="0" tIns="0" rIns="0" bIns="0" rtlCol="0" anchor="ctr"/>
           <a:lstStyle/>
           <a:p>
-            <a:pPr indent="0" marL="0">
+            <a:pPr algn="just" indent="0" marL="0">
               <a:lnSpc>
-                <a:spcPct val="140000"/>
+                <a:spcPct val="150000"/>
               </a:lnSpc>
               <a:buNone/>
             </a:pPr>
@@ -15875,9 +15524,9 @@
           <a:bodyPr wrap="square" lIns="0" tIns="0" rIns="0" bIns="0" rtlCol="0" anchor="ctr"/>
           <a:lstStyle/>
           <a:p>
-            <a:pPr indent="0" marL="0">
+            <a:pPr algn="just" indent="0" marL="0">
               <a:lnSpc>
-                <a:spcPct val="135000"/>
+                <a:spcPct val="150000"/>
               </a:lnSpc>
               <a:buNone/>
             </a:pPr>
@@ -16042,9 +15691,9 @@
           <a:bodyPr wrap="square" lIns="0" tIns="0" rIns="0" bIns="0" rtlCol="0" anchor="ctr"/>
           <a:lstStyle/>
           <a:p>
-            <a:pPr indent="0" marL="0">
+            <a:pPr algn="just" indent="0" marL="0">
               <a:lnSpc>
-                <a:spcPct val="135000"/>
+                <a:spcPct val="150000"/>
               </a:lnSpc>
               <a:buNone/>
             </a:pPr>
@@ -16084,9 +15733,9 @@
           <a:bodyPr wrap="square" lIns="0" tIns="0" rIns="0" bIns="0" rtlCol="0" anchor="ctr"/>
           <a:lstStyle/>
           <a:p>
-            <a:pPr indent="0" marL="0">
+            <a:pPr algn="just" indent="0" marL="0">
               <a:lnSpc>
-                <a:spcPct val="140000"/>
+                <a:spcPct val="150000"/>
               </a:lnSpc>
               <a:buNone/>
             </a:pPr>
@@ -16126,9 +15775,9 @@
           <a:bodyPr wrap="square" lIns="0" tIns="0" rIns="0" bIns="0" rtlCol="0" anchor="ctr"/>
           <a:lstStyle/>
           <a:p>
-            <a:pPr indent="0" marL="0">
+            <a:pPr algn="just" indent="0" marL="0">
               <a:lnSpc>
-                <a:spcPct val="135000"/>
+                <a:spcPct val="150000"/>
               </a:lnSpc>
               <a:buNone/>
             </a:pPr>
@@ -17019,9 +16668,9 @@
           <a:bodyPr wrap="square" lIns="0" tIns="0" rIns="0" bIns="0" rtlCol="0" anchor="ctr"/>
           <a:lstStyle/>
           <a:p>
-            <a:pPr marL="152400" indent="-152400">
+            <a:pPr algn="just" marL="152400" indent="-152400">
               <a:lnSpc>
-                <a:spcPct val="135000"/>
+                <a:spcPct val="150000"/>
               </a:lnSpc>
               <a:spcAft>
                 <a:spcPts val="700"/>
@@ -17043,9 +16692,9 @@
             <a:endParaRPr lang="en-US" sz="1100" dirty="0"/>
           </a:p>
           <a:p>
-            <a:pPr marL="152400" indent="-152400">
+            <a:pPr algn="just" marL="152400" indent="-152400">
               <a:lnSpc>
-                <a:spcPct val="135000"/>
+                <a:spcPct val="150000"/>
               </a:lnSpc>
               <a:spcAft>
                 <a:spcPts val="700"/>
@@ -17067,9 +16716,9 @@
             <a:endParaRPr lang="en-US" sz="1100" dirty="0"/>
           </a:p>
           <a:p>
-            <a:pPr marL="152400" indent="-152400">
+            <a:pPr algn="just" marL="152400" indent="-152400">
               <a:lnSpc>
-                <a:spcPct val="135000"/>
+                <a:spcPct val="150000"/>
               </a:lnSpc>
               <a:spcAft>
                 <a:spcPts val="700"/>
@@ -17091,9 +16740,9 @@
             <a:endParaRPr lang="en-US" sz="1100" dirty="0"/>
           </a:p>
           <a:p>
-            <a:pPr marL="152400" indent="-152400">
+            <a:pPr algn="just" marL="152400" indent="-152400">
               <a:lnSpc>
-                <a:spcPct val="135000"/>
+                <a:spcPct val="150000"/>
               </a:lnSpc>
               <a:spcAft>
                 <a:spcPts val="700"/>
@@ -17115,9 +16764,9 @@
             <a:endParaRPr lang="en-US" sz="1100" dirty="0"/>
           </a:p>
           <a:p>
-            <a:pPr marL="152400" indent="-152400">
+            <a:pPr algn="just" marL="152400" indent="-152400">
               <a:lnSpc>
-                <a:spcPct val="135000"/>
+                <a:spcPct val="150000"/>
               </a:lnSpc>
               <a:spcAft>
                 <a:spcPts val="700"/>
@@ -17227,9 +16876,9 @@
           <a:bodyPr wrap="square" lIns="0" tIns="0" rIns="0" bIns="0" rtlCol="0" anchor="ctr"/>
           <a:lstStyle/>
           <a:p>
-            <a:pPr marL="152400" indent="-152400">
+            <a:pPr algn="just" marL="152400" indent="-152400">
               <a:lnSpc>
-                <a:spcPct val="135000"/>
+                <a:spcPct val="150000"/>
               </a:lnSpc>
               <a:spcAft>
                 <a:spcPts val="700"/>
@@ -17251,9 +16900,9 @@
             <a:endParaRPr lang="en-US" sz="1100" dirty="0"/>
           </a:p>
           <a:p>
-            <a:pPr marL="152400" indent="-152400">
+            <a:pPr algn="just" marL="152400" indent="-152400">
               <a:lnSpc>
-                <a:spcPct val="135000"/>
+                <a:spcPct val="150000"/>
               </a:lnSpc>
               <a:spcAft>
                 <a:spcPts val="700"/>
@@ -17275,9 +16924,9 @@
             <a:endParaRPr lang="en-US" sz="1100" dirty="0"/>
           </a:p>
           <a:p>
-            <a:pPr marL="152400" indent="-152400">
+            <a:pPr algn="just" marL="152400" indent="-152400">
               <a:lnSpc>
-                <a:spcPct val="135000"/>
+                <a:spcPct val="150000"/>
               </a:lnSpc>
               <a:spcAft>
                 <a:spcPts val="700"/>
@@ -17299,9 +16948,9 @@
             <a:endParaRPr lang="en-US" sz="1100" dirty="0"/>
           </a:p>
           <a:p>
-            <a:pPr marL="152400" indent="-152400">
+            <a:pPr algn="just" marL="152400" indent="-152400">
               <a:lnSpc>
-                <a:spcPct val="135000"/>
+                <a:spcPct val="150000"/>
               </a:lnSpc>
               <a:spcAft>
                 <a:spcPts val="700"/>
@@ -17323,9 +16972,9 @@
             <a:endParaRPr lang="en-US" sz="1100" dirty="0"/>
           </a:p>
           <a:p>
-            <a:pPr marL="152400" indent="-152400">
+            <a:pPr algn="just" marL="152400" indent="-152400">
               <a:lnSpc>
-                <a:spcPct val="135000"/>
+                <a:spcPct val="150000"/>
               </a:lnSpc>
               <a:spcAft>
                 <a:spcPts val="700"/>
@@ -17435,9 +17084,9 @@
           <a:bodyPr wrap="square" lIns="0" tIns="0" rIns="0" bIns="0" rtlCol="0" anchor="ctr"/>
           <a:lstStyle/>
           <a:p>
-            <a:pPr marL="152400" indent="-152400">
+            <a:pPr algn="just" marL="152400" indent="-152400">
               <a:lnSpc>
-                <a:spcPct val="135000"/>
+                <a:spcPct val="150000"/>
               </a:lnSpc>
               <a:spcAft>
                 <a:spcPts val="700"/>
@@ -17459,9 +17108,9 @@
             <a:endParaRPr lang="en-US" sz="1100" dirty="0"/>
           </a:p>
           <a:p>
-            <a:pPr marL="152400" indent="-152400">
+            <a:pPr algn="just" marL="152400" indent="-152400">
               <a:lnSpc>
-                <a:spcPct val="135000"/>
+                <a:spcPct val="150000"/>
               </a:lnSpc>
               <a:spcAft>
                 <a:spcPts val="700"/>
@@ -17483,9 +17132,9 @@
             <a:endParaRPr lang="en-US" sz="1100" dirty="0"/>
           </a:p>
           <a:p>
-            <a:pPr marL="152400" indent="-152400">
+            <a:pPr algn="just" marL="152400" indent="-152400">
               <a:lnSpc>
-                <a:spcPct val="135000"/>
+                <a:spcPct val="150000"/>
               </a:lnSpc>
               <a:spcAft>
                 <a:spcPts val="700"/>
@@ -17507,9 +17156,9 @@
             <a:endParaRPr lang="en-US" sz="1100" dirty="0"/>
           </a:p>
           <a:p>
-            <a:pPr marL="152400" indent="-152400">
+            <a:pPr algn="just" marL="152400" indent="-152400">
               <a:lnSpc>
-                <a:spcPct val="135000"/>
+                <a:spcPct val="150000"/>
               </a:lnSpc>
               <a:spcAft>
                 <a:spcPts val="700"/>
@@ -17531,9 +17180,9 @@
             <a:endParaRPr lang="en-US" sz="1100" dirty="0"/>
           </a:p>
           <a:p>
-            <a:pPr marL="152400" indent="-152400">
+            <a:pPr algn="just" marL="152400" indent="-152400">
               <a:lnSpc>
-                <a:spcPct val="135000"/>
+                <a:spcPct val="150000"/>
               </a:lnSpc>
               <a:spcAft>
                 <a:spcPts val="700"/>

</xml_diff>

<commit_message>
style: strip antrean klaim dikrop ke area tabel
</commit_message>
<xml_diff>
--- a/proposal/Proposal_SiKePo_Healthkathon2026.pptx
+++ b/proposal/Proposal_SiKePo_Healthkathon2026.pptx
@@ -11317,7 +11317,7 @@
       </p:sp>
       <p:pic>
         <p:nvPicPr>
-          <p:cNvPr id="8" name="Image 0" descr="D:/FamilyAgent/Nox/workspace/sikepo-app/proposal/assets/shot-claims.png">    </p:cNvPr>
+          <p:cNvPr id="8" name="Image 0" descr="D:/FamilyAgent/Nox/workspace/sikepo-app/proposal/assets/shot-claims-strip.png">    </p:cNvPr>
           <p:cNvPicPr>
             <a:picLocks noChangeAspect="1"/>
           </p:cNvPicPr>
@@ -11325,12 +11325,12 @@
         </p:nvPicPr>
         <p:blipFill>
           <a:blip r:embed="rId1"/>
-          <a:srcRect l="0" r="0" t="0" b="0"/>
+          <a:srcRect l="0" r="0" t="3125" b="3125"/>
           <a:stretch/>
         </p:blipFill>
         <p:spPr>
           <a:xfrm>
-            <a:off x="457200" y="5138928"/>
+            <a:off x="457200" y="5074920"/>
             <a:ext cx="11274552" cy="1371600"/>
           </a:xfrm>
           <a:prstGeom prst="rect">

</xml_diff>

<commit_message>
style: atur ulang posisi bullet dan strip slide 3
</commit_message>
<xml_diff>
--- a/proposal/Proposal_SiKePo_Healthkathon2026.pptx
+++ b/proposal/Proposal_SiKePo_Healthkathon2026.pptx
@@ -11325,12 +11325,12 @@
         </p:nvPicPr>
         <p:blipFill>
           <a:blip r:embed="rId1"/>
-          <a:srcRect l="0" r="0" t="3125" b="3125"/>
+          <a:srcRect l="4000" r="4000" t="0" b="0"/>
           <a:stretch/>
         </p:blipFill>
         <p:spPr>
           <a:xfrm>
-            <a:off x="457200" y="5074920"/>
+            <a:off x="457200" y="5230368"/>
             <a:ext cx="11274552" cy="1371600"/>
           </a:xfrm>
           <a:prstGeom prst="rect">

</xml_diff>